<commit_message>
Add two China strategy slides to Heliospace investor overview
Co-authored-by: anthonyleedu <anthonyleedu@users.noreply.github.com>
</commit_message>
<xml_diff>
--- a/Heliospace_Investor_Overview.pptx
+++ b/Heliospace_Investor_Overview.pptx
@@ -19,6 +19,8 @@
     <p:sldId id="267" r:id="rId13"/>
     <p:sldId id="268" r:id="rId14"/>
     <p:sldId id="269" r:id="rId15"/>
+    <p:sldId id="272" r:id="rId23"/>
+    <p:sldId id="273" r:id="rId24"/>
     <p:sldId id="270" r:id="rId16"/>
     <p:sldId id="271" r:id="rId17"/>
   </p:sldIdLst>
@@ -7808,6 +7810,1244 @@
 </file>
 
 <file path=ppt/slides/slide15.xml><?xml version="1.0" encoding="utf-8"?>
+<p:sld xmlns:a="http://schemas.openxmlformats.org/drawingml/2006/main" xmlns:p="http://schemas.openxmlformats.org/presentationml/2006/main" xmlns:r="http://schemas.openxmlformats.org/officeDocument/2006/relationships">
+  <p:cSld>
+    <p:spTree>
+      <p:nvGrpSpPr>
+        <p:cNvPr id="1" name=""/>
+        <p:cNvGrpSpPr/>
+        <p:nvPr/>
+      </p:nvGrpSpPr>
+      <p:grpSpPr/>
+      <p:sp>
+        <p:nvSpPr>
+          <p:cNvPr id="2" name="Text 0"/>
+          <p:cNvSpPr/>
+          <p:nvPr/>
+        </p:nvSpPr>
+        <p:spPr>
+          <a:xfrm>
+            <a:off x="822960" y="457200"/>
+            <a:ext cx="7772400" cy="274320"/>
+          </a:xfrm>
+          <a:prstGeom prst="rect">
+            <a:avLst/>
+          </a:prstGeom>
+          <a:noFill/>
+          <a:ln/>
+        </p:spPr>
+        <p:txBody>
+          <a:bodyPr wrap="square" lIns="0" tIns="0" rIns="0" bIns="0" rtlCol="0" anchor="ctr"/>
+          <a:lstStyle/>
+          <a:p>
+            <a:pPr indent="0" marL="0">
+              <a:buNone/>
+            </a:pPr>
+            <a:r>
+              <a:rPr lang="en-US" sz="1100" b="1" spc="300" kern="0" dirty="0">
+                <a:solidFill>
+                  <a:srgbClr val="007BCB"/>
+                </a:solidFill>
+                <a:latin typeface="Garamond" pitchFamily="34" charset="0"/>
+                <a:ea typeface="Garamond" pitchFamily="34" charset="-122"/>
+                <a:cs typeface="Garamond" pitchFamily="34" charset="-120"/>
+              </a:rPr>
+              <a:t>CHINA STRATEGY</a:t>
+            </a:r>
+            <a:endParaRPr lang="en-US" sz="1100" dirty="0"/>
+          </a:p>
+        </p:txBody>
+      </p:sp>
+      <p:sp>
+        <p:nvSpPr>
+          <p:cNvPr id="3" name="Text 1"/>
+          <p:cNvSpPr/>
+          <p:nvPr/>
+        </p:nvSpPr>
+        <p:spPr>
+          <a:xfrm>
+            <a:off x="822960" y="713232"/>
+            <a:ext cx="8961120" cy="566928"/>
+          </a:xfrm>
+          <a:prstGeom prst="rect">
+            <a:avLst/>
+          </a:prstGeom>
+          <a:noFill/>
+          <a:ln/>
+        </p:spPr>
+        <p:txBody>
+          <a:bodyPr wrap="square" lIns="0" tIns="0" rIns="0" bIns="0" rtlCol="0" anchor="ctr"/>
+          <a:lstStyle/>
+          <a:p>
+            <a:pPr indent="0" marL="0">
+              <a:buNone/>
+            </a:pPr>
+            <a:r>
+              <a:rPr lang="en-US" sz="2900" b="1" dirty="0">
+                <a:solidFill>
+                  <a:srgbClr val="10222F"/>
+                </a:solidFill>
+                <a:latin typeface="Garamond" pitchFamily="34" charset="0"/>
+                <a:ea typeface="Garamond" pitchFamily="34" charset="-122"/>
+                <a:cs typeface="Garamond" pitchFamily="34" charset="-120"/>
+              </a:rPr>
+              <a:t>A Disciplined Two Phase Approach</a:t>
+            </a:r>
+            <a:endParaRPr lang="en-US" sz="2900" dirty="0"/>
+          </a:p>
+        </p:txBody>
+      </p:sp>
+      <p:pic>
+        <p:nvPicPr>
+          <p:cNvPr id="4" name="Image 0" descr="assets/logo_dark.jpg">    </p:cNvPr>
+          <p:cNvPicPr>
+            <a:picLocks noChangeAspect="1"/>
+          </p:cNvPicPr>
+          <p:nvPr/>
+        </p:nvPicPr>
+        <p:blipFill>
+          <a:blip r:embed="rId2"/>
+          <a:stretch>
+            <a:fillRect/>
+          </a:stretch>
+        </p:blipFill>
+        <p:spPr>
+          <a:xfrm>
+            <a:off x="10058400" y="475488"/>
+            <a:ext cx="1325880" cy="372161"/>
+          </a:xfrm>
+          <a:prstGeom prst="rect">
+            <a:avLst/>
+          </a:prstGeom>
+        </p:spPr>
+      </p:pic>
+      <p:sp>
+        <p:nvSpPr>
+          <p:cNvPr id="5" name="Text 2"/>
+          <p:cNvSpPr/>
+          <p:nvPr/>
+        </p:nvSpPr>
+        <p:spPr>
+          <a:xfrm>
+            <a:off x="822960" y="6492240"/>
+            <a:ext cx="5943600" cy="237744"/>
+          </a:xfrm>
+          <a:prstGeom prst="rect">
+            <a:avLst/>
+          </a:prstGeom>
+          <a:noFill/>
+          <a:ln/>
+        </p:spPr>
+        <p:txBody>
+          <a:bodyPr wrap="square" lIns="0" tIns="0" rIns="0" bIns="0" rtlCol="0" anchor="ctr"/>
+          <a:lstStyle/>
+          <a:p>
+            <a:pPr indent="0" marL="0">
+              <a:buNone/>
+            </a:pPr>
+            <a:r>
+              <a:rPr lang="en-US" sz="850" dirty="0">
+                <a:solidFill>
+                  <a:srgbClr val="5C6B76"/>
+                </a:solidFill>
+                <a:latin typeface="Garamond" pitchFamily="34" charset="0"/>
+                <a:ea typeface="Garamond" pitchFamily="34" charset="-122"/>
+                <a:cs typeface="Garamond" pitchFamily="34" charset="-120"/>
+              </a:rPr>
+              <a:t>Heliospace Corporation   |   Proprietary and Confidential</a:t>
+            </a:r>
+            <a:endParaRPr lang="en-US" sz="850" dirty="0"/>
+          </a:p>
+        </p:txBody>
+      </p:sp>
+      <p:sp>
+        <p:nvSpPr>
+          <p:cNvPr id="6" name="Text 3"/>
+          <p:cNvSpPr/>
+          <p:nvPr/>
+        </p:nvSpPr>
+        <p:spPr>
+          <a:xfrm>
+            <a:off x="11064240" y="6492240"/>
+            <a:ext cx="320040" cy="237744"/>
+          </a:xfrm>
+          <a:prstGeom prst="rect">
+            <a:avLst/>
+          </a:prstGeom>
+          <a:noFill/>
+          <a:ln/>
+        </p:spPr>
+        <p:txBody>
+          <a:bodyPr wrap="square" lIns="0" tIns="0" rIns="0" bIns="0" rtlCol="0" anchor="ctr"/>
+          <a:lstStyle/>
+          <a:p>
+            <a:pPr algn="r" indent="0" marL="0">
+              <a:buNone/>
+            </a:pPr>
+            <a:r>
+              <a:rPr lang="en-US" sz="850" dirty="0">
+                <a:solidFill>
+                  <a:srgbClr val="5C6B76"/>
+                </a:solidFill>
+                <a:latin typeface="Garamond" pitchFamily="34" charset="0"/>
+                <a:ea typeface="Garamond" pitchFamily="34" charset="-122"/>
+                <a:cs typeface="Garamond" pitchFamily="34" charset="-120"/>
+              </a:rPr>
+              <a:t>15</a:t>
+            </a:r>
+            <a:endParaRPr lang="en-US" sz="850" dirty="0"/>
+          </a:p>
+        </p:txBody>
+      </p:sp>
+      <p:sp>
+        <p:nvSpPr>
+          <p:cNvPr id="7" name="Text 4"/>
+          <p:cNvSpPr/>
+          <p:nvPr/>
+        </p:nvSpPr>
+        <p:spPr>
+          <a:xfrm>
+            <a:off x="822960" y="1353312"/>
+            <a:ext cx="10424160" cy="320040"/>
+          </a:xfrm>
+          <a:prstGeom prst="rect">
+            <a:avLst/>
+          </a:prstGeom>
+          <a:noFill/>
+          <a:ln/>
+        </p:spPr>
+        <p:txBody>
+          <a:bodyPr wrap="square" lIns="0" tIns="0" rIns="0" bIns="0" rtlCol="0" anchor="ctr"/>
+          <a:lstStyle/>
+          <a:p>
+            <a:pPr indent="0" marL="0">
+              <a:buNone/>
+            </a:pPr>
+            <a:r>
+              <a:rPr lang="en-US" sz="1300" dirty="0">
+                <a:solidFill>
+                  <a:srgbClr val="5C6B76"/>
+                </a:solidFill>
+                <a:latin typeface="Garamond" pitchFamily="34" charset="0"/>
+                <a:ea typeface="Garamond" pitchFamily="34" charset="-122"/>
+                <a:cs typeface="Garamond" pitchFamily="34" charset="-120"/>
+              </a:rPr>
+              <a:t>Market entry is sequenced in two phases, with production investment committed only after the quality of orders has been confirmed.</a:t>
+            </a:r>
+            <a:endParaRPr lang="en-US" sz="1300" dirty="0"/>
+          </a:p>
+        </p:txBody>
+      </p:sp>
+      <p:sp>
+        <p:nvSpPr>
+          <p:cNvPr id="8" name="Shape 4"/>
+          <p:cNvSpPr/>
+          <p:nvPr/>
+        </p:nvSpPr>
+        <p:spPr>
+          <a:xfrm>
+            <a:off x="822960" y="1874519"/>
+            <a:ext cx="5175504" cy="3429000"/>
+          </a:xfrm>
+          <a:prstGeom prst="roundRect">
+            <a:avLst>
+              <a:gd name="adj" fmla="val 1724"/>
+            </a:avLst>
+          </a:prstGeom>
+          <a:solidFill>
+            <a:srgbClr val="F3F7FA"/>
+          </a:solidFill>
+          <a:ln/>
+        </p:spPr>
+      </p:sp>
+      <p:sp>
+        <p:nvSpPr>
+          <p:cNvPr id="9" name="Shape 5"/>
+          <p:cNvSpPr/>
+          <p:nvPr/>
+        </p:nvSpPr>
+        <p:spPr>
+          <a:xfrm>
+            <a:off x="1005840" y="2075687"/>
+            <a:ext cx="384048" cy="384048"/>
+          </a:xfrm>
+          <a:prstGeom prst="ellipse">
+            <a:avLst/>
+          </a:prstGeom>
+          <a:solidFill>
+            <a:srgbClr val="007BCB"/>
+          </a:solidFill>
+          <a:ln/>
+        </p:spPr>
+      </p:sp>
+      <p:sp>
+        <p:nvSpPr>
+          <p:cNvPr id="10" name="Text 6"/>
+          <p:cNvSpPr/>
+          <p:nvPr/>
+        </p:nvSpPr>
+        <p:spPr>
+          <a:xfrm>
+            <a:off x="1005840" y="2075687"/>
+            <a:ext cx="384048" cy="384048"/>
+          </a:xfrm>
+          <a:prstGeom prst="rect">
+            <a:avLst/>
+          </a:prstGeom>
+          <a:noFill/>
+          <a:ln/>
+        </p:spPr>
+        <p:txBody>
+          <a:bodyPr wrap="square" lIns="0" tIns="0" rIns="0" bIns="0" rtlCol="0" anchor="ctr"/>
+          <a:lstStyle/>
+          <a:p>
+            <a:pPr algn="ctr" indent="0" marL="0">
+              <a:buNone/>
+            </a:pPr>
+            <a:r>
+              <a:rPr lang="en-US" sz="1500" b="1" dirty="0">
+                <a:solidFill>
+                  <a:srgbClr val="FFFFFF"/>
+                </a:solidFill>
+                <a:latin typeface="Garamond" pitchFamily="34" charset="0"/>
+                <a:ea typeface="Garamond" pitchFamily="34" charset="-122"/>
+                <a:cs typeface="Garamond" pitchFamily="34" charset="-120"/>
+              </a:rPr>
+              <a:t>1</a:t>
+            </a:r>
+            <a:endParaRPr lang="en-US" sz="1500" dirty="0"/>
+          </a:p>
+        </p:txBody>
+      </p:sp>
+      <p:sp>
+        <p:nvSpPr>
+          <p:cNvPr id="11" name="Text 7"/>
+          <p:cNvSpPr/>
+          <p:nvPr/>
+        </p:nvSpPr>
+        <p:spPr>
+          <a:xfrm>
+            <a:off x="1005840" y="2606039"/>
+            <a:ext cx="4809744" cy="640080"/>
+          </a:xfrm>
+          <a:prstGeom prst="rect">
+            <a:avLst/>
+          </a:prstGeom>
+          <a:noFill/>
+          <a:ln/>
+        </p:spPr>
+        <p:txBody>
+          <a:bodyPr wrap="square" lIns="0" tIns="0" rIns="0" bIns="0" rtlCol="0" anchor="ctr"/>
+          <a:lstStyle/>
+          <a:p>
+            <a:pPr indent="0" marL="0">
+              <a:buNone/>
+            </a:pPr>
+            <a:r>
+              <a:rPr lang="en-US" sz="1550" b="1" dirty="0">
+                <a:solidFill>
+                  <a:srgbClr val="10222F"/>
+                </a:solidFill>
+                <a:latin typeface="Garamond" pitchFamily="34" charset="0"/>
+                <a:ea typeface="Garamond" pitchFamily="34" charset="-122"/>
+                <a:cs typeface="Garamond" pitchFamily="34" charset="-120"/>
+              </a:rPr>
+              <a:t>Sell to Overseas Clients and Take Orders</a:t>
+            </a:r>
+            <a:endParaRPr lang="en-US" sz="1550" dirty="0"/>
+          </a:p>
+        </p:txBody>
+      </p:sp>
+      <p:sp>
+        <p:nvSpPr>
+          <p:cNvPr id="12" name="Text 8"/>
+          <p:cNvSpPr/>
+          <p:nvPr/>
+        </p:nvSpPr>
+        <p:spPr>
+          <a:xfrm>
+            <a:off x="1005840" y="3337559"/>
+            <a:ext cx="4809744" cy="2194560"/>
+          </a:xfrm>
+          <a:prstGeom prst="rect">
+            <a:avLst/>
+          </a:prstGeom>
+          <a:noFill/>
+          <a:ln/>
+        </p:spPr>
+        <p:txBody>
+          <a:bodyPr wrap="square" lIns="0" tIns="0" rIns="0" bIns="0" rtlCol="0" anchor="t"/>
+          <a:lstStyle/>
+          <a:p>
+            <a:pPr indent="0" marL="0">
+              <a:lnSpc>
+                <a:spcPct val="106000"/>
+              </a:lnSpc>
+              <a:buNone/>
+            </a:pPr>
+            <a:r>
+              <a:rPr lang="en-US" sz="1100" dirty="0">
+                <a:solidFill>
+                  <a:srgbClr val="1E2A33"/>
+                </a:solidFill>
+                <a:latin typeface="Garamond" pitchFamily="34" charset="0"/>
+                <a:ea typeface="Garamond" pitchFamily="34" charset="-122"/>
+                <a:cs typeface="Garamond" pitchFamily="34" charset="-120"/>
+              </a:rPr>
+              <a:t>Sell products to overseas clients, establish a base of export customers, and convert engagement into a firm order book. Every component in the current portfolio is available for sale to overseas clients, allowing revenue capture from existing product lines without new development.</a:t>
+            </a:r>
+            <a:endParaRPr lang="en-US" sz="1100" dirty="0"/>
+          </a:p>
+        </p:txBody>
+      </p:sp>
+      <p:sp>
+        <p:nvSpPr>
+          <p:cNvPr id="13" name="Shape 4"/>
+          <p:cNvSpPr/>
+          <p:nvPr/>
+        </p:nvSpPr>
+        <p:spPr>
+          <a:xfrm>
+            <a:off x="6190488" y="1874519"/>
+            <a:ext cx="5175504" cy="3429000"/>
+          </a:xfrm>
+          <a:prstGeom prst="roundRect">
+            <a:avLst>
+              <a:gd name="adj" fmla="val 1724"/>
+            </a:avLst>
+          </a:prstGeom>
+          <a:solidFill>
+            <a:srgbClr val="F3F7FA"/>
+          </a:solidFill>
+          <a:ln/>
+        </p:spPr>
+      </p:sp>
+      <p:sp>
+        <p:nvSpPr>
+          <p:cNvPr id="14" name="Shape 5"/>
+          <p:cNvSpPr/>
+          <p:nvPr/>
+        </p:nvSpPr>
+        <p:spPr>
+          <a:xfrm>
+            <a:off x="6373368" y="2075687"/>
+            <a:ext cx="384048" cy="384048"/>
+          </a:xfrm>
+          <a:prstGeom prst="ellipse">
+            <a:avLst/>
+          </a:prstGeom>
+          <a:solidFill>
+            <a:srgbClr val="007BCB"/>
+          </a:solidFill>
+          <a:ln/>
+        </p:spPr>
+      </p:sp>
+      <p:sp>
+        <p:nvSpPr>
+          <p:cNvPr id="15" name="Text 6"/>
+          <p:cNvSpPr/>
+          <p:nvPr/>
+        </p:nvSpPr>
+        <p:spPr>
+          <a:xfrm>
+            <a:off x="6373368" y="2075687"/>
+            <a:ext cx="384048" cy="384048"/>
+          </a:xfrm>
+          <a:prstGeom prst="rect">
+            <a:avLst/>
+          </a:prstGeom>
+          <a:noFill/>
+          <a:ln/>
+        </p:spPr>
+        <p:txBody>
+          <a:bodyPr wrap="square" lIns="0" tIns="0" rIns="0" bIns="0" rtlCol="0" anchor="ctr"/>
+          <a:lstStyle/>
+          <a:p>
+            <a:pPr algn="ctr" indent="0" marL="0">
+              <a:buNone/>
+            </a:pPr>
+            <a:r>
+              <a:rPr lang="en-US" sz="1500" b="1" dirty="0">
+                <a:solidFill>
+                  <a:srgbClr val="FFFFFF"/>
+                </a:solidFill>
+                <a:latin typeface="Garamond" pitchFamily="34" charset="0"/>
+                <a:ea typeface="Garamond" pitchFamily="34" charset="-122"/>
+                <a:cs typeface="Garamond" pitchFamily="34" charset="-120"/>
+              </a:rPr>
+              <a:t>2</a:t>
+            </a:r>
+            <a:endParaRPr lang="en-US" sz="1500" dirty="0"/>
+          </a:p>
+        </p:txBody>
+      </p:sp>
+      <p:sp>
+        <p:nvSpPr>
+          <p:cNvPr id="16" name="Text 7"/>
+          <p:cNvSpPr/>
+          <p:nvPr/>
+        </p:nvSpPr>
+        <p:spPr>
+          <a:xfrm>
+            <a:off x="6373368" y="2606039"/>
+            <a:ext cx="4809744" cy="640080"/>
+          </a:xfrm>
+          <a:prstGeom prst="rect">
+            <a:avLst/>
+          </a:prstGeom>
+          <a:noFill/>
+          <a:ln/>
+        </p:spPr>
+        <p:txBody>
+          <a:bodyPr wrap="square" lIns="0" tIns="0" rIns="0" bIns="0" rtlCol="0" anchor="ctr"/>
+          <a:lstStyle/>
+          <a:p>
+            <a:pPr indent="0" marL="0">
+              <a:buNone/>
+            </a:pPr>
+            <a:r>
+              <a:rPr lang="en-US" sz="1550" b="1" dirty="0">
+                <a:solidFill>
+                  <a:srgbClr val="10222F"/>
+                </a:solidFill>
+                <a:latin typeface="Garamond" pitchFamily="34" charset="0"/>
+                <a:ea typeface="Garamond" pitchFamily="34" charset="-122"/>
+                <a:cs typeface="Garamond" pitchFamily="34" charset="-120"/>
+              </a:rPr>
+              <a:t>Establish Supply Chain and Volume Production in China</a:t>
+            </a:r>
+            <a:endParaRPr lang="en-US" sz="1550" dirty="0"/>
+          </a:p>
+        </p:txBody>
+      </p:sp>
+      <p:sp>
+        <p:nvSpPr>
+          <p:cNvPr id="17" name="Text 8"/>
+          <p:cNvSpPr/>
+          <p:nvPr/>
+        </p:nvSpPr>
+        <p:spPr>
+          <a:xfrm>
+            <a:off x="6373368" y="3337559"/>
+            <a:ext cx="4809744" cy="2194560"/>
+          </a:xfrm>
+          <a:prstGeom prst="rect">
+            <a:avLst/>
+          </a:prstGeom>
+          <a:noFill/>
+          <a:ln/>
+        </p:spPr>
+        <p:txBody>
+          <a:bodyPr wrap="square" lIns="0" tIns="0" rIns="0" bIns="0" rtlCol="0" anchor="t"/>
+          <a:lstStyle/>
+          <a:p>
+            <a:pPr indent="0" marL="0">
+              <a:lnSpc>
+                <a:spcPct val="106000"/>
+              </a:lnSpc>
+              <a:buNone/>
+            </a:pPr>
+            <a:r>
+              <a:rPr lang="en-US" sz="1100" dirty="0">
+                <a:solidFill>
+                  <a:srgbClr val="1E2A33"/>
+                </a:solidFill>
+                <a:latin typeface="Garamond" pitchFamily="34" charset="0"/>
+                <a:ea typeface="Garamond" pitchFamily="34" charset="-122"/>
+                <a:cs typeface="Garamond" pitchFamily="34" charset="-120"/>
+              </a:rPr>
+              <a:t>Once the quality of orders has been confirmed, establish a dedicated supply chain in China and stand up large scale production capacity. Volume manufacturing then serves the export order book with consistent quality and competitive cost.</a:t>
+            </a:r>
+            <a:endParaRPr lang="en-US" sz="1100" dirty="0"/>
+          </a:p>
+        </p:txBody>
+      </p:sp>
+      <p:sp>
+        <p:nvSpPr>
+          <p:cNvPr id="18" name="Text 22"/>
+          <p:cNvSpPr/>
+          <p:nvPr/>
+        </p:nvSpPr>
+        <p:spPr>
+          <a:xfrm>
+            <a:off x="822960" y="5577840"/>
+            <a:ext cx="10543032" cy="365760"/>
+          </a:xfrm>
+          <a:prstGeom prst="rect">
+            <a:avLst/>
+          </a:prstGeom>
+          <a:noFill/>
+          <a:ln/>
+        </p:spPr>
+        <p:txBody>
+          <a:bodyPr wrap="square" lIns="0" tIns="0" rIns="0" bIns="0" rtlCol="0" anchor="t"/>
+          <a:lstStyle/>
+          <a:p>
+            <a:pPr indent="0" marL="0">
+              <a:lnSpc>
+                <a:spcPct val="102000"/>
+              </a:lnSpc>
+              <a:buNone/>
+            </a:pPr>
+            <a:r>
+              <a:rPr lang="en-US" sz="1050" dirty="0">
+                <a:solidFill>
+                  <a:srgbClr val="1E2A33"/>
+                </a:solidFill>
+                <a:latin typeface="Garamond" pitchFamily="34" charset="0"/>
+                <a:ea typeface="Garamond" pitchFamily="34" charset="-122"/>
+                <a:cs typeface="Garamond" pitchFamily="34" charset="-120"/>
+              </a:rPr>
+              <a:t>Capital deployment in Phase Two is gated on confirmed order quality, keeping production capacity aligned with demonstrated demand.</a:t>
+            </a:r>
+            <a:endParaRPr lang="en-US" sz="1050" dirty="0"/>
+          </a:p>
+        </p:txBody>
+      </p:sp>
+    </p:spTree>
+  </p:cSld>
+  <p:clrMapOvr>
+    <a:masterClrMapping/>
+  </p:clrMapOvr>
+</p:sld>
+</file>
+
+<file path=ppt/slides/slide16.xml><?xml version="1.0" encoding="utf-8"?>
+<p:sld xmlns:a="http://schemas.openxmlformats.org/drawingml/2006/main" xmlns:p="http://schemas.openxmlformats.org/presentationml/2006/main" xmlns:r="http://schemas.openxmlformats.org/officeDocument/2006/relationships">
+  <p:cSld>
+    <p:spTree>
+      <p:nvGrpSpPr>
+        <p:cNvPr id="1" name=""/>
+        <p:cNvGrpSpPr/>
+        <p:nvPr/>
+      </p:nvGrpSpPr>
+      <p:grpSpPr/>
+      <p:sp>
+        <p:nvSpPr>
+          <p:cNvPr id="2" name="Text 0"/>
+          <p:cNvSpPr/>
+          <p:nvPr/>
+        </p:nvSpPr>
+        <p:spPr>
+          <a:xfrm>
+            <a:off x="822960" y="457200"/>
+            <a:ext cx="7772400" cy="274320"/>
+          </a:xfrm>
+          <a:prstGeom prst="rect">
+            <a:avLst/>
+          </a:prstGeom>
+          <a:noFill/>
+          <a:ln/>
+        </p:spPr>
+        <p:txBody>
+          <a:bodyPr wrap="square" lIns="0" tIns="0" rIns="0" bIns="0" rtlCol="0" anchor="ctr"/>
+          <a:lstStyle/>
+          <a:p>
+            <a:pPr indent="0" marL="0">
+              <a:buNone/>
+            </a:pPr>
+            <a:r>
+              <a:rPr lang="en-US" sz="1100" b="1" spc="300" kern="0" dirty="0">
+                <a:solidFill>
+                  <a:srgbClr val="007BCB"/>
+                </a:solidFill>
+                <a:latin typeface="Garamond" pitchFamily="34" charset="0"/>
+                <a:ea typeface="Garamond" pitchFamily="34" charset="-122"/>
+                <a:cs typeface="Garamond" pitchFamily="34" charset="-120"/>
+              </a:rPr>
+              <a:t>CHINA STRATEGY</a:t>
+            </a:r>
+            <a:endParaRPr lang="en-US" sz="1100" dirty="0"/>
+          </a:p>
+        </p:txBody>
+      </p:sp>
+      <p:sp>
+        <p:nvSpPr>
+          <p:cNvPr id="3" name="Text 1"/>
+          <p:cNvSpPr/>
+          <p:nvPr/>
+        </p:nvSpPr>
+        <p:spPr>
+          <a:xfrm>
+            <a:off x="822960" y="713232"/>
+            <a:ext cx="8961120" cy="566928"/>
+          </a:xfrm>
+          <a:prstGeom prst="rect">
+            <a:avLst/>
+          </a:prstGeom>
+          <a:noFill/>
+          <a:ln/>
+        </p:spPr>
+        <p:txBody>
+          <a:bodyPr wrap="square" lIns="0" tIns="0" rIns="0" bIns="0" rtlCol="0" anchor="ctr"/>
+          <a:lstStyle/>
+          <a:p>
+            <a:pPr indent="0" marL="0">
+              <a:buNone/>
+            </a:pPr>
+            <a:r>
+              <a:rPr lang="en-US" sz="2900" b="1" dirty="0">
+                <a:solidFill>
+                  <a:srgbClr val="10222F"/>
+                </a:solidFill>
+                <a:latin typeface="Garamond" pitchFamily="34" charset="0"/>
+                <a:ea typeface="Garamond" pitchFamily="34" charset="-122"/>
+                <a:cs typeface="Garamond" pitchFamily="34" charset="-120"/>
+              </a:rPr>
+              <a:t>Execution Priorities by Phase</a:t>
+            </a:r>
+            <a:endParaRPr lang="en-US" sz="2900" dirty="0"/>
+          </a:p>
+        </p:txBody>
+      </p:sp>
+      <p:pic>
+        <p:nvPicPr>
+          <p:cNvPr id="4" name="Image 0" descr="assets/logo_dark.jpg">    </p:cNvPr>
+          <p:cNvPicPr>
+            <a:picLocks noChangeAspect="1"/>
+          </p:cNvPicPr>
+          <p:nvPr/>
+        </p:nvPicPr>
+        <p:blipFill>
+          <a:blip r:embed="rId2"/>
+          <a:stretch>
+            <a:fillRect/>
+          </a:stretch>
+        </p:blipFill>
+        <p:spPr>
+          <a:xfrm>
+            <a:off x="10058400" y="475488"/>
+            <a:ext cx="1325880" cy="372161"/>
+          </a:xfrm>
+          <a:prstGeom prst="rect">
+            <a:avLst/>
+          </a:prstGeom>
+        </p:spPr>
+      </p:pic>
+      <p:sp>
+        <p:nvSpPr>
+          <p:cNvPr id="5" name="Text 2"/>
+          <p:cNvSpPr/>
+          <p:nvPr/>
+        </p:nvSpPr>
+        <p:spPr>
+          <a:xfrm>
+            <a:off x="822960" y="6492240"/>
+            <a:ext cx="5943600" cy="237744"/>
+          </a:xfrm>
+          <a:prstGeom prst="rect">
+            <a:avLst/>
+          </a:prstGeom>
+          <a:noFill/>
+          <a:ln/>
+        </p:spPr>
+        <p:txBody>
+          <a:bodyPr wrap="square" lIns="0" tIns="0" rIns="0" bIns="0" rtlCol="0" anchor="ctr"/>
+          <a:lstStyle/>
+          <a:p>
+            <a:pPr indent="0" marL="0">
+              <a:buNone/>
+            </a:pPr>
+            <a:r>
+              <a:rPr lang="en-US" sz="850" dirty="0">
+                <a:solidFill>
+                  <a:srgbClr val="5C6B76"/>
+                </a:solidFill>
+                <a:latin typeface="Garamond" pitchFamily="34" charset="0"/>
+                <a:ea typeface="Garamond" pitchFamily="34" charset="-122"/>
+                <a:cs typeface="Garamond" pitchFamily="34" charset="-120"/>
+              </a:rPr>
+              <a:t>Heliospace Corporation   |   Proprietary and Confidential</a:t>
+            </a:r>
+            <a:endParaRPr lang="en-US" sz="850" dirty="0"/>
+          </a:p>
+        </p:txBody>
+      </p:sp>
+      <p:sp>
+        <p:nvSpPr>
+          <p:cNvPr id="6" name="Text 3"/>
+          <p:cNvSpPr/>
+          <p:nvPr/>
+        </p:nvSpPr>
+        <p:spPr>
+          <a:xfrm>
+            <a:off x="11064240" y="6492240"/>
+            <a:ext cx="320040" cy="237744"/>
+          </a:xfrm>
+          <a:prstGeom prst="rect">
+            <a:avLst/>
+          </a:prstGeom>
+          <a:noFill/>
+          <a:ln/>
+        </p:spPr>
+        <p:txBody>
+          <a:bodyPr wrap="square" lIns="0" tIns="0" rIns="0" bIns="0" rtlCol="0" anchor="ctr"/>
+          <a:lstStyle/>
+          <a:p>
+            <a:pPr algn="r" indent="0" marL="0">
+              <a:buNone/>
+            </a:pPr>
+            <a:r>
+              <a:rPr lang="en-US" sz="850" dirty="0">
+                <a:solidFill>
+                  <a:srgbClr val="5C6B76"/>
+                </a:solidFill>
+                <a:latin typeface="Garamond" pitchFamily="34" charset="0"/>
+                <a:ea typeface="Garamond" pitchFamily="34" charset="-122"/>
+                <a:cs typeface="Garamond" pitchFamily="34" charset="-120"/>
+              </a:rPr>
+              <a:t>16</a:t>
+            </a:r>
+            <a:endParaRPr lang="en-US" sz="850" dirty="0"/>
+          </a:p>
+        </p:txBody>
+      </p:sp>
+      <p:sp>
+        <p:nvSpPr>
+          <p:cNvPr id="7" name="Text 4"/>
+          <p:cNvSpPr/>
+          <p:nvPr/>
+        </p:nvSpPr>
+        <p:spPr>
+          <a:xfrm>
+            <a:off x="822960" y="1353312"/>
+            <a:ext cx="10424160" cy="320040"/>
+          </a:xfrm>
+          <a:prstGeom prst="rect">
+            <a:avLst/>
+          </a:prstGeom>
+          <a:noFill/>
+          <a:ln/>
+        </p:spPr>
+        <p:txBody>
+          <a:bodyPr wrap="square" lIns="0" tIns="0" rIns="0" bIns="0" rtlCol="0" anchor="ctr"/>
+          <a:lstStyle/>
+          <a:p>
+            <a:pPr indent="0" marL="0">
+              <a:buNone/>
+            </a:pPr>
+            <a:r>
+              <a:rPr lang="en-US" sz="1300" dirty="0">
+                <a:solidFill>
+                  <a:srgbClr val="5C6B76"/>
+                </a:solidFill>
+                <a:latin typeface="Garamond" pitchFamily="34" charset="0"/>
+                <a:ea typeface="Garamond" pitchFamily="34" charset="-122"/>
+                <a:cs typeface="Garamond" pitchFamily="34" charset="-120"/>
+              </a:rPr>
+              <a:t>Each phase carries defined priorities and a clear gate, so that manufacturing investment follows demonstrated demand rather than preceding it.</a:t>
+            </a:r>
+            <a:endParaRPr lang="en-US" sz="1300" dirty="0"/>
+          </a:p>
+        </p:txBody>
+      </p:sp>
+      <p:sp>
+        <p:nvSpPr>
+          <p:cNvPr id="8" name="Text 4"/>
+          <p:cNvSpPr/>
+          <p:nvPr/>
+        </p:nvSpPr>
+        <p:spPr>
+          <a:xfrm>
+            <a:off x="822960" y="2011680"/>
+            <a:ext cx="5175504" cy="548640"/>
+          </a:xfrm>
+          <a:prstGeom prst="rect">
+            <a:avLst/>
+          </a:prstGeom>
+          <a:noFill/>
+          <a:ln/>
+        </p:spPr>
+        <p:txBody>
+          <a:bodyPr wrap="square" lIns="0" tIns="0" rIns="0" bIns="0" rtlCol="0" anchor="ctr"/>
+          <a:lstStyle/>
+          <a:p>
+            <a:pPr indent="0" marL="0">
+              <a:buNone/>
+            </a:pPr>
+            <a:r>
+              <a:rPr lang="en-US" sz="1350" b="1" dirty="0">
+                <a:solidFill>
+                  <a:srgbClr val="007BCB"/>
+                </a:solidFill>
+                <a:latin typeface="Garamond" pitchFamily="34" charset="0"/>
+                <a:ea typeface="Garamond" pitchFamily="34" charset="-122"/>
+                <a:cs typeface="Garamond" pitchFamily="34" charset="-120"/>
+              </a:rPr>
+              <a:t>Phase One: Export Sales and Order Capture</a:t>
+            </a:r>
+            <a:endParaRPr lang="en-US" sz="1350" dirty="0"/>
+          </a:p>
+        </p:txBody>
+      </p:sp>
+      <p:sp>
+        <p:nvSpPr>
+          <p:cNvPr id="9" name="Text 13"/>
+          <p:cNvSpPr/>
+          <p:nvPr/>
+        </p:nvSpPr>
+        <p:spPr>
+          <a:xfrm>
+            <a:off x="822960" y="2651760"/>
+            <a:ext cx="5175504" cy="2103120"/>
+          </a:xfrm>
+          <a:prstGeom prst="rect">
+            <a:avLst/>
+          </a:prstGeom>
+          <a:noFill/>
+          <a:ln/>
+        </p:spPr>
+        <p:txBody>
+          <a:bodyPr wrap="square" lIns="0" tIns="0" rIns="0" bIns="0" rtlCol="0" anchor="t"/>
+          <a:lstStyle/>
+          <a:p>
+            <a:pPr algn="l" marL="127000" indent="-127000">
+              <a:spcAft>
+                <a:spcPts val="400"/>
+              </a:spcAft>
+              <a:buSzPct val="100000"/>
+              <a:buChar char="•"/>
+            </a:pPr>
+            <a:r>
+              <a:rPr lang="en-US" sz="1100" dirty="0">
+                <a:solidFill>
+                  <a:srgbClr val="1E2A33"/>
+                </a:solidFill>
+                <a:latin typeface="Garamond" pitchFamily="34" charset="0"/>
+                <a:ea typeface="Garamond" pitchFamily="34" charset="-122"/>
+                <a:cs typeface="Garamond" pitchFamily="34" charset="-120"/>
+              </a:rPr>
+              <a:t>Market the existing product and component catalog to overseas clients</a:t>
+            </a:r>
+            <a:endParaRPr lang="en-US" sz="1100" dirty="0"/>
+          </a:p>
+          <a:p>
+            <a:pPr algn="l" marL="127000" indent="-127000">
+              <a:spcAft>
+                <a:spcPts val="400"/>
+              </a:spcAft>
+              <a:buSzPct val="100000"/>
+              <a:buChar char="•"/>
+            </a:pPr>
+            <a:r>
+              <a:rPr lang="en-US" sz="1100" dirty="0">
+                <a:solidFill>
+                  <a:srgbClr val="1E2A33"/>
+                </a:solidFill>
+                <a:latin typeface="Garamond" pitchFamily="34" charset="0"/>
+                <a:ea typeface="Garamond" pitchFamily="34" charset="-122"/>
+                <a:cs typeface="Garamond" pitchFamily="34" charset="-120"/>
+              </a:rPr>
+              <a:t>Secure export clients and convert engagement into firm orders</a:t>
+            </a:r>
+            <a:endParaRPr lang="en-US" sz="1100" dirty="0"/>
+          </a:p>
+          <a:p>
+            <a:pPr algn="l" marL="127000" indent="-127000">
+              <a:spcAft>
+                <a:spcPts val="400"/>
+              </a:spcAft>
+              <a:buSzPct val="100000"/>
+              <a:buChar char="•"/>
+            </a:pPr>
+            <a:r>
+              <a:rPr lang="en-US" sz="1100" dirty="0">
+                <a:solidFill>
+                  <a:srgbClr val="1E2A33"/>
+                </a:solidFill>
+                <a:latin typeface="Garamond" pitchFamily="34" charset="0"/>
+                <a:ea typeface="Garamond" pitchFamily="34" charset="-122"/>
+                <a:cs typeface="Garamond" pitchFamily="34" charset="-120"/>
+              </a:rPr>
+              <a:t>Offer every component in the current portfolio for overseas sale</a:t>
+            </a:r>
+            <a:endParaRPr lang="en-US" sz="1100" dirty="0"/>
+          </a:p>
+          <a:p>
+            <a:pPr algn="l" marL="127000" indent="-127000">
+              <a:spcAft>
+                <a:spcPts val="400"/>
+              </a:spcAft>
+              <a:buSzPct val="100000"/>
+              <a:buChar char="•"/>
+            </a:pPr>
+            <a:r>
+              <a:rPr lang="en-US" sz="1100" dirty="0">
+                <a:solidFill>
+                  <a:srgbClr val="1E2A33"/>
+                </a:solidFill>
+                <a:latin typeface="Garamond" pitchFamily="34" charset="0"/>
+                <a:ea typeface="Garamond" pitchFamily="34" charset="-122"/>
+                <a:cs typeface="Garamond" pitchFamily="34" charset="-120"/>
+              </a:rPr>
+              <a:t>Build a repeatable order pipeline that demonstrates sustained demand</a:t>
+            </a:r>
+            <a:endParaRPr lang="en-US" sz="1100" dirty="0"/>
+          </a:p>
+        </p:txBody>
+      </p:sp>
+      <p:sp>
+        <p:nvSpPr>
+          <p:cNvPr id="10" name="Text 4"/>
+          <p:cNvSpPr/>
+          <p:nvPr/>
+        </p:nvSpPr>
+        <p:spPr>
+          <a:xfrm>
+            <a:off x="6190488" y="2011680"/>
+            <a:ext cx="5175504" cy="548640"/>
+          </a:xfrm>
+          <a:prstGeom prst="rect">
+            <a:avLst/>
+          </a:prstGeom>
+          <a:noFill/>
+          <a:ln/>
+        </p:spPr>
+        <p:txBody>
+          <a:bodyPr wrap="square" lIns="0" tIns="0" rIns="0" bIns="0" rtlCol="0" anchor="ctr"/>
+          <a:lstStyle/>
+          <a:p>
+            <a:pPr indent="0" marL="0">
+              <a:buNone/>
+            </a:pPr>
+            <a:r>
+              <a:rPr lang="en-US" sz="1350" b="1" dirty="0">
+                <a:solidFill>
+                  <a:srgbClr val="007BCB"/>
+                </a:solidFill>
+                <a:latin typeface="Garamond" pitchFamily="34" charset="0"/>
+                <a:ea typeface="Garamond" pitchFamily="34" charset="-122"/>
+                <a:cs typeface="Garamond" pitchFamily="34" charset="-120"/>
+              </a:rPr>
+              <a:t>Phase Two: Supply Chain and Production at Scale</a:t>
+            </a:r>
+            <a:endParaRPr lang="en-US" sz="1350" dirty="0"/>
+          </a:p>
+        </p:txBody>
+      </p:sp>
+      <p:sp>
+        <p:nvSpPr>
+          <p:cNvPr id="11" name="Text 13"/>
+          <p:cNvSpPr/>
+          <p:nvPr/>
+        </p:nvSpPr>
+        <p:spPr>
+          <a:xfrm>
+            <a:off x="6190488" y="2651760"/>
+            <a:ext cx="5175504" cy="2103120"/>
+          </a:xfrm>
+          <a:prstGeom prst="rect">
+            <a:avLst/>
+          </a:prstGeom>
+          <a:noFill/>
+          <a:ln/>
+        </p:spPr>
+        <p:txBody>
+          <a:bodyPr wrap="square" lIns="0" tIns="0" rIns="0" bIns="0" rtlCol="0" anchor="t"/>
+          <a:lstStyle/>
+          <a:p>
+            <a:pPr algn="l" marL="127000" indent="-127000">
+              <a:spcAft>
+                <a:spcPts val="400"/>
+              </a:spcAft>
+              <a:buSzPct val="100000"/>
+              <a:buChar char="•"/>
+            </a:pPr>
+            <a:r>
+              <a:rPr lang="en-US" sz="1100" dirty="0">
+                <a:solidFill>
+                  <a:srgbClr val="1E2A33"/>
+                </a:solidFill>
+                <a:latin typeface="Garamond" pitchFamily="34" charset="0"/>
+                <a:ea typeface="Garamond" pitchFamily="34" charset="-122"/>
+                <a:cs typeface="Garamond" pitchFamily="34" charset="-120"/>
+              </a:rPr>
+              <a:t>Confirm the quality of orders before committing production capital</a:t>
+            </a:r>
+            <a:endParaRPr lang="en-US" sz="1100" dirty="0"/>
+          </a:p>
+          <a:p>
+            <a:pPr algn="l" marL="127000" indent="-127000">
+              <a:spcAft>
+                <a:spcPts val="400"/>
+              </a:spcAft>
+              <a:buSzPct val="100000"/>
+              <a:buChar char="•"/>
+            </a:pPr>
+            <a:r>
+              <a:rPr lang="en-US" sz="1100" dirty="0">
+                <a:solidFill>
+                  <a:srgbClr val="1E2A33"/>
+                </a:solidFill>
+                <a:latin typeface="Garamond" pitchFamily="34" charset="0"/>
+                <a:ea typeface="Garamond" pitchFamily="34" charset="-122"/>
+                <a:cs typeface="Garamond" pitchFamily="34" charset="-120"/>
+              </a:rPr>
+              <a:t>Qualify suppliers and establish a dedicated supply chain in China</a:t>
+            </a:r>
+            <a:endParaRPr lang="en-US" sz="1100" dirty="0"/>
+          </a:p>
+          <a:p>
+            <a:pPr algn="l" marL="127000" indent="-127000">
+              <a:spcAft>
+                <a:spcPts val="400"/>
+              </a:spcAft>
+              <a:buSzPct val="100000"/>
+              <a:buChar char="•"/>
+            </a:pPr>
+            <a:r>
+              <a:rPr lang="en-US" sz="1100" dirty="0">
+                <a:solidFill>
+                  <a:srgbClr val="1E2A33"/>
+                </a:solidFill>
+                <a:latin typeface="Garamond" pitchFamily="34" charset="0"/>
+                <a:ea typeface="Garamond" pitchFamily="34" charset="-122"/>
+                <a:cs typeface="Garamond" pitchFamily="34" charset="-120"/>
+              </a:rPr>
+              <a:t>Stand up large scale production capacity matched to confirmed demand</a:t>
+            </a:r>
+            <a:endParaRPr lang="en-US" sz="1100" dirty="0"/>
+          </a:p>
+          <a:p>
+            <a:pPr algn="l" marL="127000" indent="-127000">
+              <a:spcAft>
+                <a:spcPts val="400"/>
+              </a:spcAft>
+              <a:buSzPct val="100000"/>
+              <a:buChar char="•"/>
+            </a:pPr>
+            <a:r>
+              <a:rPr lang="en-US" sz="1100" dirty="0">
+                <a:solidFill>
+                  <a:srgbClr val="1E2A33"/>
+                </a:solidFill>
+                <a:latin typeface="Garamond" pitchFamily="34" charset="0"/>
+                <a:ea typeface="Garamond" pitchFamily="34" charset="-122"/>
+                <a:cs typeface="Garamond" pitchFamily="34" charset="-120"/>
+              </a:rPr>
+              <a:t>Serve the export order book at volume with consistent quality standards</a:t>
+            </a:r>
+            <a:endParaRPr lang="en-US" sz="1100" dirty="0"/>
+          </a:p>
+        </p:txBody>
+      </p:sp>
+      <p:sp>
+        <p:nvSpPr>
+          <p:cNvPr id="12" name="Shape 20"/>
+          <p:cNvSpPr/>
+          <p:nvPr/>
+        </p:nvSpPr>
+        <p:spPr>
+          <a:xfrm>
+            <a:off x="822960" y="5074920"/>
+            <a:ext cx="10543032" cy="1188720"/>
+          </a:xfrm>
+          <a:prstGeom prst="roundRect">
+            <a:avLst>
+              <a:gd name="adj" fmla="val 3704"/>
+            </a:avLst>
+          </a:prstGeom>
+          <a:solidFill>
+            <a:srgbClr val="EDF3F8"/>
+          </a:solidFill>
+          <a:ln w="9525">
+            <a:solidFill>
+              <a:srgbClr val="C6D2DA"/>
+            </a:solidFill>
+            <a:prstDash val="solid"/>
+          </a:ln>
+        </p:spPr>
+      </p:sp>
+      <p:sp>
+        <p:nvSpPr>
+          <p:cNvPr id="13" name="Text 21"/>
+          <p:cNvSpPr/>
+          <p:nvPr/>
+        </p:nvSpPr>
+        <p:spPr>
+          <a:xfrm>
+            <a:off x="1005840" y="5184648"/>
+            <a:ext cx="3200400" cy="256032"/>
+          </a:xfrm>
+          <a:prstGeom prst="rect">
+            <a:avLst/>
+          </a:prstGeom>
+          <a:noFill/>
+          <a:ln/>
+        </p:spPr>
+        <p:txBody>
+          <a:bodyPr wrap="square" lIns="0" tIns="0" rIns="0" bIns="0" rtlCol="0" anchor="ctr"/>
+          <a:lstStyle/>
+          <a:p>
+            <a:pPr indent="0" marL="0">
+              <a:buNone/>
+            </a:pPr>
+            <a:r>
+              <a:rPr lang="en-US" sz="1250" b="1" dirty="0">
+                <a:solidFill>
+                  <a:srgbClr val="10222F"/>
+                </a:solidFill>
+                <a:latin typeface="Garamond" pitchFamily="34" charset="0"/>
+                <a:ea typeface="Garamond" pitchFamily="34" charset="-122"/>
+                <a:cs typeface="Garamond" pitchFamily="34" charset="-120"/>
+              </a:rPr>
+              <a:t>Gating discipline</a:t>
+            </a:r>
+            <a:endParaRPr lang="en-US" sz="1250" dirty="0"/>
+          </a:p>
+        </p:txBody>
+      </p:sp>
+      <p:sp>
+        <p:nvSpPr>
+          <p:cNvPr id="14" name="Text 22"/>
+          <p:cNvSpPr/>
+          <p:nvPr/>
+        </p:nvSpPr>
+        <p:spPr>
+          <a:xfrm>
+            <a:off x="1005840" y="5458968"/>
+            <a:ext cx="10149840" cy="731520"/>
+          </a:xfrm>
+          <a:prstGeom prst="rect">
+            <a:avLst/>
+          </a:prstGeom>
+          <a:noFill/>
+          <a:ln/>
+        </p:spPr>
+        <p:txBody>
+          <a:bodyPr wrap="square" lIns="0" tIns="0" rIns="0" bIns="0" rtlCol="0" anchor="t"/>
+          <a:lstStyle/>
+          <a:p>
+            <a:pPr indent="0" marL="0">
+              <a:lnSpc>
+                <a:spcPct val="102000"/>
+              </a:lnSpc>
+              <a:buNone/>
+            </a:pPr>
+            <a:r>
+              <a:rPr lang="en-US" sz="1050" dirty="0">
+                <a:solidFill>
+                  <a:srgbClr val="1E2A33"/>
+                </a:solidFill>
+                <a:latin typeface="Garamond" pitchFamily="34" charset="0"/>
+                <a:ea typeface="Garamond" pitchFamily="34" charset="-122"/>
+                <a:cs typeface="Garamond" pitchFamily="34" charset="-120"/>
+              </a:rPr>
+              <a:t>The transition from Phase One to Phase Two proceeds only after the quality of orders has been confirmed. This sequencing limits capital at risk, ties production capacity to a proven order book, and preserves flexibility in how and where manufacturing scale is added.</a:t>
+            </a:r>
+            <a:endParaRPr lang="en-US" sz="1050" dirty="0"/>
+          </a:p>
+        </p:txBody>
+      </p:sp>
+    </p:spTree>
+  </p:cSld>
+  <p:clrMapOvr>
+    <a:masterClrMapping/>
+  </p:clrMapOvr>
+</p:sld>
+</file>
+
+<file path=ppt/slides/slide17.xml><?xml version="1.0" encoding="utf-8"?>
 <p:sld xmlns:a="http://schemas.openxmlformats.org/drawingml/2006/main" xmlns:r="http://schemas.openxmlformats.org/officeDocument/2006/relationships" xmlns:p="http://schemas.openxmlformats.org/presentationml/2006/main">
   <p:cSld name="Slide 15">
     <p:bg>
@@ -8005,7 +9245,7 @@
                 <a:ea typeface="Garamond" pitchFamily="34" charset="-122"/>
                 <a:cs typeface="Garamond" pitchFamily="34" charset="-120"/>
               </a:rPr>
-              <a:t>15</a:t>
+              <a:t>17</a:t>
             </a:r>
             <a:endParaRPr lang="en-US" sz="850" dirty="0"/>
           </a:p>
@@ -8427,7 +9667,7 @@
 </p:sld>
 </file>
 
-<file path=ppt/slides/slide16.xml><?xml version="1.0" encoding="utf-8"?>
+<file path=ppt/slides/slide18.xml><?xml version="1.0" encoding="utf-8"?>
 <p:sld xmlns:a="http://schemas.openxmlformats.org/drawingml/2006/main" xmlns:r="http://schemas.openxmlformats.org/officeDocument/2006/relationships" xmlns:p="http://schemas.openxmlformats.org/presentationml/2006/main">
   <p:cSld name="Slide 16">
     <p:spTree>

</xml_diff>

<commit_message>
Rework second China slide into competitive position and route to market
Co-authored-by: anthonyleedu <anthonyleedu@users.noreply.github.com>
</commit_message>
<xml_diff>
--- a/Heliospace_Investor_Overview.pptx
+++ b/Heliospace_Investor_Overview.pptx
@@ -8494,7 +8494,7 @@
                 <a:ea typeface="Garamond" pitchFamily="34" charset="-122"/>
                 <a:cs typeface="Garamond" pitchFamily="34" charset="-120"/>
               </a:rPr>
-              <a:t>Execution Priorities by Phase</a:t>
+              <a:t>Competitive Position and Route to Market</a:t>
             </a:r>
             <a:endParaRPr lang="en-US" sz="2900" dirty="0"/>
           </a:p>
@@ -8635,7 +8635,7 @@
                 <a:ea typeface="Garamond" pitchFamily="34" charset="-122"/>
                 <a:cs typeface="Garamond" pitchFamily="34" charset="-120"/>
               </a:rPr>
-              <a:t>Each phase carries defined priorities and a clear gate, so that manufacturing investment follows demonstrated demand rather than preceding it.</a:t>
+              <a:t>A proven supplier with marquee clients, differentiated products, and a clear route to serving Chinese customers.</a:t>
             </a:r>
             <a:endParaRPr lang="en-US" sz="1300" dirty="0"/>
           </a:p>
@@ -8649,8 +8649,8 @@
         </p:nvSpPr>
         <p:spPr>
           <a:xfrm>
-            <a:off x="822960" y="2011680"/>
-            <a:ext cx="5175504" cy="548640"/>
+            <a:off x="822960" y="1828800"/>
+            <a:ext cx="5175504" cy="256032"/>
           </a:xfrm>
           <a:prstGeom prst="rect">
             <a:avLst/>
@@ -8674,7 +8674,7 @@
                 <a:ea typeface="Garamond" pitchFamily="34" charset="-122"/>
                 <a:cs typeface="Garamond" pitchFamily="34" charset="-120"/>
               </a:rPr>
-              <a:t>Phase One: Export Sales and Order Capture</a:t>
+              <a:t>Why Heliospace is competitive</a:t>
             </a:r>
             <a:endParaRPr lang="en-US" sz="1350" dirty="0"/>
           </a:p>
@@ -8682,14 +8682,248 @@
       </p:sp>
       <p:sp>
         <p:nvSpPr>
-          <p:cNvPr id="9" name="Text 13"/>
-          <p:cNvSpPr/>
-          <p:nvPr/>
-        </p:nvSpPr>
-        <p:spPr>
-          <a:xfrm>
-            <a:off x="822960" y="2651760"/>
-            <a:ext cx="5175504" cy="2103120"/>
+          <p:cNvPr id="9" name="Text 5"/>
+          <p:cNvSpPr/>
+          <p:nvPr/>
+        </p:nvSpPr>
+        <p:spPr>
+          <a:xfrm>
+            <a:off x="822960" y="2121408"/>
+            <a:ext cx="5175504" cy="914400"/>
+          </a:xfrm>
+          <a:prstGeom prst="rect">
+            <a:avLst/>
+          </a:prstGeom>
+          <a:noFill/>
+          <a:ln/>
+        </p:spPr>
+        <p:txBody>
+          <a:bodyPr wrap="square" lIns="0" tIns="0" rIns="0" bIns="0" rtlCol="0" anchor="t"/>
+          <a:lstStyle/>
+          <a:p>
+            <a:pPr indent="0" marL="0">
+              <a:buNone/>
+            </a:pPr>
+            <a:r>
+              <a:rPr lang="en-US" sz="1150" dirty="0">
+                <a:solidFill>
+                  <a:srgbClr val="1E2A33"/>
+                </a:solidFill>
+                <a:latin typeface="Garamond" pitchFamily="34" charset="0"/>
+                <a:ea typeface="Garamond" pitchFamily="34" charset="-122"/>
+                <a:cs typeface="Garamond" pitchFamily="34" charset="-120"/>
+              </a:rPr>
+              <a:t>Decades of flight heritage with NASA and ESA, an in house boom forming capability that removes supplier risk, and a lean cost structure that delivers fully qualified hardware at competitive prices and short lead times.</a:t>
+            </a:r>
+            <a:endParaRPr lang="en-US" sz="1150" dirty="0"/>
+          </a:p>
+        </p:txBody>
+      </p:sp>
+      <p:sp>
+        <p:nvSpPr>
+          <p:cNvPr id="10" name="Text 4"/>
+          <p:cNvSpPr/>
+          <p:nvPr/>
+        </p:nvSpPr>
+        <p:spPr>
+          <a:xfrm>
+            <a:off x="822960" y="3200400"/>
+            <a:ext cx="5175504" cy="256032"/>
+          </a:xfrm>
+          <a:prstGeom prst="rect">
+            <a:avLst/>
+          </a:prstGeom>
+          <a:noFill/>
+          <a:ln/>
+        </p:spPr>
+        <p:txBody>
+          <a:bodyPr wrap="square" lIns="0" tIns="0" rIns="0" bIns="0" rtlCol="0" anchor="ctr"/>
+          <a:lstStyle/>
+          <a:p>
+            <a:pPr indent="0" marL="0">
+              <a:buNone/>
+            </a:pPr>
+            <a:r>
+              <a:rPr lang="en-US" sz="1350" b="1" dirty="0">
+                <a:solidFill>
+                  <a:srgbClr val="007BCB"/>
+                </a:solidFill>
+                <a:latin typeface="Garamond" pitchFamily="34" charset="0"/>
+                <a:ea typeface="Garamond" pitchFamily="34" charset="-122"/>
+                <a:cs typeface="Garamond" pitchFamily="34" charset="-120"/>
+              </a:rPr>
+              <a:t>An established client base</a:t>
+            </a:r>
+            <a:endParaRPr lang="en-US" sz="1350" dirty="0"/>
+          </a:p>
+        </p:txBody>
+      </p:sp>
+      <p:sp>
+        <p:nvSpPr>
+          <p:cNvPr id="11" name="Text 5"/>
+          <p:cNvSpPr/>
+          <p:nvPr/>
+        </p:nvSpPr>
+        <p:spPr>
+          <a:xfrm>
+            <a:off x="822960" y="3493008"/>
+            <a:ext cx="5175504" cy="1051560"/>
+          </a:xfrm>
+          <a:prstGeom prst="rect">
+            <a:avLst/>
+          </a:prstGeom>
+          <a:noFill/>
+          <a:ln/>
+        </p:spPr>
+        <p:txBody>
+          <a:bodyPr wrap="square" lIns="0" tIns="0" rIns="0" bIns="0" rtlCol="0" anchor="t"/>
+          <a:lstStyle/>
+          <a:p>
+            <a:pPr indent="0" marL="0">
+              <a:buNone/>
+            </a:pPr>
+            <a:r>
+              <a:rPr lang="en-US" sz="1150" dirty="0">
+                <a:solidFill>
+                  <a:srgbClr val="1E2A33"/>
+                </a:solidFill>
+                <a:latin typeface="Garamond" pitchFamily="34" charset="0"/>
+                <a:ea typeface="Garamond" pitchFamily="34" charset="-122"/>
+                <a:cs typeface="Garamond" pitchFamily="34" charset="-120"/>
+              </a:rPr>
+              <a:t>NASA JPL, NASA Goddard, Caltech, UC Berkeley Space Sciences Laboratory, Firefly Aerospace, Intuitive Machines, SwRI, and Blue Origin, with hardware operating on Europa Clipper, Solar Orbiter, and the first commercial lunar landings.</a:t>
+            </a:r>
+            <a:endParaRPr lang="en-US" sz="1150" dirty="0"/>
+          </a:p>
+        </p:txBody>
+      </p:sp>
+      <p:sp>
+        <p:nvSpPr>
+          <p:cNvPr id="12" name="Text 4"/>
+          <p:cNvSpPr/>
+          <p:nvPr/>
+        </p:nvSpPr>
+        <p:spPr>
+          <a:xfrm>
+            <a:off x="822960" y="4709160"/>
+            <a:ext cx="5175504" cy="256032"/>
+          </a:xfrm>
+          <a:prstGeom prst="rect">
+            <a:avLst/>
+          </a:prstGeom>
+          <a:noFill/>
+          <a:ln/>
+        </p:spPr>
+        <p:txBody>
+          <a:bodyPr wrap="square" lIns="0" tIns="0" rIns="0" bIns="0" rtlCol="0" anchor="ctr"/>
+          <a:lstStyle/>
+          <a:p>
+            <a:pPr indent="0" marL="0">
+              <a:buNone/>
+            </a:pPr>
+            <a:r>
+              <a:rPr lang="en-US" sz="1350" b="1" dirty="0">
+                <a:solidFill>
+                  <a:srgbClr val="007BCB"/>
+                </a:solidFill>
+                <a:latin typeface="Garamond" pitchFamily="34" charset="0"/>
+                <a:ea typeface="Garamond" pitchFamily="34" charset="-122"/>
+                <a:cs typeface="Garamond" pitchFamily="34" charset="-120"/>
+              </a:rPr>
+              <a:t>Why customers choose us</a:t>
+            </a:r>
+            <a:endParaRPr lang="en-US" sz="1350" dirty="0"/>
+          </a:p>
+        </p:txBody>
+      </p:sp>
+      <p:sp>
+        <p:nvSpPr>
+          <p:cNvPr id="13" name="Text 5"/>
+          <p:cNvSpPr/>
+          <p:nvPr/>
+        </p:nvSpPr>
+        <p:spPr>
+          <a:xfrm>
+            <a:off x="822960" y="5001768"/>
+            <a:ext cx="5175504" cy="914400"/>
+          </a:xfrm>
+          <a:prstGeom prst="rect">
+            <a:avLst/>
+          </a:prstGeom>
+          <a:noFill/>
+          <a:ln/>
+        </p:spPr>
+        <p:txBody>
+          <a:bodyPr wrap="square" lIns="0" tIns="0" rIns="0" bIns="0" rtlCol="0" anchor="t"/>
+          <a:lstStyle/>
+          <a:p>
+            <a:pPr indent="0" marL="0">
+              <a:buNone/>
+            </a:pPr>
+            <a:r>
+              <a:rPr lang="en-US" sz="1150" dirty="0">
+                <a:solidFill>
+                  <a:srgbClr val="1E2A33"/>
+                </a:solidFill>
+                <a:latin typeface="Garamond" pitchFamily="34" charset="0"/>
+                <a:ea typeface="Garamond" pitchFamily="34" charset="-122"/>
+                <a:cs typeface="Garamond" pitchFamily="34" charset="-120"/>
+              </a:rPr>
+              <a:t>Supplier of record on marquee missions, on schedule delivery for launch critical payloads, and repeat awards across programs and platforms.</a:t>
+            </a:r>
+            <a:endParaRPr lang="en-US" sz="1150" dirty="0"/>
+          </a:p>
+        </p:txBody>
+      </p:sp>
+      <p:sp>
+        <p:nvSpPr>
+          <p:cNvPr id="14" name="Text 4"/>
+          <p:cNvSpPr/>
+          <p:nvPr/>
+        </p:nvSpPr>
+        <p:spPr>
+          <a:xfrm>
+            <a:off x="6190488" y="1828800"/>
+            <a:ext cx="5175504" cy="256032"/>
+          </a:xfrm>
+          <a:prstGeom prst="rect">
+            <a:avLst/>
+          </a:prstGeom>
+          <a:noFill/>
+          <a:ln/>
+        </p:spPr>
+        <p:txBody>
+          <a:bodyPr wrap="square" lIns="0" tIns="0" rIns="0" bIns="0" rtlCol="0" anchor="ctr"/>
+          <a:lstStyle/>
+          <a:p>
+            <a:pPr indent="0" marL="0">
+              <a:buNone/>
+            </a:pPr>
+            <a:r>
+              <a:rPr lang="en-US" sz="1350" b="1" dirty="0">
+                <a:solidFill>
+                  <a:srgbClr val="007BCB"/>
+                </a:solidFill>
+                <a:latin typeface="Garamond" pitchFamily="34" charset="0"/>
+                <a:ea typeface="Garamond" pitchFamily="34" charset="-122"/>
+                <a:cs typeface="Garamond" pitchFamily="34" charset="-120"/>
+              </a:rPr>
+              <a:t>Why our products are competitive</a:t>
+            </a:r>
+            <a:endParaRPr lang="en-US" sz="1350" dirty="0"/>
+          </a:p>
+        </p:txBody>
+      </p:sp>
+      <p:sp>
+        <p:nvSpPr>
+          <p:cNvPr id="15" name="Text 13"/>
+          <p:cNvSpPr/>
+          <p:nvPr/>
+        </p:nvSpPr>
+        <p:spPr>
+          <a:xfrm>
+            <a:off x="6190488" y="2121408"/>
+            <a:ext cx="5175504" cy="1600200"/>
           </a:xfrm>
           <a:prstGeom prst="rect">
             <a:avLst/>
@@ -8717,7 +8951,7 @@
                 <a:ea typeface="Garamond" pitchFamily="34" charset="-122"/>
                 <a:cs typeface="Garamond" pitchFamily="34" charset="-120"/>
               </a:rPr>
-              <a:t>Market the existing product and component catalog to overseas clients</a:t>
+              <a:t>Stow ratios of up to 50:1, well beyond typical deployables</a:t>
             </a:r>
             <a:endParaRPr lang="en-US" sz="1100" dirty="0"/>
           </a:p>
@@ -8738,7 +8972,7 @@
                 <a:ea typeface="Garamond" pitchFamily="34" charset="-122"/>
                 <a:cs typeface="Garamond" pitchFamily="34" charset="-120"/>
               </a:rPr>
-              <a:t>Secure export clients and convert engagement into firm orders</a:t>
+              <a:t>Operating range of -200 C to +200 C</a:t>
             </a:r>
             <a:endParaRPr lang="en-US" sz="1100" dirty="0"/>
           </a:p>
@@ -8759,7 +8993,7 @@
                 <a:ea typeface="Garamond" pitchFamily="34" charset="-122"/>
                 <a:cs typeface="Garamond" pitchFamily="34" charset="-120"/>
               </a:rPr>
-              <a:t>Offer every component in the current portfolio for overseas sale</a:t>
+              <a:t>Redundant, non explosive release with no ordnance handling</a:t>
             </a:r>
             <a:endParaRPr lang="en-US" sz="1100" dirty="0"/>
           </a:p>
@@ -8780,71 +9014,10 @@
                 <a:ea typeface="Garamond" pitchFamily="34" charset="-122"/>
                 <a:cs typeface="Garamond" pitchFamily="34" charset="-120"/>
               </a:rPr>
-              <a:t>Build a repeatable order pipeline that demonstrates sustained demand</a:t>
+              <a:t>Lower mass and cost with lead times measured in weeks</a:t>
             </a:r>
             <a:endParaRPr lang="en-US" sz="1100" dirty="0"/>
           </a:p>
-        </p:txBody>
-      </p:sp>
-      <p:sp>
-        <p:nvSpPr>
-          <p:cNvPr id="10" name="Text 4"/>
-          <p:cNvSpPr/>
-          <p:nvPr/>
-        </p:nvSpPr>
-        <p:spPr>
-          <a:xfrm>
-            <a:off x="6190488" y="2011680"/>
-            <a:ext cx="5175504" cy="548640"/>
-          </a:xfrm>
-          <a:prstGeom prst="rect">
-            <a:avLst/>
-          </a:prstGeom>
-          <a:noFill/>
-          <a:ln/>
-        </p:spPr>
-        <p:txBody>
-          <a:bodyPr wrap="square" lIns="0" tIns="0" rIns="0" bIns="0" rtlCol="0" anchor="ctr"/>
-          <a:lstStyle/>
-          <a:p>
-            <a:pPr indent="0" marL="0">
-              <a:buNone/>
-            </a:pPr>
-            <a:r>
-              <a:rPr lang="en-US" sz="1350" b="1" dirty="0">
-                <a:solidFill>
-                  <a:srgbClr val="007BCB"/>
-                </a:solidFill>
-                <a:latin typeface="Garamond" pitchFamily="34" charset="0"/>
-                <a:ea typeface="Garamond" pitchFamily="34" charset="-122"/>
-                <a:cs typeface="Garamond" pitchFamily="34" charset="-120"/>
-              </a:rPr>
-              <a:t>Phase Two: Supply Chain and Production at Scale</a:t>
-            </a:r>
-            <a:endParaRPr lang="en-US" sz="1350" dirty="0"/>
-          </a:p>
-        </p:txBody>
-      </p:sp>
-      <p:sp>
-        <p:nvSpPr>
-          <p:cNvPr id="11" name="Text 13"/>
-          <p:cNvSpPr/>
-          <p:nvPr/>
-        </p:nvSpPr>
-        <p:spPr>
-          <a:xfrm>
-            <a:off x="6190488" y="2651760"/>
-            <a:ext cx="5175504" cy="2103120"/>
-          </a:xfrm>
-          <a:prstGeom prst="rect">
-            <a:avLst/>
-          </a:prstGeom>
-          <a:noFill/>
-          <a:ln/>
-        </p:spPr>
-        <p:txBody>
-          <a:bodyPr wrap="square" lIns="0" tIns="0" rIns="0" bIns="0" rtlCol="0" anchor="t"/>
-          <a:lstStyle/>
           <a:p>
             <a:pPr algn="l" marL="127000" indent="-127000">
               <a:spcAft>
@@ -8862,10 +9035,71 @@
                 <a:ea typeface="Garamond" pitchFamily="34" charset="-122"/>
                 <a:cs typeface="Garamond" pitchFamily="34" charset="-120"/>
               </a:rPr>
-              <a:t>Confirm the quality of orders before committing production capital</a:t>
+              <a:t>Hundreds of successful operational deployments</a:t>
             </a:r>
             <a:endParaRPr lang="en-US" sz="1100" dirty="0"/>
           </a:p>
+        </p:txBody>
+      </p:sp>
+      <p:sp>
+        <p:nvSpPr>
+          <p:cNvPr id="16" name="Text 4"/>
+          <p:cNvSpPr/>
+          <p:nvPr/>
+        </p:nvSpPr>
+        <p:spPr>
+          <a:xfrm>
+            <a:off x="6190488" y="3977639"/>
+            <a:ext cx="5175504" cy="256032"/>
+          </a:xfrm>
+          <a:prstGeom prst="rect">
+            <a:avLst/>
+          </a:prstGeom>
+          <a:noFill/>
+          <a:ln/>
+        </p:spPr>
+        <p:txBody>
+          <a:bodyPr wrap="square" lIns="0" tIns="0" rIns="0" bIns="0" rtlCol="0" anchor="ctr"/>
+          <a:lstStyle/>
+          <a:p>
+            <a:pPr indent="0" marL="0">
+              <a:buNone/>
+            </a:pPr>
+            <a:r>
+              <a:rPr lang="en-US" sz="1350" b="1" dirty="0">
+                <a:solidFill>
+                  <a:srgbClr val="007BCB"/>
+                </a:solidFill>
+                <a:latin typeface="Garamond" pitchFamily="34" charset="0"/>
+                <a:ea typeface="Garamond" pitchFamily="34" charset="-122"/>
+                <a:cs typeface="Garamond" pitchFamily="34" charset="-120"/>
+              </a:rPr>
+              <a:t>How we sell to Chinese clients</a:t>
+            </a:r>
+            <a:endParaRPr lang="en-US" sz="1350" dirty="0"/>
+          </a:p>
+        </p:txBody>
+      </p:sp>
+      <p:sp>
+        <p:nvSpPr>
+          <p:cNvPr id="17" name="Text 13"/>
+          <p:cNvSpPr/>
+          <p:nvPr/>
+        </p:nvSpPr>
+        <p:spPr>
+          <a:xfrm>
+            <a:off x="6190488" y="4270248"/>
+            <a:ext cx="5175504" cy="1463040"/>
+          </a:xfrm>
+          <a:prstGeom prst="rect">
+            <a:avLst/>
+          </a:prstGeom>
+          <a:noFill/>
+          <a:ln/>
+        </p:spPr>
+        <p:txBody>
+          <a:bodyPr wrap="square" lIns="0" tIns="0" rIns="0" bIns="0" rtlCol="0" anchor="t"/>
+          <a:lstStyle/>
           <a:p>
             <a:pPr algn="l" marL="127000" indent="-127000">
               <a:spcAft>
@@ -8883,7 +9117,7 @@
                 <a:ea typeface="Garamond" pitchFamily="34" charset="-122"/>
                 <a:cs typeface="Garamond" pitchFamily="34" charset="-120"/>
               </a:rPr>
-              <a:t>Qualify suppliers and establish a dedicated supply chain in China</a:t>
+              <a:t>Offer qualified products and components through export orders</a:t>
             </a:r>
             <a:endParaRPr lang="en-US" sz="1100" dirty="0"/>
           </a:p>
@@ -8904,7 +9138,7 @@
                 <a:ea typeface="Garamond" pitchFamily="34" charset="-122"/>
                 <a:cs typeface="Garamond" pitchFamily="34" charset="-120"/>
               </a:rPr>
-              <a:t>Stand up large scale production capacity matched to confirmed demand</a:t>
+              <a:t>Let delivered flight hardware demonstrate reliability and value</a:t>
             </a:r>
             <a:endParaRPr lang="en-US" sz="1100" dirty="0"/>
           </a:p>
@@ -8925,107 +9159,20 @@
                 <a:ea typeface="Garamond" pitchFamily="34" charset="-122"/>
                 <a:cs typeface="Garamond" pitchFamily="34" charset="-120"/>
               </a:rPr>
-              <a:t>Serve the export order book at volume with consistent quality standards</a:t>
+              <a:t>Provide catalog pricing and published interfaces for fast procurement</a:t>
             </a:r>
             <a:endParaRPr lang="en-US" sz="1100" dirty="0"/>
           </a:p>
-        </p:txBody>
-      </p:sp>
-      <p:sp>
-        <p:nvSpPr>
-          <p:cNvPr id="12" name="Shape 20"/>
-          <p:cNvSpPr/>
-          <p:nvPr/>
-        </p:nvSpPr>
-        <p:spPr>
-          <a:xfrm>
-            <a:off x="822960" y="5074920"/>
-            <a:ext cx="10543032" cy="1188720"/>
-          </a:xfrm>
-          <a:prstGeom prst="roundRect">
-            <a:avLst>
-              <a:gd name="adj" fmla="val 3704"/>
-            </a:avLst>
-          </a:prstGeom>
-          <a:solidFill>
-            <a:srgbClr val="EDF3F8"/>
-          </a:solidFill>
-          <a:ln w="9525">
-            <a:solidFill>
-              <a:srgbClr val="C6D2DA"/>
-            </a:solidFill>
-            <a:prstDash val="solid"/>
-          </a:ln>
-        </p:spPr>
-      </p:sp>
-      <p:sp>
-        <p:nvSpPr>
-          <p:cNvPr id="13" name="Text 21"/>
-          <p:cNvSpPr/>
-          <p:nvPr/>
-        </p:nvSpPr>
-        <p:spPr>
-          <a:xfrm>
-            <a:off x="1005840" y="5184648"/>
-            <a:ext cx="3200400" cy="256032"/>
-          </a:xfrm>
-          <a:prstGeom prst="rect">
-            <a:avLst/>
-          </a:prstGeom>
-          <a:noFill/>
-          <a:ln/>
-        </p:spPr>
-        <p:txBody>
-          <a:bodyPr wrap="square" lIns="0" tIns="0" rIns="0" bIns="0" rtlCol="0" anchor="ctr"/>
-          <a:lstStyle/>
-          <a:p>
-            <a:pPr indent="0" marL="0">
-              <a:buNone/>
-            </a:pPr>
-            <a:r>
-              <a:rPr lang="en-US" sz="1250" b="1" dirty="0">
-                <a:solidFill>
-                  <a:srgbClr val="10222F"/>
-                </a:solidFill>
-                <a:latin typeface="Garamond" pitchFamily="34" charset="0"/>
-                <a:ea typeface="Garamond" pitchFamily="34" charset="-122"/>
-                <a:cs typeface="Garamond" pitchFamily="34" charset="-120"/>
-              </a:rPr>
-              <a:t>Gating discipline</a:t>
-            </a:r>
-            <a:endParaRPr lang="en-US" sz="1250" dirty="0"/>
-          </a:p>
-        </p:txBody>
-      </p:sp>
-      <p:sp>
-        <p:nvSpPr>
-          <p:cNvPr id="14" name="Text 22"/>
-          <p:cNvSpPr/>
-          <p:nvPr/>
-        </p:nvSpPr>
-        <p:spPr>
-          <a:xfrm>
-            <a:off x="1005840" y="5458968"/>
-            <a:ext cx="10149840" cy="731520"/>
-          </a:xfrm>
-          <a:prstGeom prst="rect">
-            <a:avLst/>
-          </a:prstGeom>
-          <a:noFill/>
-          <a:ln/>
-        </p:spPr>
-        <p:txBody>
-          <a:bodyPr wrap="square" lIns="0" tIns="0" rIns="0" bIns="0" rtlCol="0" anchor="t"/>
-          <a:lstStyle/>
-          <a:p>
-            <a:pPr indent="0" marL="0">
-              <a:lnSpc>
-                <a:spcPct val="102000"/>
-              </a:lnSpc>
-              <a:buNone/>
-            </a:pPr>
-            <a:r>
-              <a:rPr lang="en-US" sz="1050" dirty="0">
+          <a:p>
+            <a:pPr algn="l" marL="127000" indent="-127000">
+              <a:spcAft>
+                <a:spcPts val="400"/>
+              </a:spcAft>
+              <a:buSzPct val="100000"/>
+              <a:buChar char="•"/>
+            </a:pPr>
+            <a:r>
+              <a:rPr lang="en-US" sz="1100" dirty="0">
                 <a:solidFill>
                   <a:srgbClr val="1E2A33"/>
                 </a:solidFill>
@@ -9033,9 +9180,9 @@
                 <a:ea typeface="Garamond" pitchFamily="34" charset="-122"/>
                 <a:cs typeface="Garamond" pitchFamily="34" charset="-120"/>
               </a:rPr>
-              <a:t>The transition from Phase One to Phase Two proceeds only after the quality of orders has been confirmed. This sequencing limits capital at risk, ties production capacity to a proven order book, and preserves flexibility in how and where manufacturing scale is added.</a:t>
-            </a:r>
-            <a:endParaRPr lang="en-US" sz="1050" dirty="0"/>
+              <a:t>Scale a China based supply chain and production as order quality is confirmed</a:t>
+            </a:r>
+            <a:endParaRPr lang="en-US" sz="1100" dirty="0"/>
           </a:p>
         </p:txBody>
       </p:sp>

</xml_diff>

<commit_message>
Retarget deck to Chinese customers: new profile, stats, product lines, contact
Co-authored-by: anthonyleedu <anthonyleedu@users.noreply.github.com>
</commit_message>
<xml_diff>
--- a/Heliospace_Investor_Overview.pptx
+++ b/Heliospace_Investor_Overview.pptx
@@ -21,7 +21,6 @@
     <p:sldId id="269" r:id="rId15"/>
     <p:sldId id="272" r:id="rId23"/>
     <p:sldId id="273" r:id="rId24"/>
-    <p:sldId id="270" r:id="rId16"/>
     <p:sldId id="271" r:id="rId17"/>
   </p:sldIdLst>
   <p:notesMasterIdLst>
@@ -220,13 +219,13 @@
           </c:val>
         </c:ser>
         <c:dLbls>
-          <c:numFmt formatCode="&quot;$&quot;#,##0" sourceLinked="0"/>
+          <c:numFmt formatCode="#,##0" sourceLinked="0"/>
           <c:txPr>
             <a:bodyPr/>
             <a:lstStyle/>
             <a:p>
               <a:pPr>
-                <a:defRPr b="0" i="0" strike="noStrike" sz="1200" u="none">
+                <a:defRPr b="1" i="0" strike="noStrike" sz="1100" u="none">
                   <a:solidFill>
                     <a:srgbClr val="10222F"/>
                   </a:solidFill>
@@ -235,6 +234,7 @@
               </a:pPr>
             </a:p>
           </c:txPr>
+          <c:dLblPos val="outEnd"/>
           <c:showLegendKey val="0"/>
           <c:showVal val="1"/>
           <c:showCatName val="0"/>
@@ -295,248 +295,6 @@
         <c:scaling>
           <c:orientation val="minMax"/>
           <c:max val="2000"/>
-        </c:scaling>
-        <c:delete val="1"/>
-        <c:axPos val="l"/>
-        <c:numFmt formatCode="General" sourceLinked="0"/>
-        <c:majorTickMark val="out"/>
-        <c:minorTickMark val="none"/>
-        <c:tickLblPos val="nextTo"/>
-        <c:spPr>
-          <a:ln w="12700" cap="flat">
-            <a:solidFill>
-              <a:srgbClr val="888888"/>
-            </a:solidFill>
-            <a:prstDash val="solid"/>
-            <a:round/>
-          </a:ln>
-        </c:spPr>
-        <c:txPr>
-          <a:bodyPr/>
-          <a:lstStyle/>
-          <a:p>
-            <a:pPr>
-              <a:defRPr sz="1200" b="0" i="0" u="none" strike="noStrike">
-                <a:solidFill>
-                  <a:srgbClr val="000000"/>
-                </a:solidFill>
-                <a:latin typeface="Arial"/>
-              </a:defRPr>
-            </a:pPr>
-            <a:endParaRPr lang="en-US"/>
-          </a:p>
-        </c:txPr>
-        <c:crossAx val="2094734554"/>
-        <c:crosses val="autoZero"/>
-        <c:crossBetween val="between"/>
-      </c:valAx>
-      <c:spPr>
-        <a:noFill/>
-        <a:ln>
-          <a:noFill/>
-        </a:ln>
-        <a:effectLst/>
-      </c:spPr>
-    </c:plotArea>
-    <c:plotVisOnly val="1"/>
-    <c:dispBlanksAs val="span"/>
-  </c:chart>
-  <c:spPr>
-    <a:noFill/>
-    <a:ln>
-      <a:noFill/>
-    </a:ln>
-    <a:effectLst/>
-  </c:spPr>
-  <c:externalData r:id="rId1">
-    <c:autoUpdate val="0"/>
-  </c:externalData>
-</c:chartSpace>
-</file>
-
-<file path=ppt/charts/chart2.xml><?xml version="1.0" encoding="utf-8"?>
-<c:chartSpace xmlns:c="http://schemas.openxmlformats.org/drawingml/2006/chart" xmlns:a="http://schemas.openxmlformats.org/drawingml/2006/main" xmlns:r="http://schemas.openxmlformats.org/officeDocument/2006/relationships">
-  <c:date1904 val="0"/>
-  <c:roundedCorners val="1"/>
-  <c:chart>
-    <c:autoTitleDeleted val="1"/>
-    <c:plotArea>
-      <c:layout/>
-      <c:barChart>
-        <c:barDir val="col"/>
-        <c:grouping val="clustered"/>
-        <c:varyColors val="0"/>
-        <c:ser>
-          <c:idx val="0"/>
-          <c:order val="0"/>
-          <c:tx>
-            <c:strRef>
-              <c:f>Sheet1!$B$1</c:f>
-              <c:strCache>
-                <c:ptCount val="1"/>
-                <c:pt idx="0">
-                  <c:v>Revenue</c:v>
-                </c:pt>
-              </c:strCache>
-            </c:strRef>
-          </c:tx>
-          <c:spPr>
-            <a:solidFill>
-              <a:srgbClr val="007BCB"/>
-            </a:solidFill>
-            <a:effectLst/>
-          </c:spPr>
-          <c:invertIfNegative val="0"/>
-          <c:dLbls>
-            <c:numFmt formatCode="&quot;$&quot;0&quot;M&quot;" sourceLinked="0"/>
-            <c:txPr>
-              <a:bodyPr/>
-              <a:lstStyle/>
-              <a:p>
-                <a:pPr>
-                  <a:defRPr b="0" i="0" strike="noStrike" sz="1150" u="none">
-                    <a:solidFill>
-                      <a:srgbClr val="10222F"/>
-                    </a:solidFill>
-                    <a:latin typeface="Garamond"/>
-                  </a:defRPr>
-                </a:pPr>
-              </a:p>
-            </c:txPr>
-            <c:showLegendKey val="0"/>
-            <c:showVal val="1"/>
-            <c:showCatName val="0"/>
-            <c:showSerName val="0"/>
-            <c:showPercent val="0"/>
-            <c:showBubbleSize val="0"/>
-            <c:showLeaderLines val="0"/>
-          </c:dLbls>
-          <c:cat>
-            <c:multiLvlStrRef>
-              <c:f>Sheet1!$A$2:$A$6</c:f>
-              <c:multiLvlStrCache>
-                <c:ptCount val="5"/>
-                <c:lvl>
-                  <c:pt idx="0">
-                    <c:v>FY26</c:v>
-                  </c:pt>
-                  <c:pt idx="1">
-                    <c:v>FY27</c:v>
-                  </c:pt>
-                  <c:pt idx="2">
-                    <c:v>FY28</c:v>
-                  </c:pt>
-                  <c:pt idx="3">
-                    <c:v>FY29</c:v>
-                  </c:pt>
-                  <c:pt idx="4">
-                    <c:v>FY30</c:v>
-                  </c:pt>
-                </c:lvl>
-              </c:multiLvlStrCache>
-            </c:multiLvlStrRef>
-          </c:cat>
-          <c:val>
-            <c:numRef>
-              <c:f>Sheet1!$B$2:$B$6</c:f>
-              <c:numCache>
-                <c:formatCode>General</c:formatCode>
-                <c:ptCount val="5"/>
-                <c:pt idx="0">
-                  <c:v>9</c:v>
-                </c:pt>
-                <c:pt idx="1">
-                  <c:v>14</c:v>
-                </c:pt>
-                <c:pt idx="2">
-                  <c:v>22</c:v>
-                </c:pt>
-                <c:pt idx="3">
-                  <c:v>32</c:v>
-                </c:pt>
-                <c:pt idx="4">
-                  <c:v>45</c:v>
-                </c:pt>
-              </c:numCache>
-            </c:numRef>
-          </c:val>
-        </c:ser>
-        <c:dLbls>
-          <c:numFmt formatCode="&quot;$&quot;0&quot;M&quot;" sourceLinked="0"/>
-          <c:txPr>
-            <a:bodyPr/>
-            <a:lstStyle/>
-            <a:p>
-              <a:pPr>
-                <a:defRPr b="0" i="0" strike="noStrike" sz="1150" u="none">
-                  <a:solidFill>
-                    <a:srgbClr val="10222F"/>
-                  </a:solidFill>
-                  <a:latin typeface="Garamond"/>
-                </a:defRPr>
-              </a:pPr>
-            </a:p>
-          </c:txPr>
-          <c:showLegendKey val="0"/>
-          <c:showVal val="1"/>
-          <c:showCatName val="0"/>
-          <c:showSerName val="0"/>
-          <c:showPercent val="0"/>
-          <c:showBubbleSize val="0"/>
-          <c:showLeaderLines val="0"/>
-        </c:dLbls>
-        <c:gapWidth val="45"/>
-        <c:overlap val="0"/>
-        <c:axId val="2094734554"/>
-        <c:axId val="2094734552"/>
-        <c:axId val="2094734556"/>
-      </c:barChart>
-      <c:catAx>
-        <c:axId val="2094734554"/>
-        <c:scaling>
-          <c:orientation val="minMax"/>
-        </c:scaling>
-        <c:delete val="0"/>
-        <c:axPos val="b"/>
-        <c:numFmt formatCode="General" sourceLinked="1"/>
-        <c:majorTickMark val="out"/>
-        <c:minorTickMark val="none"/>
-        <c:tickLblPos val="low"/>
-        <c:spPr>
-          <a:ln w="12700" cap="flat">
-            <a:solidFill>
-              <a:srgbClr val="888888"/>
-            </a:solidFill>
-            <a:prstDash val="solid"/>
-            <a:round/>
-          </a:ln>
-        </c:spPr>
-        <c:txPr>
-          <a:bodyPr/>
-          <a:lstStyle/>
-          <a:p>
-            <a:pPr>
-              <a:defRPr sz="1150" b="0" i="0" u="none" strike="noStrike">
-                <a:solidFill>
-                  <a:srgbClr val="5C6B76"/>
-                </a:solidFill>
-                <a:latin typeface="Garamond"/>
-              </a:defRPr>
-            </a:pPr>
-            <a:endParaRPr lang="en-US"/>
-          </a:p>
-        </c:txPr>
-        <c:crossAx val="2094734552"/>
-        <c:crosses val="autoZero"/>
-        <c:auto val="1"/>
-        <c:lblAlgn val="ctr"/>
-        <c:noMultiLvlLbl val="1"/>
-      </c:catAx>
-      <c:valAx>
-        <c:axId val="2094734552"/>
-        <c:scaling>
-          <c:orientation val="minMax"/>
-          <c:max val="50"/>
         </c:scaling>
         <c:delete val="1"/>
         <c:axPos val="l"/>
@@ -1455,94 +1213,6 @@
             <a:fld id="{F7021451-1387-4CA6-816F-3879F97B5CBC}" type="slidenum">
               <a:rPr lang="en-US"/>
               <a:t>14</a:t>
-            </a:fld>
-            <a:endParaRPr lang="en-US"/>
-          </a:p>
-        </p:txBody>
-      </p:sp>
-    </p:spTree>
-    <p:extLst>
-      <p:ext uri="{BB962C8B-B14F-4D97-AF65-F5344CB8AC3E}">
-        <p14:creationId xmlns:p14="http://schemas.microsoft.com/office/powerpoint/2010/main" val="1024086991"/>
-      </p:ext>
-    </p:extLst>
-  </p:cSld>
-  <p:clrMapOvr>
-    <a:masterClrMapping/>
-  </p:clrMapOvr>
-</p:notes>
-</file>
-
-<file path=ppt/notesSlides/notesSlide15.xml><?xml version="1.0" encoding="utf-8"?>
-<p:notes xmlns:a="http://schemas.openxmlformats.org/drawingml/2006/main" xmlns:r="http://schemas.openxmlformats.org/officeDocument/2006/relationships" xmlns:p="http://schemas.openxmlformats.org/presentationml/2006/main">
-  <p:cSld>
-    <p:spTree>
-      <p:nvGrpSpPr>
-        <p:cNvPr id="1" name=""/>
-        <p:cNvGrpSpPr/>
-        <p:nvPr/>
-      </p:nvGrpSpPr>
-      <p:grpSpPr>
-        <a:xfrm>
-          <a:off x="0" y="0"/>
-          <a:ext cx="0" cy="0"/>
-          <a:chOff x="0" y="0"/>
-          <a:chExt cx="0" cy="0"/>
-        </a:xfrm>
-      </p:grpSpPr>
-      <p:sp>
-        <p:nvSpPr>
-          <p:cNvPr id="2" name="Slide Image Placeholder 1"/>
-          <p:cNvSpPr>
-            <a:spLocks noGrp="1" noRot="1" noChangeAspect="1"/>
-          </p:cNvSpPr>
-          <p:nvPr>
-            <p:ph type="sldImg"/>
-          </p:nvPr>
-        </p:nvSpPr>
-        <p:spPr/>
-      </p:sp>
-      <p:sp>
-        <p:nvSpPr>
-          <p:cNvPr id="3" name="Notes Placeholder 2"/>
-          <p:cNvSpPr>
-            <a:spLocks noGrp="1"/>
-          </p:cNvSpPr>
-          <p:nvPr>
-            <p:ph type="body" idx="1"/>
-          </p:nvPr>
-        </p:nvSpPr>
-        <p:spPr/>
-        <p:txBody>
-          <a:bodyPr/>
-          <a:lstStyle/>
-          <a:p>
-            <a:r>
-              <a:rPr lang="en-US" dirty="0"/>
-              <a:t/>
-            </a:r>
-            <a:endParaRPr lang="en-US" dirty="0"/>
-          </a:p>
-        </p:txBody>
-      </p:sp>
-      <p:sp>
-        <p:nvSpPr>
-          <p:cNvPr id="4" name="Slide Number Placeholder 3"/>
-          <p:cNvSpPr>
-            <a:spLocks noGrp="1"/>
-          </p:cNvSpPr>
-          <p:nvPr>
-            <p:ph type="sldNum" sz="quarter" idx="10"/>
-          </p:nvPr>
-        </p:nvSpPr>
-        <p:spPr/>
-        <p:txBody>
-          <a:bodyPr/>
-          <a:lstStyle/>
-          <a:p>
-            <a:fld id="{F7021451-1387-4CA6-816F-3879F97B5CBC}" type="slidenum">
-              <a:rPr lang="en-US"/>
-              <a:t>15</a:t>
             </a:fld>
             <a:endParaRPr lang="en-US"/>
           </a:p>
@@ -2758,7 +2428,7 @@
                 <a:ea typeface="Garamond" pitchFamily="34" charset="-122"/>
                 <a:cs typeface="Garamond" pitchFamily="34" charset="-120"/>
               </a:rPr>
-              <a:t>INVESTOR OVERVIEW</a:t>
+              <a:t>COMPANY &amp; PRODUCT PRESENTATION</a:t>
             </a:r>
             <a:endParaRPr lang="en-US" sz="1200" dirty="0"/>
           </a:p>
@@ -3177,6 +2847,10 @@
             <a:prstDash val="solid"/>
           </a:ln>
         </p:spPr>
+        <p:txBody>
+          <a:bodyPr/>
+          <a:p/>
+        </p:txBody>
       </p:sp>
       <p:pic>
         <p:nvPicPr>
@@ -3223,6 +2897,10 @@
             <a:prstDash val="solid"/>
           </a:ln>
         </p:spPr>
+        <p:txBody>
+          <a:bodyPr/>
+          <a:p/>
+        </p:txBody>
       </p:sp>
       <p:sp>
         <p:nvSpPr>
@@ -3308,6 +2986,10 @@
             <a:prstDash val="solid"/>
           </a:ln>
         </p:spPr>
+        <p:txBody>
+          <a:bodyPr/>
+          <a:p/>
+        </p:txBody>
       </p:sp>
       <p:sp>
         <p:nvSpPr>
@@ -3393,6 +3075,10 @@
             <a:prstDash val="solid"/>
           </a:ln>
         </p:spPr>
+        <p:txBody>
+          <a:bodyPr/>
+          <a:p/>
+        </p:txBody>
       </p:sp>
       <p:sp>
         <p:nvSpPr>
@@ -3556,6 +3242,10 @@
             <a:prstDash val="solid"/>
           </a:ln>
         </p:spPr>
+        <p:txBody>
+          <a:bodyPr/>
+          <a:p/>
+        </p:txBody>
       </p:sp>
       <p:sp>
         <p:nvSpPr>
@@ -3578,6 +3268,10 @@
           </a:solidFill>
           <a:ln/>
         </p:spPr>
+        <p:txBody>
+          <a:bodyPr/>
+          <a:p/>
+        </p:txBody>
       </p:sp>
       <p:sp>
         <p:nvSpPr>
@@ -3915,7 +3609,7 @@
                 <a:ea typeface="Garamond" pitchFamily="34" charset="-122"/>
                 <a:cs typeface="Garamond" pitchFamily="34" charset="-120"/>
               </a:rPr>
-              <a:t>Global space economy, USD billions</a:t>
+              <a:t>Global space economy: forecast to reach $1.8 trillion by 2035 (USD billions)</a:t>
             </a:r>
             <a:endParaRPr lang="en-US" sz="1300" dirty="0"/>
           </a:p>
@@ -4436,7 +4130,7 @@
         </p:nvSpPr>
         <p:spPr>
           <a:xfrm>
-            <a:off x="822960" y="1508760"/>
+            <a:off x="822960" y="1444752"/>
             <a:ext cx="347472" cy="347472"/>
           </a:xfrm>
           <a:prstGeom prst="ellipse">
@@ -4447,6 +4141,10 @@
           </a:solidFill>
           <a:ln/>
         </p:spPr>
+        <p:txBody>
+          <a:bodyPr/>
+          <a:p/>
+        </p:txBody>
       </p:sp>
       <p:sp>
         <p:nvSpPr>
@@ -4456,7 +4154,7 @@
         </p:nvSpPr>
         <p:spPr>
           <a:xfrm>
-            <a:off x="822960" y="1508760"/>
+            <a:off x="822960" y="1444752"/>
             <a:ext cx="347472" cy="347472"/>
           </a:xfrm>
           <a:prstGeom prst="rect">
@@ -4495,7 +4193,7 @@
         </p:nvSpPr>
         <p:spPr>
           <a:xfrm>
-            <a:off x="1325880" y="1481328"/>
+            <a:off x="1325880" y="1417320"/>
             <a:ext cx="5120640" cy="274320"/>
           </a:xfrm>
           <a:prstGeom prst="rect">
@@ -4520,7 +4218,7 @@
                 <a:ea typeface="Garamond" pitchFamily="34" charset="-122"/>
                 <a:cs typeface="Garamond" pitchFamily="34" charset="-120"/>
               </a:rPr>
-              <a:t>Flight proven heritage</a:t>
+              <a:t>Proven space heritage</a:t>
             </a:r>
             <a:endParaRPr lang="en-US" sz="1450" dirty="0"/>
           </a:p>
@@ -4534,8 +4232,8 @@
         </p:nvSpPr>
         <p:spPr>
           <a:xfrm>
-            <a:off x="1325880" y="1764792"/>
-            <a:ext cx="5166360" cy="868680"/>
+            <a:off x="1325880" y="1728216"/>
+            <a:ext cx="5166360" cy="658368"/>
           </a:xfrm>
           <a:prstGeom prst="rect">
             <a:avLst/>
@@ -4562,7 +4260,7 @@
                 <a:ea typeface="Garamond" pitchFamily="34" charset="-122"/>
                 <a:cs typeface="Garamond" pitchFamily="34" charset="-120"/>
               </a:rPr>
-              <a:t>Hardware operating today across the solar system, with a qualification pedigree that new entrants cannot shortcut.</a:t>
+              <a:t>More than 40 space flight missions and more than 125 instruments and systems built and deployed, including hardware on NASA's Europa Clipper and support for the James Webb Space Telescope.</a:t>
             </a:r>
             <a:endParaRPr lang="en-US" sz="1100" dirty="0"/>
           </a:p>
@@ -4576,7 +4274,7 @@
         </p:nvSpPr>
         <p:spPr>
           <a:xfrm>
-            <a:off x="822960" y="2715768"/>
+            <a:off x="822960" y="2414016"/>
             <a:ext cx="347472" cy="347472"/>
           </a:xfrm>
           <a:prstGeom prst="ellipse">
@@ -4587,6 +4285,10 @@
           </a:solidFill>
           <a:ln/>
         </p:spPr>
+        <p:txBody>
+          <a:bodyPr/>
+          <a:p/>
+        </p:txBody>
       </p:sp>
       <p:sp>
         <p:nvSpPr>
@@ -4596,7 +4298,7 @@
         </p:nvSpPr>
         <p:spPr>
           <a:xfrm>
-            <a:off x="822960" y="2715768"/>
+            <a:off x="822960" y="2414016"/>
             <a:ext cx="347472" cy="347472"/>
           </a:xfrm>
           <a:prstGeom prst="rect">
@@ -4635,7 +4337,7 @@
         </p:nvSpPr>
         <p:spPr>
           <a:xfrm>
-            <a:off x="1325880" y="2688336"/>
+            <a:off x="1325880" y="2386584"/>
             <a:ext cx="5120640" cy="274320"/>
           </a:xfrm>
           <a:prstGeom prst="rect">
@@ -4660,7 +4362,7 @@
                 <a:ea typeface="Garamond" pitchFamily="34" charset="-122"/>
                 <a:cs typeface="Garamond" pitchFamily="34" charset="-120"/>
               </a:rPr>
-              <a:t>Vertical integration</a:t>
+              <a:t>Specialized engineering expertise</a:t>
             </a:r>
             <a:endParaRPr lang="en-US" sz="1450" dirty="0"/>
           </a:p>
@@ -4674,8 +4376,8 @@
         </p:nvSpPr>
         <p:spPr>
           <a:xfrm>
-            <a:off x="1325880" y="2971800"/>
-            <a:ext cx="5166360" cy="868680"/>
+            <a:off x="1325880" y="2697480"/>
+            <a:ext cx="5166360" cy="658368"/>
           </a:xfrm>
           <a:prstGeom prst="rect">
             <a:avLst/>
@@ -4702,7 +4404,7 @@
                 <a:ea typeface="Garamond" pitchFamily="34" charset="-122"/>
                 <a:cs typeface="Garamond" pitchFamily="34" charset="-120"/>
               </a:rPr>
-              <a:t>A NASA SBIR funded, in house boom forming capability removes sole source supplier risk, cuts tooling lead times from months to days, and enables geometries competitors cannot produce.</a:t>
+              <a:t>Custom deployable antennas, sensors, large deployable structures, spacecraft mechanisms, and systems engineering, built to work reliably in extreme conditions where repair is impossible.</a:t>
             </a:r>
             <a:endParaRPr lang="en-US" sz="1100" dirty="0"/>
           </a:p>
@@ -4716,7 +4418,7 @@
         </p:nvSpPr>
         <p:spPr>
           <a:xfrm>
-            <a:off x="822960" y="3922776"/>
+            <a:off x="822960" y="3383280"/>
             <a:ext cx="347472" cy="347472"/>
           </a:xfrm>
           <a:prstGeom prst="ellipse">
@@ -4727,6 +4429,10 @@
           </a:solidFill>
           <a:ln/>
         </p:spPr>
+        <p:txBody>
+          <a:bodyPr/>
+          <a:p/>
+        </p:txBody>
       </p:sp>
       <p:sp>
         <p:nvSpPr>
@@ -4736,7 +4442,7 @@
         </p:nvSpPr>
         <p:spPr>
           <a:xfrm>
-            <a:off x="822960" y="3922776"/>
+            <a:off x="822960" y="3383280"/>
             <a:ext cx="347472" cy="347472"/>
           </a:xfrm>
           <a:prstGeom prst="rect">
@@ -4775,7 +4481,7 @@
         </p:nvSpPr>
         <p:spPr>
           <a:xfrm>
-            <a:off x="1325880" y="3895344"/>
+            <a:off x="1325880" y="3355848"/>
             <a:ext cx="5120640" cy="274320"/>
           </a:xfrm>
           <a:prstGeom prst="rect">
@@ -4800,7 +4506,7 @@
                 <a:ea typeface="Garamond" pitchFamily="34" charset="-122"/>
                 <a:cs typeface="Garamond" pitchFamily="34" charset="-120"/>
               </a:rPr>
-              <a:t>Speed and cost</a:t>
+              <a:t>Lower mission risk</a:t>
             </a:r>
             <a:endParaRPr lang="en-US" sz="1450" dirty="0"/>
           </a:p>
@@ -4814,8 +4520,8 @@
         </p:nvSpPr>
         <p:spPr>
           <a:xfrm>
-            <a:off x="1325880" y="4178808"/>
-            <a:ext cx="5166360" cy="868680"/>
+            <a:off x="1325880" y="3666744"/>
+            <a:ext cx="5166360" cy="658368"/>
           </a:xfrm>
           <a:prstGeom prst="rect">
             <a:avLst/>
@@ -4842,7 +4548,7 @@
                 <a:ea typeface="Garamond" pitchFamily="34" charset="-122"/>
                 <a:cs typeface="Garamond" pitchFamily="34" charset="-120"/>
               </a:rPr>
-              <a:t>Lean development on purchase order and time and materials contracts, with record time deliveries for launch critical lunar payloads.</a:t>
+              <a:t>A record of successful missions and a problem solver approach to difficult hardware challenges reduce technical risk where failure is extremely expensive.</a:t>
             </a:r>
             <a:endParaRPr lang="en-US" sz="1100" dirty="0"/>
           </a:p>
@@ -4856,7 +4562,7 @@
         </p:nvSpPr>
         <p:spPr>
           <a:xfrm>
-            <a:off x="822960" y="5129784"/>
+            <a:off x="822960" y="4352544"/>
             <a:ext cx="347472" cy="347472"/>
           </a:xfrm>
           <a:prstGeom prst="ellipse">
@@ -4867,6 +4573,10 @@
           </a:solidFill>
           <a:ln/>
         </p:spPr>
+        <p:txBody>
+          <a:bodyPr/>
+          <a:p/>
+        </p:txBody>
       </p:sp>
       <p:sp>
         <p:nvSpPr>
@@ -4876,7 +4586,7 @@
         </p:nvSpPr>
         <p:spPr>
           <a:xfrm>
-            <a:off x="822960" y="5129784"/>
+            <a:off x="822960" y="4352544"/>
             <a:ext cx="347472" cy="347472"/>
           </a:xfrm>
           <a:prstGeom prst="rect">
@@ -4915,7 +4625,7 @@
         </p:nvSpPr>
         <p:spPr>
           <a:xfrm>
-            <a:off x="1325880" y="5102352"/>
+            <a:off x="1325880" y="4325112"/>
             <a:ext cx="5120640" cy="274320"/>
           </a:xfrm>
           <a:prstGeom prst="rect">
@@ -4940,7 +4650,7 @@
                 <a:ea typeface="Garamond" pitchFamily="34" charset="-122"/>
                 <a:cs typeface="Garamond" pitchFamily="34" charset="-120"/>
               </a:rPr>
-              <a:t>Performance edge</a:t>
+              <a:t>Innovation and future technology</a:t>
             </a:r>
             <a:endParaRPr lang="en-US" sz="1450" dirty="0"/>
           </a:p>
@@ -4954,8 +4664,8 @@
         </p:nvSpPr>
         <p:spPr>
           <a:xfrm>
-            <a:off x="1325880" y="5385816"/>
-            <a:ext cx="5166360" cy="868680"/>
+            <a:off x="1325880" y="4636008"/>
+            <a:ext cx="5166360" cy="658368"/>
           </a:xfrm>
           <a:prstGeom prst="rect">
             <a:avLst/>
@@ -4982,7 +4692,7 @@
                 <a:ea typeface="Garamond" pitchFamily="34" charset="-122"/>
                 <a:cs typeface="Garamond" pitchFamily="34" charset="-120"/>
               </a:rPr>
-              <a:t>Wider thermal range, redundant non explosive release, and stowage ratios of up to 50:1.</a:t>
+              <a:t>Development of space based solar power systems designed to collect solar energy in orbit and transmit power to Earth, a pathway toward next generation space infrastructure.</a:t>
             </a:r>
             <a:endParaRPr lang="en-US" sz="1100" dirty="0"/>
           </a:p>
@@ -6116,6 +5826,150 @@
           </a:p>
         </p:txBody>
       </p:sp>
+      <p:sp>
+        <p:nvSpPr>
+          <p:cNvPr id="26" name="Shape 4"/>
+          <p:cNvSpPr/>
+          <p:nvPr/>
+        </p:nvSpPr>
+        <p:spPr>
+          <a:xfrm>
+            <a:off x="822960" y="5321808"/>
+            <a:ext cx="347472" cy="347472"/>
+          </a:xfrm>
+          <a:prstGeom prst="ellipse">
+            <a:avLst/>
+          </a:prstGeom>
+          <a:solidFill>
+            <a:srgbClr val="007BCB"/>
+          </a:solidFill>
+          <a:ln/>
+        </p:spPr>
+        <p:txBody>
+          <a:bodyPr/>
+          <a:p/>
+        </p:txBody>
+      </p:sp>
+      <p:sp>
+        <p:nvSpPr>
+          <p:cNvPr id="27" name="Text 5"/>
+          <p:cNvSpPr/>
+          <p:nvPr/>
+        </p:nvSpPr>
+        <p:spPr>
+          <a:xfrm>
+            <a:off x="822960" y="5321808"/>
+            <a:ext cx="347472" cy="347472"/>
+          </a:xfrm>
+          <a:prstGeom prst="rect">
+            <a:avLst/>
+          </a:prstGeom>
+          <a:noFill/>
+          <a:ln/>
+        </p:spPr>
+        <p:txBody>
+          <a:bodyPr wrap="square" lIns="0" tIns="0" rIns="0" bIns="0" rtlCol="0" anchor="ctr"/>
+          <a:lstStyle/>
+          <a:p>
+            <a:pPr algn="ctr" indent="0" marL="0">
+              <a:buNone/>
+            </a:pPr>
+            <a:r>
+              <a:rPr lang="en-US" sz="1400" b="1" dirty="0">
+                <a:solidFill>
+                  <a:srgbClr val="FFFFFF"/>
+                </a:solidFill>
+                <a:latin typeface="Garamond" pitchFamily="34" charset="0"/>
+                <a:ea typeface="Garamond" pitchFamily="34" charset="-122"/>
+                <a:cs typeface="Garamond" pitchFamily="34" charset="-120"/>
+              </a:rPr>
+              <a:t>5</a:t>
+            </a:r>
+            <a:endParaRPr lang="en-US" sz="1400" dirty="0"/>
+          </a:p>
+        </p:txBody>
+      </p:sp>
+      <p:sp>
+        <p:nvSpPr>
+          <p:cNvPr id="28" name="Text 6"/>
+          <p:cNvSpPr/>
+          <p:nvPr/>
+        </p:nvSpPr>
+        <p:spPr>
+          <a:xfrm>
+            <a:off x="1325880" y="5294376"/>
+            <a:ext cx="5120640" cy="274320"/>
+          </a:xfrm>
+          <a:prstGeom prst="rect">
+            <a:avLst/>
+          </a:prstGeom>
+          <a:noFill/>
+          <a:ln/>
+        </p:spPr>
+        <p:txBody>
+          <a:bodyPr wrap="square" lIns="0" tIns="0" rIns="0" bIns="0" rtlCol="0" anchor="ctr"/>
+          <a:lstStyle/>
+          <a:p>
+            <a:pPr indent="0" marL="0">
+              <a:buNone/>
+            </a:pPr>
+            <a:r>
+              <a:rPr lang="en-US" sz="1450" b="1" dirty="0">
+                <a:solidFill>
+                  <a:srgbClr val="10222F"/>
+                </a:solidFill>
+                <a:latin typeface="Garamond" pitchFamily="34" charset="0"/>
+                <a:ea typeface="Garamond" pitchFamily="34" charset="-122"/>
+                <a:cs typeface="Garamond" pitchFamily="34" charset="-120"/>
+              </a:rPr>
+              <a:t>A flexible partner</a:t>
+            </a:r>
+            <a:endParaRPr lang="en-US" sz="1450" dirty="0"/>
+          </a:p>
+        </p:txBody>
+      </p:sp>
+      <p:sp>
+        <p:nvSpPr>
+          <p:cNvPr id="29" name="Text 7"/>
+          <p:cNvSpPr/>
+          <p:nvPr/>
+        </p:nvSpPr>
+        <p:spPr>
+          <a:xfrm>
+            <a:off x="1325880" y="5605272"/>
+            <a:ext cx="5166360" cy="658368"/>
+          </a:xfrm>
+          <a:prstGeom prst="rect">
+            <a:avLst/>
+          </a:prstGeom>
+          <a:noFill/>
+          <a:ln/>
+        </p:spPr>
+        <p:txBody>
+          <a:bodyPr wrap="square" lIns="0" tIns="0" rIns="0" bIns="0" rtlCol="0" anchor="t"/>
+          <a:lstStyle/>
+          <a:p>
+            <a:pPr indent="0" marL="0">
+              <a:lnSpc>
+                <a:spcPct val="103000"/>
+              </a:lnSpc>
+              <a:buNone/>
+            </a:pPr>
+            <a:r>
+              <a:rPr lang="en-US" sz="1100" dirty="0">
+                <a:solidFill>
+                  <a:srgbClr val="1E2A33"/>
+                </a:solidFill>
+                <a:latin typeface="Garamond" pitchFamily="34" charset="0"/>
+                <a:ea typeface="Garamond" pitchFamily="34" charset="-122"/>
+                <a:cs typeface="Garamond" pitchFamily="34" charset="-120"/>
+              </a:rPr>
+              <a:t>Customized systems rather than only standardized products, for government agencies, private aerospace companies, universities, and research organizations.</a:t>
+            </a:r>
+            <a:endParaRPr lang="en-US" sz="1100" dirty="0"/>
+          </a:p>
+        </p:txBody>
+      </p:sp>
     </p:spTree>
   </p:cSld>
   <p:clrMapOvr>
@@ -6809,6 +6663,10 @@
             <a:prstDash val="solid"/>
           </a:ln>
         </p:spPr>
+        <p:txBody>
+          <a:bodyPr/>
+          <a:p/>
+        </p:txBody>
       </p:sp>
       <p:sp>
         <p:nvSpPr>
@@ -6870,6 +6728,10 @@
           </a:solidFill>
           <a:ln/>
         </p:spPr>
+        <p:txBody>
+          <a:bodyPr/>
+          <a:p/>
+        </p:txBody>
       </p:sp>
       <p:sp>
         <p:nvSpPr>
@@ -7182,6 +7044,10 @@
           </a:solidFill>
           <a:ln/>
         </p:spPr>
+        <p:txBody>
+          <a:bodyPr/>
+          <a:p/>
+        </p:txBody>
       </p:sp>
       <p:sp>
         <p:nvSpPr>
@@ -7202,6 +7068,10 @@
           </a:solidFill>
           <a:ln/>
         </p:spPr>
+        <p:txBody>
+          <a:bodyPr/>
+          <a:p/>
+        </p:txBody>
       </p:sp>
       <p:sp>
         <p:nvSpPr>
@@ -7344,6 +7214,10 @@
           </a:solidFill>
           <a:ln/>
         </p:spPr>
+        <p:txBody>
+          <a:bodyPr/>
+          <a:p/>
+        </p:txBody>
       </p:sp>
       <p:sp>
         <p:nvSpPr>
@@ -7364,6 +7238,10 @@
           </a:solidFill>
           <a:ln/>
         </p:spPr>
+        <p:txBody>
+          <a:bodyPr/>
+          <a:p/>
+        </p:txBody>
       </p:sp>
       <p:sp>
         <p:nvSpPr>
@@ -7506,6 +7384,10 @@
           </a:solidFill>
           <a:ln/>
         </p:spPr>
+        <p:txBody>
+          <a:bodyPr/>
+          <a:p/>
+        </p:txBody>
       </p:sp>
       <p:sp>
         <p:nvSpPr>
@@ -7526,6 +7408,10 @@
           </a:solidFill>
           <a:ln/>
         </p:spPr>
+        <p:txBody>
+          <a:bodyPr/>
+          <a:p/>
+        </p:txBody>
       </p:sp>
       <p:sp>
         <p:nvSpPr>
@@ -7692,6 +7578,10 @@
             <a:prstDash val="solid"/>
           </a:ln>
         </p:spPr>
+        <p:txBody>
+          <a:bodyPr/>
+          <a:p/>
+        </p:txBody>
       </p:sp>
       <p:sp>
         <p:nvSpPr>
@@ -7719,6 +7609,10 @@
             <a:prstDash val="solid"/>
           </a:ln>
         </p:spPr>
+        <p:txBody>
+          <a:bodyPr/>
+          <a:p/>
+        </p:txBody>
       </p:sp>
       <p:sp>
         <p:nvSpPr>
@@ -7795,7 +7689,7 @@
                 <a:ea typeface="Garamond" pitchFamily="34" charset="-122"/>
                 <a:cs typeface="Garamond" pitchFamily="34" charset="-120"/>
               </a:rPr>
-              <a:t>Heliospace hardware and technical data are subject to US export controls under ITAR and the EAR. All international business is pursued only under required US Government authorizations, supported by an internal export compliance program. Markets subject to US arms embargoes, including China, are outside the company's addressable strategy.</a:t>
+              <a:t>Heliospace hardware and technical data are subject to US export controls under ITAR and the EAR. All international business is pursued only under required US Government authorizations, supported by an internal export compliance program.</a:t>
             </a:r>
             <a:endParaRPr lang="en-US" sz="1050" dirty="0"/>
           </a:p>
@@ -8059,6 +7953,10 @@
           </a:solidFill>
           <a:ln/>
         </p:spPr>
+        <p:txBody>
+          <a:bodyPr/>
+          <a:p/>
+        </p:txBody>
       </p:sp>
       <p:sp>
         <p:nvSpPr>
@@ -8079,6 +7977,10 @@
           </a:solidFill>
           <a:ln/>
         </p:spPr>
+        <p:txBody>
+          <a:bodyPr/>
+          <a:p/>
+        </p:txBody>
       </p:sp>
       <p:sp>
         <p:nvSpPr>
@@ -8221,6 +8123,10 @@
           </a:solidFill>
           <a:ln/>
         </p:spPr>
+        <p:txBody>
+          <a:bodyPr/>
+          <a:p/>
+        </p:txBody>
       </p:sp>
       <p:sp>
         <p:nvSpPr>
@@ -8241,6 +8147,10 @@
           </a:solidFill>
           <a:ln/>
         </p:spPr>
+        <p:txBody>
+          <a:bodyPr/>
+          <a:p/>
+        </p:txBody>
       </p:sp>
       <p:sp>
         <p:nvSpPr>
@@ -9183,626 +9093,6 @@
               <a:t>Scale a China based supply chain and production as order quality is confirmed</a:t>
             </a:r>
             <a:endParaRPr lang="en-US" sz="1100" dirty="0"/>
-          </a:p>
-        </p:txBody>
-      </p:sp>
-    </p:spTree>
-  </p:cSld>
-  <p:clrMapOvr>
-    <a:masterClrMapping/>
-  </p:clrMapOvr>
-</p:sld>
-</file>
-
-<file path=ppt/slides/slide17.xml><?xml version="1.0" encoding="utf-8"?>
-<p:sld xmlns:a="http://schemas.openxmlformats.org/drawingml/2006/main" xmlns:r="http://schemas.openxmlformats.org/officeDocument/2006/relationships" xmlns:p="http://schemas.openxmlformats.org/presentationml/2006/main">
-  <p:cSld name="Slide 15">
-    <p:bg>
-      <p:bgPr>
-        <a:solidFill>
-          <a:srgbClr val="FFFFFF"/>
-        </a:solidFill>
-      </p:bgPr>
-    </p:bg>
-    <p:spTree>
-      <p:nvGrpSpPr>
-        <p:cNvPr id="1" name=""/>
-        <p:cNvGrpSpPr/>
-        <p:nvPr/>
-      </p:nvGrpSpPr>
-      <p:grpSpPr>
-        <a:xfrm>
-          <a:off x="0" y="0"/>
-          <a:ext cx="0" cy="0"/>
-          <a:chOff x="0" y="0"/>
-          <a:chExt cx="0" cy="0"/>
-        </a:xfrm>
-      </p:grpSpPr>
-      <p:sp>
-        <p:nvSpPr>
-          <p:cNvPr id="2" name="Text 0"/>
-          <p:cNvSpPr/>
-          <p:nvPr/>
-        </p:nvSpPr>
-        <p:spPr>
-          <a:xfrm>
-            <a:off x="822960" y="457200"/>
-            <a:ext cx="7772400" cy="274320"/>
-          </a:xfrm>
-          <a:prstGeom prst="rect">
-            <a:avLst/>
-          </a:prstGeom>
-          <a:noFill/>
-          <a:ln/>
-        </p:spPr>
-        <p:txBody>
-          <a:bodyPr wrap="square" lIns="0" tIns="0" rIns="0" bIns="0" rtlCol="0" anchor="ctr"/>
-          <a:lstStyle/>
-          <a:p>
-            <a:pPr indent="0" marL="0">
-              <a:buNone/>
-            </a:pPr>
-            <a:r>
-              <a:rPr lang="en-US" sz="1100" b="1" spc="300" kern="0" dirty="0">
-                <a:solidFill>
-                  <a:srgbClr val="007BCB"/>
-                </a:solidFill>
-                <a:latin typeface="Garamond" pitchFamily="34" charset="0"/>
-                <a:ea typeface="Garamond" pitchFamily="34" charset="-122"/>
-                <a:cs typeface="Garamond" pitchFamily="34" charset="-120"/>
-              </a:rPr>
-              <a:t>FINANCIAL OUTLOOK</a:t>
-            </a:r>
-            <a:endParaRPr lang="en-US" sz="1100" dirty="0"/>
-          </a:p>
-        </p:txBody>
-      </p:sp>
-      <p:sp>
-        <p:nvSpPr>
-          <p:cNvPr id="3" name="Text 1"/>
-          <p:cNvSpPr/>
-          <p:nvPr/>
-        </p:nvSpPr>
-        <p:spPr>
-          <a:xfrm>
-            <a:off x="822960" y="713232"/>
-            <a:ext cx="8961120" cy="566928"/>
-          </a:xfrm>
-          <a:prstGeom prst="rect">
-            <a:avLst/>
-          </a:prstGeom>
-          <a:noFill/>
-          <a:ln/>
-        </p:spPr>
-        <p:txBody>
-          <a:bodyPr wrap="square" lIns="0" tIns="0" rIns="0" bIns="0" rtlCol="0" anchor="ctr"/>
-          <a:lstStyle/>
-          <a:p>
-            <a:pPr indent="0" marL="0">
-              <a:buNone/>
-            </a:pPr>
-            <a:r>
-              <a:rPr lang="en-US" sz="2900" b="1" dirty="0">
-                <a:solidFill>
-                  <a:srgbClr val="10222F"/>
-                </a:solidFill>
-                <a:latin typeface="Garamond" pitchFamily="34" charset="0"/>
-                <a:ea typeface="Garamond" pitchFamily="34" charset="-122"/>
-                <a:cs typeface="Garamond" pitchFamily="34" charset="-120"/>
-              </a:rPr>
-              <a:t>Illustrative Five Year Revenue Scenario</a:t>
-            </a:r>
-            <a:endParaRPr lang="en-US" sz="2900" dirty="0"/>
-          </a:p>
-        </p:txBody>
-      </p:sp>
-      <p:pic>
-        <p:nvPicPr>
-          <p:cNvPr id="4" name="Image 0" descr="assets/logo_dark.jpg">    </p:cNvPr>
-          <p:cNvPicPr>
-            <a:picLocks noChangeAspect="1"/>
-          </p:cNvPicPr>
-          <p:nvPr/>
-        </p:nvPicPr>
-        <p:blipFill>
-          <a:blip r:embed="rId1"/>
-          <a:stretch>
-            <a:fillRect/>
-          </a:stretch>
-        </p:blipFill>
-        <p:spPr>
-          <a:xfrm>
-            <a:off x="10058400" y="475488"/>
-            <a:ext cx="1325880" cy="372161"/>
-          </a:xfrm>
-          <a:prstGeom prst="rect">
-            <a:avLst/>
-          </a:prstGeom>
-        </p:spPr>
-      </p:pic>
-      <p:sp>
-        <p:nvSpPr>
-          <p:cNvPr id="5" name="Text 2"/>
-          <p:cNvSpPr/>
-          <p:nvPr/>
-        </p:nvSpPr>
-        <p:spPr>
-          <a:xfrm>
-            <a:off x="822960" y="6492240"/>
-            <a:ext cx="5943600" cy="237744"/>
-          </a:xfrm>
-          <a:prstGeom prst="rect">
-            <a:avLst/>
-          </a:prstGeom>
-          <a:noFill/>
-          <a:ln/>
-        </p:spPr>
-        <p:txBody>
-          <a:bodyPr wrap="square" lIns="0" tIns="0" rIns="0" bIns="0" rtlCol="0" anchor="ctr"/>
-          <a:lstStyle/>
-          <a:p>
-            <a:pPr indent="0" marL="0">
-              <a:buNone/>
-            </a:pPr>
-            <a:r>
-              <a:rPr lang="en-US" sz="850" dirty="0">
-                <a:solidFill>
-                  <a:srgbClr val="5C6B76"/>
-                </a:solidFill>
-                <a:latin typeface="Garamond" pitchFamily="34" charset="0"/>
-                <a:ea typeface="Garamond" pitchFamily="34" charset="-122"/>
-                <a:cs typeface="Garamond" pitchFamily="34" charset="-120"/>
-              </a:rPr>
-              <a:t>Heliospace Corporation   |   Proprietary and Confidential</a:t>
-            </a:r>
-            <a:endParaRPr lang="en-US" sz="850" dirty="0"/>
-          </a:p>
-        </p:txBody>
-      </p:sp>
-      <p:sp>
-        <p:nvSpPr>
-          <p:cNvPr id="6" name="Text 3"/>
-          <p:cNvSpPr/>
-          <p:nvPr/>
-        </p:nvSpPr>
-        <p:spPr>
-          <a:xfrm>
-            <a:off x="11064240" y="6492240"/>
-            <a:ext cx="320040" cy="237744"/>
-          </a:xfrm>
-          <a:prstGeom prst="rect">
-            <a:avLst/>
-          </a:prstGeom>
-          <a:noFill/>
-          <a:ln/>
-        </p:spPr>
-        <p:txBody>
-          <a:bodyPr wrap="square" lIns="0" tIns="0" rIns="0" bIns="0" rtlCol="0" anchor="ctr"/>
-          <a:lstStyle/>
-          <a:p>
-            <a:pPr algn="r" indent="0" marL="0">
-              <a:buNone/>
-            </a:pPr>
-            <a:r>
-              <a:rPr lang="en-US" sz="850" dirty="0">
-                <a:solidFill>
-                  <a:srgbClr val="5C6B76"/>
-                </a:solidFill>
-                <a:latin typeface="Garamond" pitchFamily="34" charset="0"/>
-                <a:ea typeface="Garamond" pitchFamily="34" charset="-122"/>
-                <a:cs typeface="Garamond" pitchFamily="34" charset="-120"/>
-              </a:rPr>
-              <a:t>17</a:t>
-            </a:r>
-            <a:endParaRPr lang="en-US" sz="850" dirty="0"/>
-          </a:p>
-        </p:txBody>
-      </p:sp>
-      <p:sp>
-        <p:nvSpPr>
-          <p:cNvPr id="7" name="Text 4"/>
-          <p:cNvSpPr/>
-          <p:nvPr/>
-        </p:nvSpPr>
-        <p:spPr>
-          <a:xfrm>
-            <a:off x="822960" y="1463040"/>
-            <a:ext cx="4846320" cy="274320"/>
-          </a:xfrm>
-          <a:prstGeom prst="rect">
-            <a:avLst/>
-          </a:prstGeom>
-          <a:noFill/>
-          <a:ln/>
-        </p:spPr>
-        <p:txBody>
-          <a:bodyPr wrap="square" lIns="0" tIns="0" rIns="0" bIns="0" rtlCol="0" anchor="ctr"/>
-          <a:lstStyle/>
-          <a:p>
-            <a:pPr indent="0" marL="0">
-              <a:buNone/>
-            </a:pPr>
-            <a:r>
-              <a:rPr lang="en-US" sz="1350" b="1" dirty="0">
-                <a:solidFill>
-                  <a:srgbClr val="10222F"/>
-                </a:solidFill>
-                <a:latin typeface="Garamond" pitchFamily="34" charset="0"/>
-                <a:ea typeface="Garamond" pitchFamily="34" charset="-122"/>
-                <a:cs typeface="Garamond" pitchFamily="34" charset="-120"/>
-              </a:rPr>
-              <a:t>Anchors</a:t>
-            </a:r>
-            <a:endParaRPr lang="en-US" sz="1350" dirty="0"/>
-          </a:p>
-        </p:txBody>
-      </p:sp>
-      <p:sp>
-        <p:nvSpPr>
-          <p:cNvPr id="8" name="Text 5"/>
-          <p:cNvSpPr/>
-          <p:nvPr/>
-        </p:nvSpPr>
-        <p:spPr>
-          <a:xfrm>
-            <a:off x="822960" y="1783080"/>
-            <a:ext cx="4892040" cy="1143000"/>
-          </a:xfrm>
-          <a:prstGeom prst="rect">
-            <a:avLst/>
-          </a:prstGeom>
-          <a:noFill/>
-          <a:ln/>
-        </p:spPr>
-        <p:txBody>
-          <a:bodyPr wrap="square" lIns="0" tIns="0" rIns="0" bIns="0" rtlCol="0" anchor="t"/>
-          <a:lstStyle/>
-          <a:p>
-            <a:pPr algn="l" marL="127000" indent="-127000">
-              <a:spcAft>
-                <a:spcPts val="500"/>
-              </a:spcAft>
-              <a:buSzPct val="100000"/>
-              <a:buChar char="•"/>
-            </a:pPr>
-            <a:r>
-              <a:rPr lang="en-US" sz="1150" dirty="0">
-                <a:solidFill>
-                  <a:srgbClr val="1E2A33"/>
-                </a:solidFill>
-                <a:latin typeface="Garamond" pitchFamily="34" charset="0"/>
-                <a:ea typeface="Garamond" pitchFamily="34" charset="-122"/>
-                <a:cs typeface="Garamond" pitchFamily="34" charset="-120"/>
-              </a:rPr>
-              <a:t>$11.8M REASON contract delivered, 2017 to 2024</a:t>
-            </a:r>
-            <a:endParaRPr lang="en-US" sz="1150" dirty="0"/>
-          </a:p>
-          <a:p>
-            <a:pPr algn="l" marL="127000" indent="-127000">
-              <a:spcAft>
-                <a:spcPts val="500"/>
-              </a:spcAft>
-              <a:buSzPct val="100000"/>
-              <a:buChar char="•"/>
-            </a:pPr>
-            <a:r>
-              <a:rPr lang="en-US" sz="1150" dirty="0">
-                <a:solidFill>
-                  <a:srgbClr val="1E2A33"/>
-                </a:solidFill>
-                <a:latin typeface="Garamond" pitchFamily="34" charset="0"/>
-                <a:ea typeface="Garamond" pitchFamily="34" charset="-122"/>
-                <a:cs typeface="Garamond" pitchFamily="34" charset="-120"/>
-              </a:rPr>
-              <a:t>$1.5M+ in ongoing CLPS lunar contracts</a:t>
-            </a:r>
-            <a:endParaRPr lang="en-US" sz="1150" dirty="0"/>
-          </a:p>
-          <a:p>
-            <a:pPr algn="l" marL="127000" indent="-127000">
-              <a:spcAft>
-                <a:spcPts val="500"/>
-              </a:spcAft>
-              <a:buSzPct val="100000"/>
-              <a:buChar char="•"/>
-            </a:pPr>
-            <a:r>
-              <a:rPr lang="en-US" sz="1150" dirty="0">
-                <a:solidFill>
-                  <a:srgbClr val="1E2A33"/>
-                </a:solidFill>
-                <a:latin typeface="Garamond" pitchFamily="34" charset="0"/>
-                <a:ea typeface="Garamond" pitchFamily="34" charset="-122"/>
-                <a:cs typeface="Garamond" pitchFamily="34" charset="-120"/>
-              </a:rPr>
-              <a:t>Growing SABER catalog quote pipeline</a:t>
-            </a:r>
-            <a:endParaRPr lang="en-US" sz="1150" dirty="0"/>
-          </a:p>
-        </p:txBody>
-      </p:sp>
-      <p:sp>
-        <p:nvSpPr>
-          <p:cNvPr id="9" name="Text 6"/>
-          <p:cNvSpPr/>
-          <p:nvPr/>
-        </p:nvSpPr>
-        <p:spPr>
-          <a:xfrm>
-            <a:off x="822960" y="3063240"/>
-            <a:ext cx="4846320" cy="274320"/>
-          </a:xfrm>
-          <a:prstGeom prst="rect">
-            <a:avLst/>
-          </a:prstGeom>
-          <a:noFill/>
-          <a:ln/>
-        </p:spPr>
-        <p:txBody>
-          <a:bodyPr wrap="square" lIns="0" tIns="0" rIns="0" bIns="0" rtlCol="0" anchor="ctr"/>
-          <a:lstStyle/>
-          <a:p>
-            <a:pPr indent="0" marL="0">
-              <a:buNone/>
-            </a:pPr>
-            <a:r>
-              <a:rPr lang="en-US" sz="1350" b="1" dirty="0">
-                <a:solidFill>
-                  <a:srgbClr val="10222F"/>
-                </a:solidFill>
-                <a:latin typeface="Garamond" pitchFamily="34" charset="0"/>
-                <a:ea typeface="Garamond" pitchFamily="34" charset="-122"/>
-                <a:cs typeface="Garamond" pitchFamily="34" charset="-120"/>
-              </a:rPr>
-              <a:t>Scenario drivers</a:t>
-            </a:r>
-            <a:endParaRPr lang="en-US" sz="1350" dirty="0"/>
-          </a:p>
-        </p:txBody>
-      </p:sp>
-      <p:sp>
-        <p:nvSpPr>
-          <p:cNvPr id="10" name="Text 7"/>
-          <p:cNvSpPr/>
-          <p:nvPr/>
-        </p:nvSpPr>
-        <p:spPr>
-          <a:xfrm>
-            <a:off x="822960" y="3383280"/>
-            <a:ext cx="4892040" cy="1463040"/>
-          </a:xfrm>
-          <a:prstGeom prst="rect">
-            <a:avLst/>
-          </a:prstGeom>
-          <a:noFill/>
-          <a:ln/>
-        </p:spPr>
-        <p:txBody>
-          <a:bodyPr wrap="square" lIns="0" tIns="0" rIns="0" bIns="0" rtlCol="0" anchor="t"/>
-          <a:lstStyle/>
-          <a:p>
-            <a:pPr algn="l" marL="127000" indent="-127000">
-              <a:spcAft>
-                <a:spcPts val="500"/>
-              </a:spcAft>
-              <a:buSzPct val="100000"/>
-              <a:buChar char="•"/>
-            </a:pPr>
-            <a:r>
-              <a:rPr lang="en-US" sz="1150" dirty="0">
-                <a:solidFill>
-                  <a:srgbClr val="1E2A33"/>
-                </a:solidFill>
-                <a:latin typeface="Garamond" pitchFamily="34" charset="0"/>
-                <a:ea typeface="Garamond" pitchFamily="34" charset="-122"/>
-                <a:cs typeface="Garamond" pitchFamily="34" charset="-120"/>
-              </a:rPr>
-              <a:t>Catalog product sales at higher volume and margin than one off engineering programs</a:t>
-            </a:r>
-            <a:endParaRPr lang="en-US" sz="1150" dirty="0"/>
-          </a:p>
-          <a:p>
-            <a:pPr algn="l" marL="127000" indent="-127000">
-              <a:spcAft>
-                <a:spcPts val="500"/>
-              </a:spcAft>
-              <a:buSzPct val="100000"/>
-              <a:buChar char="•"/>
-            </a:pPr>
-            <a:r>
-              <a:rPr lang="en-US" sz="1150" dirty="0">
-                <a:solidFill>
-                  <a:srgbClr val="1E2A33"/>
-                </a:solidFill>
-                <a:latin typeface="Garamond" pitchFamily="34" charset="0"/>
-                <a:ea typeface="Garamond" pitchFamily="34" charset="-122"/>
-                <a:cs typeface="Garamond" pitchFamily="34" charset="-120"/>
-              </a:rPr>
-              <a:t>Recurring lunar payload demand under NASA CLPS</a:t>
-            </a:r>
-            <a:endParaRPr lang="en-US" sz="1150" dirty="0"/>
-          </a:p>
-          <a:p>
-            <a:pPr algn="l" marL="127000" indent="-127000">
-              <a:spcAft>
-                <a:spcPts val="500"/>
-              </a:spcAft>
-              <a:buSzPct val="100000"/>
-              <a:buChar char="•"/>
-            </a:pPr>
-            <a:r>
-              <a:rPr lang="en-US" sz="1150" dirty="0">
-                <a:solidFill>
-                  <a:srgbClr val="1E2A33"/>
-                </a:solidFill>
-                <a:latin typeface="Garamond" pitchFamily="34" charset="0"/>
-                <a:ea typeface="Garamond" pitchFamily="34" charset="-122"/>
-                <a:cs typeface="Garamond" pitchFamily="34" charset="-120"/>
-              </a:rPr>
-              <a:t>Existing facility capacity supports the ramp with limited capital expenditure</a:t>
-            </a:r>
-            <a:endParaRPr lang="en-US" sz="1150" dirty="0"/>
-          </a:p>
-        </p:txBody>
-      </p:sp>
-      <p:sp>
-        <p:nvSpPr>
-          <p:cNvPr id="11" name="Shape 8"/>
-          <p:cNvSpPr/>
-          <p:nvPr/>
-        </p:nvSpPr>
-        <p:spPr>
-          <a:xfrm>
-            <a:off x="822960" y="5074920"/>
-            <a:ext cx="4892040" cy="1188720"/>
-          </a:xfrm>
-          <a:prstGeom prst="roundRect">
-            <a:avLst>
-              <a:gd name="adj" fmla="val 3846"/>
-            </a:avLst>
-          </a:prstGeom>
-          <a:solidFill>
-            <a:srgbClr val="EDF3F8"/>
-          </a:solidFill>
-          <a:ln w="9525">
-            <a:solidFill>
-              <a:srgbClr val="C6D2DA"/>
-            </a:solidFill>
-            <a:prstDash val="solid"/>
-          </a:ln>
-        </p:spPr>
-      </p:sp>
-      <p:sp>
-        <p:nvSpPr>
-          <p:cNvPr id="12" name="Text 9"/>
-          <p:cNvSpPr/>
-          <p:nvPr/>
-        </p:nvSpPr>
-        <p:spPr>
-          <a:xfrm>
-            <a:off x="987552" y="5212080"/>
-            <a:ext cx="4572000" cy="960120"/>
-          </a:xfrm>
-          <a:prstGeom prst="rect">
-            <a:avLst/>
-          </a:prstGeom>
-          <a:noFill/>
-          <a:ln/>
-        </p:spPr>
-        <p:txBody>
-          <a:bodyPr wrap="square" lIns="0" tIns="0" rIns="0" bIns="0" rtlCol="0" anchor="t"/>
-          <a:lstStyle/>
-          <a:p>
-            <a:pPr indent="0" marL="0">
-              <a:buNone/>
-            </a:pPr>
-            <a:r>
-              <a:rPr lang="en-US" sz="1050" i="1" dirty="0">
-                <a:solidFill>
-                  <a:srgbClr val="5C6B76"/>
-                </a:solidFill>
-                <a:latin typeface="Garamond" pitchFamily="34" charset="0"/>
-                <a:ea typeface="Garamond" pitchFamily="34" charset="-122"/>
-                <a:cs typeface="Garamond" pitchFamily="34" charset="-120"/>
-              </a:rPr>
-              <a:t>The chart presents an illustrative planning scenario for discussion. It is not guidance, and it should be replaced with the management financial plan before any investor distribution.</a:t>
-            </a:r>
-            <a:endParaRPr lang="en-US" sz="1050" dirty="0"/>
-          </a:p>
-        </p:txBody>
-      </p:sp>
-      <p:sp>
-        <p:nvSpPr>
-          <p:cNvPr id="13" name="Text 10"/>
-          <p:cNvSpPr/>
-          <p:nvPr/>
-        </p:nvSpPr>
-        <p:spPr>
-          <a:xfrm>
-            <a:off x="6172200" y="1463040"/>
-            <a:ext cx="5212080" cy="274320"/>
-          </a:xfrm>
-          <a:prstGeom prst="rect">
-            <a:avLst/>
-          </a:prstGeom>
-          <a:noFill/>
-          <a:ln/>
-        </p:spPr>
-        <p:txBody>
-          <a:bodyPr wrap="square" lIns="0" tIns="0" rIns="0" bIns="0" rtlCol="0" anchor="ctr"/>
-          <a:lstStyle/>
-          <a:p>
-            <a:pPr indent="0" marL="0">
-              <a:buNone/>
-            </a:pPr>
-            <a:r>
-              <a:rPr lang="en-US" sz="1300" b="1" dirty="0">
-                <a:solidFill>
-                  <a:srgbClr val="10222F"/>
-                </a:solidFill>
-                <a:latin typeface="Garamond" pitchFamily="34" charset="0"/>
-                <a:ea typeface="Garamond" pitchFamily="34" charset="-122"/>
-                <a:cs typeface="Garamond" pitchFamily="34" charset="-120"/>
-              </a:rPr>
-              <a:t>Revenue scenario, USD millions</a:t>
-            </a:r>
-            <a:endParaRPr lang="en-US" sz="1300" dirty="0"/>
-          </a:p>
-        </p:txBody>
-      </p:sp>
-      <p:graphicFrame>
-        <p:nvGraphicFramePr>
-          <p:cNvPr id="14" name="Chart 0" descr=""/>
-          <p:cNvGraphicFramePr/>
-          <p:nvPr/>
-        </p:nvGraphicFramePr>
-        <p:xfrm>
-          <a:off x="6172200" y="1828800"/>
-          <a:ext cx="5212080" cy="4114800"/>
-        </p:xfrm>
-        <a:graphic xmlns:a="http://schemas.openxmlformats.org/drawingml/2006/main">
-          <a:graphicData uri="http://schemas.openxmlformats.org/drawingml/2006/chart">
-            <c:chart xmlns:c="http://schemas.openxmlformats.org/drawingml/2006/chart" r:id="rId2"/>
-          </a:graphicData>
-        </a:graphic>
-      </p:graphicFrame>
-      <p:sp>
-        <p:nvSpPr>
-          <p:cNvPr id="15" name="Text 11"/>
-          <p:cNvSpPr/>
-          <p:nvPr/>
-        </p:nvSpPr>
-        <p:spPr>
-          <a:xfrm>
-            <a:off x="6172200" y="5989320"/>
-            <a:ext cx="5120640" cy="256032"/>
-          </a:xfrm>
-          <a:prstGeom prst="rect">
-            <a:avLst/>
-          </a:prstGeom>
-          <a:noFill/>
-          <a:ln/>
-        </p:spPr>
-        <p:txBody>
-          <a:bodyPr wrap="square" lIns="0" tIns="0" rIns="0" bIns="0" rtlCol="0" anchor="ctr"/>
-          <a:lstStyle/>
-          <a:p>
-            <a:pPr indent="0" marL="0">
-              <a:buNone/>
-            </a:pPr>
-            <a:r>
-              <a:rPr lang="en-US" sz="900" i="1" dirty="0">
-                <a:solidFill>
-                  <a:srgbClr val="5C6B76"/>
-                </a:solidFill>
-                <a:latin typeface="Garamond" pitchFamily="34" charset="0"/>
-                <a:ea typeface="Garamond" pitchFamily="34" charset="-122"/>
-                <a:cs typeface="Garamond" pitchFamily="34" charset="-120"/>
-              </a:rPr>
-              <a:t>Illustrative only; not guidance.</a:t>
-            </a:r>
-            <a:endParaRPr lang="en-US" sz="900" dirty="0"/>
           </a:p>
         </p:txBody>
       </p:sp>
@@ -9985,6 +9275,10 @@
             <a:prstDash val="solid"/>
           </a:ln>
         </p:spPr>
+        <p:txBody>
+          <a:bodyPr/>
+          <a:p/>
+        </p:txBody>
       </p:sp>
       <p:sp>
         <p:nvSpPr>
@@ -10042,7 +9336,7 @@
                 <a:ea typeface="Garamond" pitchFamily="34" charset="-122"/>
                 <a:cs typeface="Garamond" pitchFamily="34" charset="-120"/>
               </a:rPr>
-              <a:t>[Title], Heliospace Corporation</a:t>
+              <a:t>Exclusive Sales Distributor in China</a:t>
             </a:r>
             <a:endParaRPr lang="en-US" sz="1700" dirty="0"/>
           </a:p>
@@ -10062,7 +9356,7 @@
                 <a:ea typeface="Garamond" pitchFamily="34" charset="-122"/>
                 <a:cs typeface="Garamond" pitchFamily="34" charset="-120"/>
               </a:rPr>
-              <a:t>[direct email]   |   [direct phone]</a:t>
+              <a:t>rocky@helio.space   |   19921169641</a:t>
             </a:r>
             <a:endParaRPr lang="en-US" sz="1700" dirty="0"/>
           </a:p>
@@ -10404,7 +9698,7 @@
                 <a:ea typeface="Garamond" pitchFamily="34" charset="-122"/>
                 <a:cs typeface="Garamond" pitchFamily="34" charset="-120"/>
               </a:rPr>
-              <a:t>Heliospace Corporation designs, develops, and delivers high reliability deployable mechanisms and space hardware for civil, commercial, and scientific missions. The team brings decades of experience building flight hardware for NASA and ESA programs, carrying designs from concept through qualification, delivery, and on orbit operations.</a:t>
+              <a:t>Helio is pioneering a new class of energy infrastructure: space based power systems, or power plants in space, that capture solar energy beyond Earth's atmosphere and beam it safely and efficiently to the surface. Our vision is to establish orbital energy platforms as a foundational layer of the global power grid, delivering uninterrupted, carbon free electricity at scale.</a:t>
             </a:r>
             <a:endParaRPr lang="en-US" sz="1350" dirty="0"/>
           </a:p>
@@ -10446,7 +9740,7 @@
                 <a:ea typeface="Garamond" pitchFamily="34" charset="-122"/>
                 <a:cs typeface="Garamond" pitchFamily="34" charset="-120"/>
               </a:rPr>
-              <a:t>The company's SABER deployable boom technology provides a low mass, compact solution for spaceborne antennas, sensors, and instrument booms, with a record of hundreds of successful operational deployments on some of the most demanding missions ever flown.</a:t>
+              <a:t>Founded in 2018, Helio delivers cutting edge aerospace hardware, systems engineering, and mission services, supporting NASA, private companies, universities, and global space agencies. A trusted partner to more than a dozen organizations worldwide, with products operating from the Sun to Jupiter.</a:t>
             </a:r>
             <a:endParaRPr lang="en-US" sz="1350" dirty="0"/>
           </a:p>
@@ -10485,7 +9779,7 @@
                 <a:ea typeface="Garamond" pitchFamily="34" charset="-122"/>
                 <a:cs typeface="Garamond" pitchFamily="34" charset="-120"/>
               </a:rPr>
-              <a:t>60+</a:t>
+              <a:t>40+</a:t>
             </a:r>
             <a:endParaRPr lang="en-US" sz="2800" dirty="0"/>
           </a:p>
@@ -10524,7 +9818,7 @@
                 <a:ea typeface="Garamond" pitchFamily="34" charset="-122"/>
                 <a:cs typeface="Garamond" pitchFamily="34" charset="-120"/>
               </a:rPr>
-              <a:t>engineer years of deployables experience</a:t>
+              <a:t>space flight missions supported</a:t>
             </a:r>
             <a:endParaRPr lang="en-US" sz="1050" dirty="0"/>
           </a:p>
@@ -10563,7 +9857,7 @@
                 <a:ea typeface="Garamond" pitchFamily="34" charset="-122"/>
                 <a:cs typeface="Garamond" pitchFamily="34" charset="-120"/>
               </a:rPr>
-              <a:t>100s</a:t>
+              <a:t>125+</a:t>
             </a:r>
             <a:endParaRPr lang="en-US" sz="2800" dirty="0"/>
           </a:p>
@@ -10602,7 +9896,7 @@
                 <a:ea typeface="Garamond" pitchFamily="34" charset="-122"/>
                 <a:cs typeface="Garamond" pitchFamily="34" charset="-120"/>
               </a:rPr>
-              <a:t>of successful operational deployments</a:t>
+              <a:t>instruments and systems built</a:t>
             </a:r>
             <a:endParaRPr lang="en-US" sz="1050" dirty="0"/>
           </a:p>
@@ -10641,7 +9935,7 @@
                 <a:ea typeface="Garamond" pitchFamily="34" charset="-122"/>
                 <a:cs typeface="Garamond" pitchFamily="34" charset="-120"/>
               </a:rPr>
-              <a:t>20,000</a:t>
+              <a:t>30+</a:t>
             </a:r>
             <a:endParaRPr lang="en-US" sz="2800" dirty="0"/>
           </a:p>
@@ -10680,7 +9974,7 @@
                 <a:ea typeface="Garamond" pitchFamily="34" charset="-122"/>
                 <a:cs typeface="Garamond" pitchFamily="34" charset="-120"/>
               </a:rPr>
-              <a:t>square feet of Berkeley production space</a:t>
+              <a:t>engineers on the team</a:t>
             </a:r>
             <a:endParaRPr lang="en-US" sz="1050" dirty="0"/>
           </a:p>
@@ -10719,7 +10013,7 @@
                 <a:ea typeface="Garamond" pitchFamily="34" charset="-122"/>
                 <a:cs typeface="Garamond" pitchFamily="34" charset="-120"/>
               </a:rPr>
-              <a:t>$13M+</a:t>
+              <a:t>$45M</a:t>
             </a:r>
             <a:endParaRPr lang="en-US" sz="2800" dirty="0"/>
           </a:p>
@@ -10758,7 +10052,7 @@
                 <a:ea typeface="Garamond" pitchFamily="34" charset="-122"/>
                 <a:cs typeface="Garamond" pitchFamily="34" charset="-120"/>
               </a:rPr>
-              <a:t>in delivered and ongoing mission contracts</a:t>
+              <a:t>delivered in contracts</a:t>
             </a:r>
             <a:endParaRPr lang="en-US" sz="1050" dirty="0"/>
           </a:p>
@@ -10809,6 +10103,10 @@
             <a:prstDash val="solid"/>
           </a:ln>
         </p:spPr>
+        <p:txBody>
+          <a:bodyPr/>
+          <a:p/>
+        </p:txBody>
       </p:sp>
       <p:sp>
         <p:nvSpPr>
@@ -11094,7 +10392,7 @@
                 <a:ea typeface="Garamond" pitchFamily="34" charset="-122"/>
                 <a:cs typeface="Garamond" pitchFamily="34" charset="-120"/>
               </a:rPr>
-              <a:t>Three integrated lines of business supported by a single Berkeley facility and quality system, from initial design through on orbit operations.</a:t>
+              <a:t>Five product and revenue areas supported by a single Berkeley facility and quality system, from initial design through on orbit operations.</a:t>
             </a:r>
             <a:endParaRPr lang="en-US" sz="1300" dirty="0"/>
           </a:p>
@@ -11102,18 +10400,18 @@
       </p:sp>
       <p:sp>
         <p:nvSpPr>
-          <p:cNvPr id="8" name="Shape 5"/>
-          <p:cNvSpPr/>
-          <p:nvPr/>
-        </p:nvSpPr>
-        <p:spPr>
-          <a:xfrm>
-            <a:off x="822960" y="1874520"/>
-            <a:ext cx="3392424" cy="4160520"/>
+          <p:cNvPr id="8" name="Shape 4"/>
+          <p:cNvSpPr/>
+          <p:nvPr/>
+        </p:nvSpPr>
+        <p:spPr>
+          <a:xfrm>
+            <a:off x="822960" y="1874519"/>
+            <a:ext cx="3392424" cy="2057400"/>
           </a:xfrm>
           <a:prstGeom prst="roundRect">
             <a:avLst>
-              <a:gd name="adj" fmla="val 1348"/>
+              <a:gd name="adj" fmla="val 1724"/>
             </a:avLst>
           </a:prstGeom>
           <a:solidFill>
@@ -11121,63 +10419,60 @@
           </a:solidFill>
           <a:ln/>
         </p:spPr>
-      </p:sp>
-      <p:pic>
-        <p:nvPicPr>
-          <p:cNvPr id="9" name="Image 1" descr="assets/s3_antennas.jpg">    </p:cNvPr>
-          <p:cNvPicPr>
-            <a:picLocks noChangeAspect="1"/>
-          </p:cNvPicPr>
-          <p:nvPr/>
-        </p:nvPicPr>
-        <p:blipFill>
-          <a:blip r:embed="rId2"/>
-          <a:stretch>
-            <a:fillRect/>
-          </a:stretch>
-        </p:blipFill>
-        <p:spPr>
-          <a:xfrm>
-            <a:off x="932688" y="1984248"/>
-            <a:ext cx="3172968" cy="1883664"/>
-          </a:xfrm>
-          <a:prstGeom prst="rect">
-            <a:avLst/>
-          </a:prstGeom>
-        </p:spPr>
-      </p:pic>
-      <p:sp>
-        <p:nvSpPr>
-          <p:cNvPr id="10" name="Shape 6"/>
-          <p:cNvSpPr/>
-          <p:nvPr/>
-        </p:nvSpPr>
-        <p:spPr>
-          <a:xfrm>
-            <a:off x="932688" y="1984248"/>
-            <a:ext cx="3172968" cy="1883664"/>
-          </a:xfrm>
-          <a:prstGeom prst="rect">
-            <a:avLst/>
-          </a:prstGeom>
-          <a:ln w="12700">
-            <a:solidFill>
-              <a:srgbClr val="C6D2DA"/>
-            </a:solidFill>
-            <a:prstDash val="solid"/>
-          </a:ln>
-        </p:spPr>
-      </p:sp>
-      <p:sp>
-        <p:nvSpPr>
-          <p:cNvPr id="11" name="Text 7"/>
-          <p:cNvSpPr/>
-          <p:nvPr/>
-        </p:nvSpPr>
-        <p:spPr>
-          <a:xfrm>
-            <a:off x="987552" y="4023360"/>
-            <a:ext cx="3063240" cy="685800"/>
+        <p:txBody>
+          <a:bodyPr/>
+          <a:p/>
+        </p:txBody>
+      </p:sp>
+      <p:sp>
+        <p:nvSpPr>
+          <p:cNvPr id="9" name="Text 12"/>
+          <p:cNvSpPr/>
+          <p:nvPr/>
+        </p:nvSpPr>
+        <p:spPr>
+          <a:xfrm>
+            <a:off x="987552" y="2020823"/>
+            <a:ext cx="3063240" cy="566928"/>
+          </a:xfrm>
+          <a:prstGeom prst="rect">
+            <a:avLst/>
+          </a:prstGeom>
+          <a:noFill/>
+          <a:ln/>
+        </p:spPr>
+        <p:txBody>
+          <a:bodyPr wrap="square" lIns="0" tIns="0" rIns="0" bIns="0" rtlCol="0" anchor="ctr"/>
+          <a:lstStyle/>
+          <a:p>
+            <a:pPr indent="0" marL="0">
+              <a:buNone/>
+            </a:pPr>
+            <a:r>
+              <a:rPr lang="en-US" sz="1550" b="1" dirty="0">
+                <a:solidFill>
+                  <a:srgbClr val="10222F"/>
+                </a:solidFill>
+                <a:latin typeface="Garamond" pitchFamily="34" charset="0"/>
+                <a:ea typeface="Garamond" pitchFamily="34" charset="-122"/>
+                <a:cs typeface="Garamond" pitchFamily="34" charset="-120"/>
+              </a:rPr>
+              <a:t>Space Qualified Hardware</a:t>
+            </a:r>
+            <a:endParaRPr lang="en-US" sz="1550" dirty="0"/>
+          </a:p>
+        </p:txBody>
+      </p:sp>
+      <p:sp>
+        <p:nvSpPr>
+          <p:cNvPr id="10" name="Text 13"/>
+          <p:cNvSpPr/>
+          <p:nvPr/>
+        </p:nvSpPr>
+        <p:spPr>
+          <a:xfrm>
+            <a:off x="987552" y="2660903"/>
+            <a:ext cx="3063240" cy="1143000"/>
           </a:xfrm>
           <a:prstGeom prst="rect">
             <a:avLst/>
@@ -11189,53 +10484,15 @@
           <a:bodyPr wrap="square" lIns="0" tIns="0" rIns="0" bIns="0" rtlCol="0" anchor="t"/>
           <a:lstStyle/>
           <a:p>
-            <a:pPr indent="0" marL="0">
-              <a:buNone/>
-            </a:pPr>
-            <a:r>
-              <a:rPr lang="en-US" sz="1500" b="1" dirty="0">
-                <a:solidFill>
-                  <a:srgbClr val="10222F"/>
-                </a:solidFill>
-                <a:latin typeface="Garamond" pitchFamily="34" charset="0"/>
-                <a:ea typeface="Garamond" pitchFamily="34" charset="-122"/>
-                <a:cs typeface="Garamond" pitchFamily="34" charset="-120"/>
-              </a:rPr>
-              <a:t>Deployable Antennas and Booms</a:t>
-            </a:r>
-            <a:endParaRPr lang="en-US" sz="1500" dirty="0"/>
-          </a:p>
-        </p:txBody>
-      </p:sp>
-      <p:sp>
-        <p:nvSpPr>
-          <p:cNvPr id="12" name="Text 8"/>
-          <p:cNvSpPr/>
-          <p:nvPr/>
-        </p:nvSpPr>
-        <p:spPr>
-          <a:xfrm>
-            <a:off x="987552" y="4736592"/>
-            <a:ext cx="3063240" cy="1188720"/>
-          </a:xfrm>
-          <a:prstGeom prst="rect">
-            <a:avLst/>
-          </a:prstGeom>
-          <a:noFill/>
-          <a:ln/>
-        </p:spPr>
-        <p:txBody>
-          <a:bodyPr wrap="square" lIns="0" tIns="0" rIns="0" bIns="0" rtlCol="0" anchor="t"/>
-          <a:lstStyle/>
-          <a:p>
-            <a:pPr indent="0" marL="0">
-              <a:lnSpc>
-                <a:spcPct val="105000"/>
-              </a:lnSpc>
-              <a:buNone/>
-            </a:pPr>
-            <a:r>
-              <a:rPr lang="en-US" sz="1150" dirty="0">
+            <a:pPr algn="l" marL="127000" indent="-127000">
+              <a:spcAft>
+                <a:spcPts val="400"/>
+              </a:spcAft>
+              <a:buSzPct val="100000"/>
+              <a:buChar char="•"/>
+            </a:pPr>
+            <a:r>
+              <a:rPr lang="en-US" sz="1100" dirty="0">
                 <a:solidFill>
                   <a:srgbClr val="1E2A33"/>
                 </a:solidFill>
@@ -11243,26 +10500,68 @@
                 <a:ea typeface="Garamond" pitchFamily="34" charset="-122"/>
                 <a:cs typeface="Garamond" pitchFamily="34" charset="-120"/>
               </a:rPr>
-              <a:t>SABER and Stacer based monopoles, dipoles, and custom geometries from 1 m to 17.6 m tip to tip, delivered fully qualified for flight.</a:t>
-            </a:r>
-            <a:endParaRPr lang="en-US" sz="1150" dirty="0"/>
-          </a:p>
-        </p:txBody>
-      </p:sp>
-      <p:sp>
-        <p:nvSpPr>
-          <p:cNvPr id="13" name="Shape 9"/>
-          <p:cNvSpPr/>
-          <p:nvPr/>
-        </p:nvSpPr>
-        <p:spPr>
-          <a:xfrm>
-            <a:off x="4398264" y="1874520"/>
-            <a:ext cx="3392424" cy="4160520"/>
+              <a:t>Deployable antennas</a:t>
+            </a:r>
+            <a:endParaRPr lang="en-US" sz="1100" dirty="0"/>
+          </a:p>
+          <a:p>
+            <a:pPr algn="l" marL="127000" indent="-127000">
+              <a:spcAft>
+                <a:spcPts val="400"/>
+              </a:spcAft>
+              <a:buSzPct val="100000"/>
+              <a:buChar char="•"/>
+            </a:pPr>
+            <a:r>
+              <a:rPr lang="en-US" sz="1100" dirty="0">
+                <a:solidFill>
+                  <a:srgbClr val="1E2A33"/>
+                </a:solidFill>
+                <a:latin typeface="Garamond" pitchFamily="34" charset="0"/>
+                <a:ea typeface="Garamond" pitchFamily="34" charset="-122"/>
+                <a:cs typeface="Garamond" pitchFamily="34" charset="-120"/>
+              </a:rPr>
+              <a:t>Sensors and scientific instruments</a:t>
+            </a:r>
+            <a:endParaRPr lang="en-US" sz="1100" dirty="0"/>
+          </a:p>
+          <a:p>
+            <a:pPr algn="l" marL="127000" indent="-127000">
+              <a:spcAft>
+                <a:spcPts val="400"/>
+              </a:spcAft>
+              <a:buSzPct val="100000"/>
+              <a:buChar char="•"/>
+            </a:pPr>
+            <a:r>
+              <a:rPr lang="en-US" sz="1100" dirty="0">
+                <a:solidFill>
+                  <a:srgbClr val="1E2A33"/>
+                </a:solidFill>
+                <a:latin typeface="Garamond" pitchFamily="34" charset="0"/>
+                <a:ea typeface="Garamond" pitchFamily="34" charset="-122"/>
+                <a:cs typeface="Garamond" pitchFamily="34" charset="-120"/>
+              </a:rPr>
+              <a:t>Mechanical systems and structures for spacecraft</a:t>
+            </a:r>
+            <a:endParaRPr lang="en-US" sz="1100" dirty="0"/>
+          </a:p>
+        </p:txBody>
+      </p:sp>
+      <p:sp>
+        <p:nvSpPr>
+          <p:cNvPr id="11" name="Shape 4"/>
+          <p:cNvSpPr/>
+          <p:nvPr/>
+        </p:nvSpPr>
+        <p:spPr>
+          <a:xfrm>
+            <a:off x="4398264" y="1874519"/>
+            <a:ext cx="3392424" cy="2057400"/>
           </a:xfrm>
           <a:prstGeom prst="roundRect">
             <a:avLst>
-              <a:gd name="adj" fmla="val 1348"/>
+              <a:gd name="adj" fmla="val 1724"/>
             </a:avLst>
           </a:prstGeom>
           <a:solidFill>
@@ -11270,63 +10569,60 @@
           </a:solidFill>
           <a:ln/>
         </p:spPr>
-      </p:sp>
-      <p:pic>
-        <p:nvPicPr>
-          <p:cNvPr id="14" name="Image 2" descr="assets/s3_mech.jpg">    </p:cNvPr>
-          <p:cNvPicPr>
-            <a:picLocks noChangeAspect="1"/>
-          </p:cNvPicPr>
-          <p:nvPr/>
-        </p:nvPicPr>
-        <p:blipFill>
-          <a:blip r:embed="rId3"/>
-          <a:stretch>
-            <a:fillRect/>
-          </a:stretch>
-        </p:blipFill>
-        <p:spPr>
-          <a:xfrm>
-            <a:off x="4507992" y="1984248"/>
-            <a:ext cx="3172968" cy="1883664"/>
-          </a:xfrm>
-          <a:prstGeom prst="rect">
-            <a:avLst/>
-          </a:prstGeom>
-        </p:spPr>
-      </p:pic>
-      <p:sp>
-        <p:nvSpPr>
-          <p:cNvPr id="15" name="Shape 10"/>
-          <p:cNvSpPr/>
-          <p:nvPr/>
-        </p:nvSpPr>
-        <p:spPr>
-          <a:xfrm>
-            <a:off x="4507992" y="1984248"/>
-            <a:ext cx="3172968" cy="1883664"/>
-          </a:xfrm>
-          <a:prstGeom prst="rect">
-            <a:avLst/>
-          </a:prstGeom>
-          <a:ln w="12700">
-            <a:solidFill>
-              <a:srgbClr val="C6D2DA"/>
-            </a:solidFill>
-            <a:prstDash val="solid"/>
-          </a:ln>
-        </p:spPr>
-      </p:sp>
-      <p:sp>
-        <p:nvSpPr>
-          <p:cNvPr id="16" name="Text 11"/>
-          <p:cNvSpPr/>
-          <p:nvPr/>
-        </p:nvSpPr>
-        <p:spPr>
-          <a:xfrm>
-            <a:off x="4562856" y="4023360"/>
-            <a:ext cx="3063240" cy="685800"/>
+        <p:txBody>
+          <a:bodyPr/>
+          <a:p/>
+        </p:txBody>
+      </p:sp>
+      <p:sp>
+        <p:nvSpPr>
+          <p:cNvPr id="12" name="Text 12"/>
+          <p:cNvSpPr/>
+          <p:nvPr/>
+        </p:nvSpPr>
+        <p:spPr>
+          <a:xfrm>
+            <a:off x="4562856" y="2020823"/>
+            <a:ext cx="3063240" cy="566928"/>
+          </a:xfrm>
+          <a:prstGeom prst="rect">
+            <a:avLst/>
+          </a:prstGeom>
+          <a:noFill/>
+          <a:ln/>
+        </p:spPr>
+        <p:txBody>
+          <a:bodyPr wrap="square" lIns="0" tIns="0" rIns="0" bIns="0" rtlCol="0" anchor="ctr"/>
+          <a:lstStyle/>
+          <a:p>
+            <a:pPr indent="0" marL="0">
+              <a:buNone/>
+            </a:pPr>
+            <a:r>
+              <a:rPr lang="en-US" sz="1550" b="1" dirty="0">
+                <a:solidFill>
+                  <a:srgbClr val="10222F"/>
+                </a:solidFill>
+                <a:latin typeface="Garamond" pitchFamily="34" charset="0"/>
+                <a:ea typeface="Garamond" pitchFamily="34" charset="-122"/>
+                <a:cs typeface="Garamond" pitchFamily="34" charset="-120"/>
+              </a:rPr>
+              <a:t>Mission Systems and Engineering Services</a:t>
+            </a:r>
+            <a:endParaRPr lang="en-US" sz="1550" dirty="0"/>
+          </a:p>
+        </p:txBody>
+      </p:sp>
+      <p:sp>
+        <p:nvSpPr>
+          <p:cNvPr id="13" name="Text 13"/>
+          <p:cNvSpPr/>
+          <p:nvPr/>
+        </p:nvSpPr>
+        <p:spPr>
+          <a:xfrm>
+            <a:off x="4562856" y="2660903"/>
+            <a:ext cx="3063240" cy="1143000"/>
           </a:xfrm>
           <a:prstGeom prst="rect">
             <a:avLst/>
@@ -11338,53 +10634,15 @@
           <a:bodyPr wrap="square" lIns="0" tIns="0" rIns="0" bIns="0" rtlCol="0" anchor="t"/>
           <a:lstStyle/>
           <a:p>
-            <a:pPr indent="0" marL="0">
-              <a:buNone/>
-            </a:pPr>
-            <a:r>
-              <a:rPr lang="en-US" sz="1500" b="1" dirty="0">
-                <a:solidFill>
-                  <a:srgbClr val="10222F"/>
-                </a:solidFill>
-                <a:latin typeface="Garamond" pitchFamily="34" charset="0"/>
-                <a:ea typeface="Garamond" pitchFamily="34" charset="-122"/>
-                <a:cs typeface="Garamond" pitchFamily="34" charset="-120"/>
-              </a:rPr>
-              <a:t>Sensors and Flight Mechanisms</a:t>
-            </a:r>
-            <a:endParaRPr lang="en-US" sz="1500" dirty="0"/>
-          </a:p>
-        </p:txBody>
-      </p:sp>
-      <p:sp>
-        <p:nvSpPr>
-          <p:cNvPr id="17" name="Text 12"/>
-          <p:cNvSpPr/>
-          <p:nvPr/>
-        </p:nvSpPr>
-        <p:spPr>
-          <a:xfrm>
-            <a:off x="4562856" y="4736592"/>
-            <a:ext cx="3063240" cy="1188720"/>
-          </a:xfrm>
-          <a:prstGeom prst="rect">
-            <a:avLst/>
-          </a:prstGeom>
-          <a:noFill/>
-          <a:ln/>
-        </p:spPr>
-        <p:txBody>
-          <a:bodyPr wrap="square" lIns="0" tIns="0" rIns="0" bIns="0" rtlCol="0" anchor="t"/>
-          <a:lstStyle/>
-          <a:p>
-            <a:pPr indent="0" marL="0">
-              <a:lnSpc>
-                <a:spcPct val="105000"/>
-              </a:lnSpc>
-              <a:buNone/>
-            </a:pPr>
-            <a:r>
-              <a:rPr lang="en-US" sz="1150" dirty="0">
+            <a:pPr algn="l" marL="127000" indent="-127000">
+              <a:spcAft>
+                <a:spcPts val="400"/>
+              </a:spcAft>
+              <a:buSzPct val="100000"/>
+              <a:buChar char="•"/>
+            </a:pPr>
+            <a:r>
+              <a:rPr lang="en-US" sz="1100" dirty="0">
                 <a:solidFill>
                   <a:srgbClr val="1E2A33"/>
                 </a:solidFill>
@@ -11392,26 +10650,68 @@
                 <a:ea typeface="Garamond" pitchFamily="34" charset="-122"/>
                 <a:cs typeface="Garamond" pitchFamily="34" charset="-120"/>
               </a:rPr>
-              <a:t>Release mechanisms, lunar payload sensors, magnetometer masts, and precision mechanisms for landers, orbiters, and instruments.</a:t>
-            </a:r>
-            <a:endParaRPr lang="en-US" sz="1150" dirty="0"/>
-          </a:p>
-        </p:txBody>
-      </p:sp>
-      <p:sp>
-        <p:nvSpPr>
-          <p:cNvPr id="18" name="Shape 13"/>
-          <p:cNvSpPr/>
-          <p:nvPr/>
-        </p:nvSpPr>
-        <p:spPr>
-          <a:xfrm>
-            <a:off x="7973568" y="1874520"/>
-            <a:ext cx="3392424" cy="4160520"/>
+              <a:t>Spacecraft system design</a:t>
+            </a:r>
+            <a:endParaRPr lang="en-US" sz="1100" dirty="0"/>
+          </a:p>
+          <a:p>
+            <a:pPr algn="l" marL="127000" indent="-127000">
+              <a:spcAft>
+                <a:spcPts val="400"/>
+              </a:spcAft>
+              <a:buSzPct val="100000"/>
+              <a:buChar char="•"/>
+            </a:pPr>
+            <a:r>
+              <a:rPr lang="en-US" sz="1100" dirty="0">
+                <a:solidFill>
+                  <a:srgbClr val="1E2A33"/>
+                </a:solidFill>
+                <a:latin typeface="Garamond" pitchFamily="34" charset="0"/>
+                <a:ea typeface="Garamond" pitchFamily="34" charset="-122"/>
+                <a:cs typeface="Garamond" pitchFamily="34" charset="-120"/>
+              </a:rPr>
+              <a:t>Integration and testing</a:t>
+            </a:r>
+            <a:endParaRPr lang="en-US" sz="1100" dirty="0"/>
+          </a:p>
+          <a:p>
+            <a:pPr algn="l" marL="127000" indent="-127000">
+              <a:spcAft>
+                <a:spcPts val="400"/>
+              </a:spcAft>
+              <a:buSzPct val="100000"/>
+              <a:buChar char="•"/>
+            </a:pPr>
+            <a:r>
+              <a:rPr lang="en-US" sz="1100" dirty="0">
+                <a:solidFill>
+                  <a:srgbClr val="1E2A33"/>
+                </a:solidFill>
+                <a:latin typeface="Garamond" pitchFamily="34" charset="0"/>
+                <a:ea typeface="Garamond" pitchFamily="34" charset="-122"/>
+                <a:cs typeface="Garamond" pitchFamily="34" charset="-120"/>
+              </a:rPr>
+              <a:t>Engineering support for government and commercial space missions</a:t>
+            </a:r>
+            <a:endParaRPr lang="en-US" sz="1100" dirty="0"/>
+          </a:p>
+        </p:txBody>
+      </p:sp>
+      <p:sp>
+        <p:nvSpPr>
+          <p:cNvPr id="14" name="Shape 4"/>
+          <p:cNvSpPr/>
+          <p:nvPr/>
+        </p:nvSpPr>
+        <p:spPr>
+          <a:xfrm>
+            <a:off x="7973568" y="1874519"/>
+            <a:ext cx="3392424" cy="2057400"/>
           </a:xfrm>
           <a:prstGeom prst="roundRect">
             <a:avLst>
-              <a:gd name="adj" fmla="val 1348"/>
+              <a:gd name="adj" fmla="val 1724"/>
             </a:avLst>
           </a:prstGeom>
           <a:solidFill>
@@ -11419,63 +10719,60 @@
           </a:solidFill>
           <a:ln/>
         </p:spPr>
-      </p:sp>
-      <p:pic>
-        <p:nvPicPr>
-          <p:cNvPr id="19" name="Image 3" descr="assets/s3_seit.jpg">    </p:cNvPr>
-          <p:cNvPicPr>
-            <a:picLocks noChangeAspect="1"/>
-          </p:cNvPicPr>
-          <p:nvPr/>
-        </p:nvPicPr>
-        <p:blipFill>
-          <a:blip r:embed="rId4"/>
-          <a:stretch>
-            <a:fillRect/>
-          </a:stretch>
-        </p:blipFill>
-        <p:spPr>
-          <a:xfrm>
-            <a:off x="8083296" y="1984248"/>
-            <a:ext cx="3172968" cy="1883664"/>
-          </a:xfrm>
-          <a:prstGeom prst="rect">
-            <a:avLst/>
-          </a:prstGeom>
-        </p:spPr>
-      </p:pic>
-      <p:sp>
-        <p:nvSpPr>
-          <p:cNvPr id="20" name="Shape 14"/>
-          <p:cNvSpPr/>
-          <p:nvPr/>
-        </p:nvSpPr>
-        <p:spPr>
-          <a:xfrm>
-            <a:off x="8083296" y="1984248"/>
-            <a:ext cx="3172968" cy="1883664"/>
-          </a:xfrm>
-          <a:prstGeom prst="rect">
-            <a:avLst/>
-          </a:prstGeom>
-          <a:ln w="12700">
-            <a:solidFill>
-              <a:srgbClr val="C6D2DA"/>
-            </a:solidFill>
-            <a:prstDash val="solid"/>
-          </a:ln>
-        </p:spPr>
-      </p:sp>
-      <p:sp>
-        <p:nvSpPr>
-          <p:cNvPr id="21" name="Text 15"/>
-          <p:cNvSpPr/>
-          <p:nvPr/>
-        </p:nvSpPr>
-        <p:spPr>
-          <a:xfrm>
-            <a:off x="8138160" y="4023360"/>
-            <a:ext cx="3063240" cy="685800"/>
+        <p:txBody>
+          <a:bodyPr/>
+          <a:p/>
+        </p:txBody>
+      </p:sp>
+      <p:sp>
+        <p:nvSpPr>
+          <p:cNvPr id="15" name="Text 12"/>
+          <p:cNvSpPr/>
+          <p:nvPr/>
+        </p:nvSpPr>
+        <p:spPr>
+          <a:xfrm>
+            <a:off x="8138160" y="2020823"/>
+            <a:ext cx="3063240" cy="566928"/>
+          </a:xfrm>
+          <a:prstGeom prst="rect">
+            <a:avLst/>
+          </a:prstGeom>
+          <a:noFill/>
+          <a:ln/>
+        </p:spPr>
+        <p:txBody>
+          <a:bodyPr wrap="square" lIns="0" tIns="0" rIns="0" bIns="0" rtlCol="0" anchor="ctr"/>
+          <a:lstStyle/>
+          <a:p>
+            <a:pPr indent="0" marL="0">
+              <a:buNone/>
+            </a:pPr>
+            <a:r>
+              <a:rPr lang="en-US" sz="1550" b="1" dirty="0">
+                <a:solidFill>
+                  <a:srgbClr val="10222F"/>
+                </a:solidFill>
+                <a:latin typeface="Garamond" pitchFamily="34" charset="0"/>
+                <a:ea typeface="Garamond" pitchFamily="34" charset="-122"/>
+                <a:cs typeface="Garamond" pitchFamily="34" charset="-120"/>
+              </a:rPr>
+              <a:t>Deployable Space Systems</a:t>
+            </a:r>
+            <a:endParaRPr lang="en-US" sz="1550" dirty="0"/>
+          </a:p>
+        </p:txBody>
+      </p:sp>
+      <p:sp>
+        <p:nvSpPr>
+          <p:cNvPr id="16" name="Text 13"/>
+          <p:cNvSpPr/>
+          <p:nvPr/>
+        </p:nvSpPr>
+        <p:spPr>
+          <a:xfrm>
+            <a:off x="8138160" y="2660903"/>
+            <a:ext cx="3063240" cy="1143000"/>
           </a:xfrm>
           <a:prstGeom prst="rect">
             <a:avLst/>
@@ -11487,11 +10784,122 @@
           <a:bodyPr wrap="square" lIns="0" tIns="0" rIns="0" bIns="0" rtlCol="0" anchor="t"/>
           <a:lstStyle/>
           <a:p>
-            <a:pPr indent="0" marL="0">
-              <a:buNone/>
-            </a:pPr>
-            <a:r>
-              <a:rPr lang="en-US" sz="1500" b="1" dirty="0">
+            <a:pPr algn="l" marL="127000" indent="-127000">
+              <a:spcAft>
+                <a:spcPts val="400"/>
+              </a:spcAft>
+              <a:buSzPct val="100000"/>
+              <a:buChar char="•"/>
+            </a:pPr>
+            <a:r>
+              <a:rPr lang="en-US" sz="1100" dirty="0">
+                <a:solidFill>
+                  <a:srgbClr val="1E2A33"/>
+                </a:solidFill>
+                <a:latin typeface="Garamond" pitchFamily="34" charset="0"/>
+                <a:ea typeface="Garamond" pitchFamily="34" charset="-122"/>
+                <a:cs typeface="Garamond" pitchFamily="34" charset="-120"/>
+              </a:rPr>
+              <a:t>Large deployable antennas</a:t>
+            </a:r>
+            <a:endParaRPr lang="en-US" sz="1100" dirty="0"/>
+          </a:p>
+          <a:p>
+            <a:pPr algn="l" marL="127000" indent="-127000">
+              <a:spcAft>
+                <a:spcPts val="400"/>
+              </a:spcAft>
+              <a:buSzPct val="100000"/>
+              <a:buChar char="•"/>
+            </a:pPr>
+            <a:r>
+              <a:rPr lang="en-US" sz="1100" dirty="0">
+                <a:solidFill>
+                  <a:srgbClr val="1E2A33"/>
+                </a:solidFill>
+                <a:latin typeface="Garamond" pitchFamily="34" charset="0"/>
+                <a:ea typeface="Garamond" pitchFamily="34" charset="-122"/>
+                <a:cs typeface="Garamond" pitchFamily="34" charset="-120"/>
+              </a:rPr>
+              <a:t>Solar arrays and other expandable structures</a:t>
+            </a:r>
+            <a:endParaRPr lang="en-US" sz="1100" dirty="0"/>
+          </a:p>
+          <a:p>
+            <a:pPr algn="l" marL="127000" indent="-127000">
+              <a:spcAft>
+                <a:spcPts val="400"/>
+              </a:spcAft>
+              <a:buSzPct val="100000"/>
+              <a:buChar char="•"/>
+            </a:pPr>
+            <a:r>
+              <a:rPr lang="en-US" sz="1100" dirty="0">
+                <a:solidFill>
+                  <a:srgbClr val="1E2A33"/>
+                </a:solidFill>
+                <a:latin typeface="Garamond" pitchFamily="34" charset="0"/>
+                <a:ea typeface="Garamond" pitchFamily="34" charset="-122"/>
+                <a:cs typeface="Garamond" pitchFamily="34" charset="-120"/>
+              </a:rPr>
+              <a:t>Components for satellites, lunar missions, and deep space missions</a:t>
+            </a:r>
+            <a:endParaRPr lang="en-US" sz="1100" dirty="0"/>
+          </a:p>
+        </p:txBody>
+      </p:sp>
+      <p:sp>
+        <p:nvSpPr>
+          <p:cNvPr id="17" name="Shape 4"/>
+          <p:cNvSpPr/>
+          <p:nvPr/>
+        </p:nvSpPr>
+        <p:spPr>
+          <a:xfrm>
+            <a:off x="822960" y="4114800"/>
+            <a:ext cx="5175504" cy="2057400"/>
+          </a:xfrm>
+          <a:prstGeom prst="roundRect">
+            <a:avLst>
+              <a:gd name="adj" fmla="val 1724"/>
+            </a:avLst>
+          </a:prstGeom>
+          <a:solidFill>
+            <a:srgbClr val="F3F7FA"/>
+          </a:solidFill>
+          <a:ln/>
+        </p:spPr>
+        <p:txBody>
+          <a:bodyPr/>
+          <a:p/>
+        </p:txBody>
+      </p:sp>
+      <p:sp>
+        <p:nvSpPr>
+          <p:cNvPr id="18" name="Text 12"/>
+          <p:cNvSpPr/>
+          <p:nvPr/>
+        </p:nvSpPr>
+        <p:spPr>
+          <a:xfrm>
+            <a:off x="987552" y="4261104"/>
+            <a:ext cx="4846320" cy="566928"/>
+          </a:xfrm>
+          <a:prstGeom prst="rect">
+            <a:avLst/>
+          </a:prstGeom>
+          <a:noFill/>
+          <a:ln/>
+        </p:spPr>
+        <p:txBody>
+          <a:bodyPr wrap="square" lIns="0" tIns="0" rIns="0" bIns="0" rtlCol="0" anchor="ctr"/>
+          <a:lstStyle/>
+          <a:p>
+            <a:pPr indent="0" marL="0">
+              <a:buNone/>
+            </a:pPr>
+            <a:r>
+              <a:rPr lang="en-US" sz="1550" b="1" dirty="0">
                 <a:solidFill>
                   <a:srgbClr val="10222F"/>
                 </a:solidFill>
@@ -11499,22 +10907,22 @@
                 <a:ea typeface="Garamond" pitchFamily="34" charset="-122"/>
                 <a:cs typeface="Garamond" pitchFamily="34" charset="-120"/>
               </a:rPr>
-              <a:t>Systems Engineering, Integration, and Test</a:t>
-            </a:r>
-            <a:endParaRPr lang="en-US" sz="1500" dirty="0"/>
-          </a:p>
-        </p:txBody>
-      </p:sp>
-      <p:sp>
-        <p:nvSpPr>
-          <p:cNvPr id="22" name="Text 16"/>
-          <p:cNvSpPr/>
-          <p:nvPr/>
-        </p:nvSpPr>
-        <p:spPr>
-          <a:xfrm>
-            <a:off x="8138160" y="4736592"/>
-            <a:ext cx="3063240" cy="1188720"/>
+              <a:t>Space Based Solar Power Technology</a:t>
+            </a:r>
+            <a:endParaRPr lang="en-US" sz="1550" dirty="0"/>
+          </a:p>
+        </p:txBody>
+      </p:sp>
+      <p:sp>
+        <p:nvSpPr>
+          <p:cNvPr id="19" name="Text 13"/>
+          <p:cNvSpPr/>
+          <p:nvPr/>
+        </p:nvSpPr>
+        <p:spPr>
+          <a:xfrm>
+            <a:off x="987552" y="4901184"/>
+            <a:ext cx="4846320" cy="1143000"/>
           </a:xfrm>
           <a:prstGeom prst="rect">
             <a:avLst/>
@@ -11526,14 +10934,15 @@
           <a:bodyPr wrap="square" lIns="0" tIns="0" rIns="0" bIns="0" rtlCol="0" anchor="t"/>
           <a:lstStyle/>
           <a:p>
-            <a:pPr indent="0" marL="0">
-              <a:lnSpc>
-                <a:spcPct val="105000"/>
-              </a:lnSpc>
-              <a:buNone/>
-            </a:pPr>
-            <a:r>
-              <a:rPr lang="en-US" sz="1150" dirty="0">
+            <a:pPr algn="l" marL="127000" indent="-127000">
+              <a:spcAft>
+                <a:spcPts val="400"/>
+              </a:spcAft>
+              <a:buSzPct val="100000"/>
+              <a:buChar char="•"/>
+            </a:pPr>
+            <a:r>
+              <a:rPr lang="en-US" sz="1100" dirty="0">
                 <a:solidFill>
                   <a:srgbClr val="1E2A33"/>
                 </a:solidFill>
@@ -11541,9 +10950,159 @@
                 <a:ea typeface="Garamond" pitchFamily="34" charset="-122"/>
                 <a:cs typeface="Garamond" pitchFamily="34" charset="-120"/>
               </a:rPr>
-              <a:t>Design, analysis, assembly, and environmental test services for complex space systems, from JWST to next generation observatories.</a:t>
-            </a:r>
-            <a:endParaRPr lang="en-US" sz="1150" dirty="0"/>
+              <a:t>Orbital solar power platforms, power plants in space</a:t>
+            </a:r>
+            <a:endParaRPr lang="en-US" sz="1100" dirty="0"/>
+          </a:p>
+          <a:p>
+            <a:pPr algn="l" marL="127000" indent="-127000">
+              <a:spcAft>
+                <a:spcPts val="400"/>
+              </a:spcAft>
+              <a:buSzPct val="100000"/>
+              <a:buChar char="•"/>
+            </a:pPr>
+            <a:r>
+              <a:rPr lang="en-US" sz="1100" dirty="0">
+                <a:solidFill>
+                  <a:srgbClr val="1E2A33"/>
+                </a:solidFill>
+                <a:latin typeface="Garamond" pitchFamily="34" charset="0"/>
+                <a:ea typeface="Garamond" pitchFamily="34" charset="-122"/>
+                <a:cs typeface="Garamond" pitchFamily="34" charset="-120"/>
+              </a:rPr>
+              <a:t>Wireless energy transmission designed to beam solar energy from orbit to Earth</a:t>
+            </a:r>
+            <a:endParaRPr lang="en-US" sz="1100" dirty="0"/>
+          </a:p>
+        </p:txBody>
+      </p:sp>
+      <p:sp>
+        <p:nvSpPr>
+          <p:cNvPr id="20" name="Shape 4"/>
+          <p:cNvSpPr/>
+          <p:nvPr/>
+        </p:nvSpPr>
+        <p:spPr>
+          <a:xfrm>
+            <a:off x="6190488" y="4114800"/>
+            <a:ext cx="5175504" cy="2057400"/>
+          </a:xfrm>
+          <a:prstGeom prst="roundRect">
+            <a:avLst>
+              <a:gd name="adj" fmla="val 1724"/>
+            </a:avLst>
+          </a:prstGeom>
+          <a:solidFill>
+            <a:srgbClr val="F3F7FA"/>
+          </a:solidFill>
+          <a:ln/>
+        </p:spPr>
+        <p:txBody>
+          <a:bodyPr/>
+          <a:p/>
+        </p:txBody>
+      </p:sp>
+      <p:sp>
+        <p:nvSpPr>
+          <p:cNvPr id="21" name="Text 12"/>
+          <p:cNvSpPr/>
+          <p:nvPr/>
+        </p:nvSpPr>
+        <p:spPr>
+          <a:xfrm>
+            <a:off x="6355080" y="4261104"/>
+            <a:ext cx="4846320" cy="566928"/>
+          </a:xfrm>
+          <a:prstGeom prst="rect">
+            <a:avLst/>
+          </a:prstGeom>
+          <a:noFill/>
+          <a:ln/>
+        </p:spPr>
+        <p:txBody>
+          <a:bodyPr wrap="square" lIns="0" tIns="0" rIns="0" bIns="0" rtlCol="0" anchor="ctr"/>
+          <a:lstStyle/>
+          <a:p>
+            <a:pPr indent="0" marL="0">
+              <a:buNone/>
+            </a:pPr>
+            <a:r>
+              <a:rPr lang="en-US" sz="1550" b="1" dirty="0">
+                <a:solidFill>
+                  <a:srgbClr val="10222F"/>
+                </a:solidFill>
+                <a:latin typeface="Garamond" pitchFamily="34" charset="0"/>
+                <a:ea typeface="Garamond" pitchFamily="34" charset="-122"/>
+                <a:cs typeface="Garamond" pitchFamily="34" charset="-120"/>
+              </a:rPr>
+              <a:t>Future Manufacturing and Licensing</a:t>
+            </a:r>
+            <a:endParaRPr lang="en-US" sz="1550" dirty="0"/>
+          </a:p>
+        </p:txBody>
+      </p:sp>
+      <p:sp>
+        <p:nvSpPr>
+          <p:cNvPr id="22" name="Text 13"/>
+          <p:cNvSpPr/>
+          <p:nvPr/>
+        </p:nvSpPr>
+        <p:spPr>
+          <a:xfrm>
+            <a:off x="6355080" y="4901184"/>
+            <a:ext cx="4846320" cy="1143000"/>
+          </a:xfrm>
+          <a:prstGeom prst="rect">
+            <a:avLst/>
+          </a:prstGeom>
+          <a:noFill/>
+          <a:ln/>
+        </p:spPr>
+        <p:txBody>
+          <a:bodyPr wrap="square" lIns="0" tIns="0" rIns="0" bIns="0" rtlCol="0" anchor="t"/>
+          <a:lstStyle/>
+          <a:p>
+            <a:pPr algn="l" marL="127000" indent="-127000">
+              <a:spcAft>
+                <a:spcPts val="400"/>
+              </a:spcAft>
+              <a:buSzPct val="100000"/>
+              <a:buChar char="•"/>
+            </a:pPr>
+            <a:r>
+              <a:rPr lang="en-US" sz="1100" dirty="0">
+                <a:solidFill>
+                  <a:srgbClr val="1E2A33"/>
+                </a:solidFill>
+                <a:latin typeface="Garamond" pitchFamily="34" charset="0"/>
+                <a:ea typeface="Garamond" pitchFamily="34" charset="-122"/>
+                <a:cs typeface="Garamond" pitchFamily="34" charset="-120"/>
+              </a:rPr>
+              <a:t>Mass production of space qualified hardware</a:t>
+            </a:r>
+            <a:endParaRPr lang="en-US" sz="1100" dirty="0"/>
+          </a:p>
+          <a:p>
+            <a:pPr algn="l" marL="127000" indent="-127000">
+              <a:spcAft>
+                <a:spcPts val="400"/>
+              </a:spcAft>
+              <a:buSzPct val="100000"/>
+              <a:buChar char="•"/>
+            </a:pPr>
+            <a:r>
+              <a:rPr lang="en-US" sz="1100" dirty="0">
+                <a:solidFill>
+                  <a:srgbClr val="1E2A33"/>
+                </a:solidFill>
+                <a:latin typeface="Garamond" pitchFamily="34" charset="0"/>
+                <a:ea typeface="Garamond" pitchFamily="34" charset="-122"/>
+                <a:cs typeface="Garamond" pitchFamily="34" charset="-120"/>
+              </a:rPr>
+              <a:t>Licensing of proprietary space technologies</a:t>
+            </a:r>
+            <a:endParaRPr lang="en-US" sz="1100" dirty="0"/>
           </a:p>
         </p:txBody>
       </p:sp>
@@ -11804,6 +11363,10 @@
             <a:prstDash val="solid"/>
           </a:ln>
         </p:spPr>
+        <p:txBody>
+          <a:bodyPr/>
+          <a:p/>
+        </p:txBody>
       </p:sp>
       <p:sp>
         <p:nvSpPr>
@@ -11928,6 +11491,10 @@
             <a:prstDash val="solid"/>
           </a:ln>
         </p:spPr>
+        <p:txBody>
+          <a:bodyPr/>
+          <a:p/>
+        </p:txBody>
       </p:sp>
       <p:sp>
         <p:nvSpPr>
@@ -12052,6 +11619,10 @@
             <a:prstDash val="solid"/>
           </a:ln>
         </p:spPr>
+        <p:txBody>
+          <a:bodyPr/>
+          <a:p/>
+        </p:txBody>
       </p:sp>
       <p:sp>
         <p:nvSpPr>
@@ -12176,6 +11747,10 @@
             <a:prstDash val="solid"/>
           </a:ln>
         </p:spPr>
+        <p:txBody>
+          <a:bodyPr/>
+          <a:p/>
+        </p:txBody>
       </p:sp>
       <p:sp>
         <p:nvSpPr>
@@ -12300,6 +11875,10 @@
             <a:prstDash val="solid"/>
           </a:ln>
         </p:spPr>
+        <p:txBody>
+          <a:bodyPr/>
+          <a:p/>
+        </p:txBody>
       </p:sp>
       <p:sp>
         <p:nvSpPr>
@@ -12424,6 +12003,10 @@
             <a:prstDash val="solid"/>
           </a:ln>
         </p:spPr>
+        <p:txBody>
+          <a:bodyPr/>
+          <a:p/>
+        </p:txBody>
       </p:sp>
       <p:sp>
         <p:nvSpPr>
@@ -12775,6 +12358,10 @@
           </a:solidFill>
           <a:ln/>
         </p:spPr>
+        <p:txBody>
+          <a:bodyPr/>
+          <a:p/>
+        </p:txBody>
       </p:sp>
       <p:sp>
         <p:nvSpPr>
@@ -12860,6 +12447,10 @@
             <a:prstDash val="solid"/>
           </a:ln>
         </p:spPr>
+        <p:txBody>
+          <a:bodyPr/>
+          <a:p/>
+        </p:txBody>
       </p:sp>
       <p:sp>
         <p:nvSpPr>
@@ -13027,6 +12618,10 @@
           </a:solidFill>
           <a:ln/>
         </p:spPr>
+        <p:txBody>
+          <a:bodyPr/>
+          <a:p/>
+        </p:txBody>
       </p:sp>
       <p:sp>
         <p:nvSpPr>
@@ -13112,6 +12707,10 @@
             <a:prstDash val="solid"/>
           </a:ln>
         </p:spPr>
+        <p:txBody>
+          <a:bodyPr/>
+          <a:p/>
+        </p:txBody>
       </p:sp>
       <p:sp>
         <p:nvSpPr>
@@ -13303,6 +12902,10 @@
             <a:prstDash val="solid"/>
           </a:ln>
         </p:spPr>
+        <p:txBody>
+          <a:bodyPr/>
+          <a:p/>
+        </p:txBody>
       </p:sp>
       <p:sp>
         <p:nvSpPr>
@@ -14776,6 +14379,10 @@
             <a:prstDash val="solid"/>
           </a:ln>
         </p:spPr>
+        <p:txBody>
+          <a:bodyPr/>
+          <a:p/>
+        </p:txBody>
       </p:sp>
       <p:sp>
         <p:nvSpPr>
@@ -14861,6 +14468,10 @@
             <a:prstDash val="solid"/>
           </a:ln>
         </p:spPr>
+        <p:txBody>
+          <a:bodyPr/>
+          <a:p/>
+        </p:txBody>
       </p:sp>
       <p:sp>
         <p:nvSpPr>
@@ -15644,6 +15255,10 @@
           </a:solidFill>
           <a:ln/>
         </p:spPr>
+        <p:txBody>
+          <a:bodyPr/>
+          <a:p/>
+        </p:txBody>
       </p:sp>
       <p:sp>
         <p:nvSpPr>
@@ -15835,6 +15450,10 @@
             <a:prstDash val="solid"/>
           </a:ln>
         </p:spPr>
+        <p:txBody>
+          <a:bodyPr/>
+          <a:p/>
+        </p:txBody>
       </p:sp>
       <p:sp>
         <p:nvSpPr>
@@ -15920,6 +15539,10 @@
             <a:prstDash val="solid"/>
           </a:ln>
         </p:spPr>
+        <p:txBody>
+          <a:bodyPr/>
+          <a:p/>
+        </p:txBody>
       </p:sp>
     </p:spTree>
   </p:cSld>
@@ -16359,6 +15982,10 @@
           </a:solidFill>
           <a:ln/>
         </p:spPr>
+        <p:txBody>
+          <a:bodyPr/>
+          <a:p/>
+        </p:txBody>
       </p:sp>
       <p:sp>
         <p:nvSpPr>
@@ -16529,6 +16156,10 @@
             <a:prstDash val="solid"/>
           </a:ln>
         </p:spPr>
+        <p:txBody>
+          <a:bodyPr/>
+          <a:p/>
+        </p:txBody>
       </p:sp>
       <p:sp>
         <p:nvSpPr>
@@ -17324,6 +16955,10 @@
           </a:solidFill>
           <a:ln/>
         </p:spPr>
+        <p:txBody>
+          <a:bodyPr/>
+          <a:p/>
+        </p:txBody>
       </p:sp>
       <p:pic>
         <p:nvPicPr>
@@ -17370,6 +17005,10 @@
             <a:prstDash val="solid"/>
           </a:ln>
         </p:spPr>
+        <p:txBody>
+          <a:bodyPr/>
+          <a:p/>
+        </p:txBody>
       </p:sp>
       <p:sp>
         <p:nvSpPr>
@@ -17473,6 +17112,10 @@
           </a:solidFill>
           <a:ln/>
         </p:spPr>
+        <p:txBody>
+          <a:bodyPr/>
+          <a:p/>
+        </p:txBody>
       </p:sp>
       <p:pic>
         <p:nvPicPr>
@@ -17519,6 +17162,10 @@
             <a:prstDash val="solid"/>
           </a:ln>
         </p:spPr>
+        <p:txBody>
+          <a:bodyPr/>
+          <a:p/>
+        </p:txBody>
       </p:sp>
       <p:sp>
         <p:nvSpPr>
@@ -17622,6 +17269,10 @@
           </a:solidFill>
           <a:ln/>
         </p:spPr>
+        <p:txBody>
+          <a:bodyPr/>
+          <a:p/>
+        </p:txBody>
       </p:sp>
       <p:pic>
         <p:nvPicPr>
@@ -17668,6 +17319,10 @@
             <a:prstDash val="solid"/>
           </a:ln>
         </p:spPr>
+        <p:txBody>
+          <a:bodyPr/>
+          <a:p/>
+        </p:txBody>
       </p:sp>
       <p:sp>
         <p:nvSpPr>
@@ -17771,6 +17426,10 @@
           </a:solidFill>
           <a:ln/>
         </p:spPr>
+        <p:txBody>
+          <a:bodyPr/>
+          <a:p/>
+        </p:txBody>
       </p:sp>
       <p:pic>
         <p:nvPicPr>
@@ -17817,6 +17476,10 @@
             <a:prstDash val="solid"/>
           </a:ln>
         </p:spPr>
+        <p:txBody>
+          <a:bodyPr/>
+          <a:p/>
+        </p:txBody>
       </p:sp>
       <p:sp>
         <p:nvSpPr>

</xml_diff>

<commit_message>
Rework market slide: sourced 2-bar chart and TAM/SAM/SOM funnel
Co-authored-by: anthonyleedu <anthonyleedu@users.noreply.github.com>
</commit_message>
<xml_diff>
--- a/Heliospace_Investor_Overview.pptx
+++ b/Heliospace_Investor_Overview.pptx
@@ -181,37 +181,29 @@
             <c:showLeaderLines val="0"/>
           </c:dLbls>
           <c:cat>
-            <c:multiLvlStrRef>
-              <c:f>Sheet1!$A$2:$A$4</c:f>
-              <c:multiLvlStrCache>
-                <c:ptCount val="3"/>
-                <c:lvl>
-                  <c:pt idx="0">
-                    <c:v>2000</c:v>
-                  </c:pt>
-                  <c:pt idx="1">
-                    <c:v>2023</c:v>
-                  </c:pt>
-                  <c:pt idx="2">
-                    <c:v>2035E</c:v>
-                  </c:pt>
-                </c:lvl>
-              </c:multiLvlStrCache>
-            </c:multiLvlStrRef>
+            <c:strRef>
+              <c:f>Sheet1!$A$2:$A$3</c:f>
+              <c:strCache>
+                <c:ptCount val="2"/>
+                <c:pt idx="0">
+                  <c:v>2023</c:v>
+                </c:pt>
+                <c:pt idx="1">
+                  <c:v>2035E</c:v>
+                </c:pt>
+              </c:strCache>
+            </c:strRef>
           </c:cat>
           <c:val>
             <c:numRef>
-              <c:f>Sheet1!$B$2:$B$4</c:f>
+              <c:f>Sheet1!$B$2:$B$3</c:f>
               <c:numCache>
                 <c:formatCode>General</c:formatCode>
-                <c:ptCount val="3"/>
+                <c:ptCount val="2"/>
                 <c:pt idx="0">
-                  <c:v>130</c:v>
+                  <c:v>630</c:v>
                 </c:pt>
                 <c:pt idx="1">
-                  <c:v>630</c:v>
-                </c:pt>
-                <c:pt idx="2">
                   <c:v>1800</c:v>
                 </c:pt>
               </c:numCache>
@@ -3609,7 +3601,7 @@
                 <a:ea typeface="Garamond" pitchFamily="34" charset="-122"/>
                 <a:cs typeface="Garamond" pitchFamily="34" charset="-120"/>
               </a:rPr>
-              <a:t>Global space economy: forecast to reach $1.8 trillion by 2035 (USD billions)</a:t>
+              <a:t>Global space economy, USD billions</a:t>
             </a:r>
             <a:endParaRPr lang="en-US" sz="1300" dirty="0"/>
           </a:p>
@@ -3672,14 +3664,14 @@
       </p:sp>
       <p:sp>
         <p:nvSpPr>
-          <p:cNvPr id="10" name="Text 6"/>
-          <p:cNvSpPr/>
-          <p:nvPr/>
-        </p:nvSpPr>
-        <p:spPr>
-          <a:xfrm>
-            <a:off x="7178040" y="1554480"/>
-            <a:ext cx="4114800" cy="548640"/>
+          <p:cNvPr id="12" name="Text 8"/>
+          <p:cNvSpPr/>
+          <p:nvPr/>
+        </p:nvSpPr>
+        <p:spPr>
+          <a:xfrm>
+            <a:off x="7178040" y="1481328"/>
+            <a:ext cx="4160520" cy="274320"/>
           </a:xfrm>
           <a:prstGeom prst="rect">
             <a:avLst/>
@@ -3695,7 +3687,72 @@
               <a:buNone/>
             </a:pPr>
             <a:r>
-              <a:rPr lang="en-US" sz="3400" b="1" dirty="0">
+              <a:rPr lang="en-US" sz="1350" b="1" dirty="0">
+                <a:solidFill>
+                  <a:srgbClr val="10222F"/>
+                </a:solidFill>
+                <a:latin typeface="Garamond" pitchFamily="34" charset="0"/>
+                <a:ea typeface="Garamond" pitchFamily="34" charset="-122"/>
+                <a:cs typeface="Garamond" pitchFamily="34" charset="-120"/>
+              </a:rPr>
+              <a:t>Addressable market, top down</a:t>
+            </a:r>
+            <a:endParaRPr lang="en-US" sz="1350" dirty="0"/>
+          </a:p>
+        </p:txBody>
+      </p:sp>
+      <p:sp>
+        <p:nvSpPr>
+          <p:cNvPr id="13" name="Shape 4"/>
+          <p:cNvSpPr/>
+          <p:nvPr/>
+        </p:nvSpPr>
+        <p:spPr>
+          <a:xfrm>
+            <a:off x="7178040" y="1847088"/>
+            <a:ext cx="4160520" cy="1097280"/>
+          </a:xfrm>
+          <a:prstGeom prst="roundRect">
+            <a:avLst>
+              <a:gd name="adj" fmla="val 1724"/>
+            </a:avLst>
+          </a:prstGeom>
+          <a:solidFill>
+            <a:srgbClr val="F3F7FA"/>
+          </a:solidFill>
+          <a:ln/>
+        </p:spPr>
+        <p:txBody>
+          <a:bodyPr/>
+          <a:p/>
+        </p:txBody>
+      </p:sp>
+      <p:sp>
+        <p:nvSpPr>
+          <p:cNvPr id="14" name="Text 5"/>
+          <p:cNvSpPr/>
+          <p:nvPr/>
+        </p:nvSpPr>
+        <p:spPr>
+          <a:xfrm>
+            <a:off x="7315200" y="1938528"/>
+            <a:ext cx="3886200" cy="329184"/>
+          </a:xfrm>
+          <a:prstGeom prst="rect">
+            <a:avLst/>
+          </a:prstGeom>
+          <a:noFill/>
+          <a:ln/>
+        </p:spPr>
+        <p:txBody>
+          <a:bodyPr wrap="square" lIns="0" tIns="0" rIns="0" bIns="0" rtlCol="0" anchor="ctr"/>
+          <a:lstStyle/>
+          <a:p>
+            <a:pPr indent="0" marL="0">
+              <a:buNone/>
+            </a:pPr>
+            <a:r>
+              <a:rPr lang="en-US" sz="1050" b="1" dirty="0">
                 <a:solidFill>
                   <a:srgbClr val="007BCB"/>
                 </a:solidFill>
@@ -3703,38 +3760,77 @@
                 <a:ea typeface="Garamond" pitchFamily="34" charset="-122"/>
                 <a:cs typeface="Garamond" pitchFamily="34" charset="-120"/>
               </a:rPr>
-              <a:t>16,900</a:t>
-            </a:r>
-            <a:endParaRPr lang="en-US" sz="3400" dirty="0"/>
-          </a:p>
-        </p:txBody>
-      </p:sp>
-      <p:sp>
-        <p:nvSpPr>
-          <p:cNvPr id="11" name="Text 7"/>
-          <p:cNvSpPr/>
-          <p:nvPr/>
-        </p:nvSpPr>
-        <p:spPr>
-          <a:xfrm>
-            <a:off x="7178040" y="2121408"/>
-            <a:ext cx="4069080" cy="502920"/>
-          </a:xfrm>
-          <a:prstGeom prst="rect">
-            <a:avLst/>
-          </a:prstGeom>
-          <a:noFill/>
-          <a:ln/>
-        </p:spPr>
-        <p:txBody>
-          <a:bodyPr wrap="square" lIns="0" tIns="0" rIns="0" bIns="0" rtlCol="0" anchor="t"/>
-          <a:lstStyle/>
-          <a:p>
-            <a:pPr indent="0" marL="0">
-              <a:buNone/>
-            </a:pPr>
-            <a:r>
-              <a:rPr lang="en-US" sz="1100" dirty="0">
+              <a:t>TAM: TOTAL SPACE ECONOMY</a:t>
+            </a:r>
+            <a:endParaRPr lang="en-US" sz="1050" dirty="0"/>
+          </a:p>
+        </p:txBody>
+      </p:sp>
+      <p:sp>
+        <p:nvSpPr>
+          <p:cNvPr id="15" name="Text 12"/>
+          <p:cNvSpPr/>
+          <p:nvPr/>
+        </p:nvSpPr>
+        <p:spPr>
+          <a:xfrm>
+            <a:off x="7315200" y="2194560"/>
+            <a:ext cx="3886200" cy="274320"/>
+          </a:xfrm>
+          <a:prstGeom prst="rect">
+            <a:avLst/>
+          </a:prstGeom>
+          <a:noFill/>
+          <a:ln/>
+        </p:spPr>
+        <p:txBody>
+          <a:bodyPr wrap="square" lIns="0" tIns="0" rIns="0" bIns="0" rtlCol="0" anchor="ctr"/>
+          <a:lstStyle/>
+          <a:p>
+            <a:pPr indent="0" marL="0">
+              <a:buNone/>
+            </a:pPr>
+            <a:r>
+              <a:rPr lang="en-US" sz="1550" b="1" dirty="0">
+                <a:solidFill>
+                  <a:srgbClr val="10222F"/>
+                </a:solidFill>
+                <a:latin typeface="Garamond" pitchFamily="34" charset="0"/>
+                <a:ea typeface="Garamond" pitchFamily="34" charset="-122"/>
+                <a:cs typeface="Garamond" pitchFamily="34" charset="-120"/>
+              </a:rPr>
+              <a:t>$1.8 trillion by 2035E</a:t>
+            </a:r>
+            <a:endParaRPr lang="en-US" sz="1550" dirty="0"/>
+          </a:p>
+        </p:txBody>
+      </p:sp>
+      <p:sp>
+        <p:nvSpPr>
+          <p:cNvPr id="16" name="Text 6"/>
+          <p:cNvSpPr/>
+          <p:nvPr/>
+        </p:nvSpPr>
+        <p:spPr>
+          <a:xfrm>
+            <a:off x="7315200" y="2487168"/>
+            <a:ext cx="3886200" cy="402336"/>
+          </a:xfrm>
+          <a:prstGeom prst="rect">
+            <a:avLst/>
+          </a:prstGeom>
+          <a:noFill/>
+          <a:ln/>
+        </p:spPr>
+        <p:txBody>
+          <a:bodyPr wrap="square" lIns="0" tIns="0" rIns="0" bIns="0" rtlCol="0" anchor="ctr"/>
+          <a:lstStyle/>
+          <a:p>
+            <a:pPr indent="0" marL="0">
+              <a:buNone/>
+            </a:pPr>
+            <a:r>
+              <a:rPr lang="en-US" sz="950" i="1" dirty="0">
                 <a:solidFill>
                   <a:srgbClr val="5C6B76"/>
                 </a:solidFill>
@@ -3742,22 +3838,48 @@
                 <a:ea typeface="Garamond" pitchFamily="34" charset="-122"/>
                 <a:cs typeface="Garamond" pitchFamily="34" charset="-120"/>
               </a:rPr>
-              <a:t>small satellites forecast for launch between 2026 and 2035 (Novaspace)</a:t>
-            </a:r>
-            <a:endParaRPr lang="en-US" sz="1100" dirty="0"/>
-          </a:p>
-        </p:txBody>
-      </p:sp>
-      <p:sp>
-        <p:nvSpPr>
-          <p:cNvPr id="12" name="Text 8"/>
-          <p:cNvSpPr/>
-          <p:nvPr/>
-        </p:nvSpPr>
-        <p:spPr>
-          <a:xfrm>
-            <a:off x="7178040" y="2880360"/>
-            <a:ext cx="4114800" cy="274320"/>
+              <a:t>Global space economy forecast (World Economic Forum and McKinsey, 2024)</a:t>
+            </a:r>
+            <a:endParaRPr lang="en-US" sz="950" dirty="0"/>
+          </a:p>
+        </p:txBody>
+      </p:sp>
+      <p:sp>
+        <p:nvSpPr>
+          <p:cNvPr id="17" name="Shape 4"/>
+          <p:cNvSpPr/>
+          <p:nvPr/>
+        </p:nvSpPr>
+        <p:spPr>
+          <a:xfrm>
+            <a:off x="7178040" y="3054096"/>
+            <a:ext cx="3840480" cy="1097280"/>
+          </a:xfrm>
+          <a:prstGeom prst="roundRect">
+            <a:avLst>
+              <a:gd name="adj" fmla="val 1724"/>
+            </a:avLst>
+          </a:prstGeom>
+          <a:solidFill>
+            <a:srgbClr val="F3F7FA"/>
+          </a:solidFill>
+          <a:ln/>
+        </p:spPr>
+        <p:txBody>
+          <a:bodyPr/>
+          <a:p/>
+        </p:txBody>
+      </p:sp>
+      <p:sp>
+        <p:nvSpPr>
+          <p:cNvPr id="18" name="Text 5"/>
+          <p:cNvSpPr/>
+          <p:nvPr/>
+        </p:nvSpPr>
+        <p:spPr>
+          <a:xfrm>
+            <a:off x="7315200" y="3145536"/>
+            <a:ext cx="3566160" cy="329184"/>
           </a:xfrm>
           <a:prstGeom prst="rect">
             <a:avLst/>
@@ -3773,7 +3895,46 @@
               <a:buNone/>
             </a:pPr>
             <a:r>
-              <a:rPr lang="en-US" sz="1350" b="1" dirty="0">
+              <a:rPr lang="en-US" sz="1050" b="1" dirty="0">
+                <a:solidFill>
+                  <a:srgbClr val="007BCB"/>
+                </a:solidFill>
+                <a:latin typeface="Garamond" pitchFamily="34" charset="0"/>
+                <a:ea typeface="Garamond" pitchFamily="34" charset="-122"/>
+                <a:cs typeface="Garamond" pitchFamily="34" charset="-120"/>
+              </a:rPr>
+              <a:t>SAM: SATELLITE MANUFACTURING</a:t>
+            </a:r>
+            <a:endParaRPr lang="en-US" sz="1050" dirty="0"/>
+          </a:p>
+        </p:txBody>
+      </p:sp>
+      <p:sp>
+        <p:nvSpPr>
+          <p:cNvPr id="19" name="Text 12"/>
+          <p:cNvSpPr/>
+          <p:nvPr/>
+        </p:nvSpPr>
+        <p:spPr>
+          <a:xfrm>
+            <a:off x="7315200" y="3401568"/>
+            <a:ext cx="3566160" cy="274320"/>
+          </a:xfrm>
+          <a:prstGeom prst="rect">
+            <a:avLst/>
+          </a:prstGeom>
+          <a:noFill/>
+          <a:ln/>
+        </p:spPr>
+        <p:txBody>
+          <a:bodyPr wrap="square" lIns="0" tIns="0" rIns="0" bIns="0" rtlCol="0" anchor="ctr"/>
+          <a:lstStyle/>
+          <a:p>
+            <a:pPr indent="0" marL="0">
+              <a:buNone/>
+            </a:pPr>
+            <a:r>
+              <a:rPr lang="en-US" sz="1550" b="1" dirty="0">
                 <a:solidFill>
                   <a:srgbClr val="10222F"/>
                 </a:solidFill>
@@ -3781,64 +3942,22 @@
                 <a:ea typeface="Garamond" pitchFamily="34" charset="-122"/>
                 <a:cs typeface="Garamond" pitchFamily="34" charset="-120"/>
               </a:rPr>
-              <a:t>Deployables on every platform</a:t>
-            </a:r>
-            <a:endParaRPr lang="en-US" sz="1350" dirty="0"/>
-          </a:p>
-        </p:txBody>
-      </p:sp>
-      <p:sp>
-        <p:nvSpPr>
-          <p:cNvPr id="13" name="Text 9"/>
-          <p:cNvSpPr/>
-          <p:nvPr/>
-        </p:nvSpPr>
-        <p:spPr>
-          <a:xfrm>
-            <a:off x="7178040" y="3182112"/>
-            <a:ext cx="4160520" cy="960120"/>
-          </a:xfrm>
-          <a:prstGeom prst="rect">
-            <a:avLst/>
-          </a:prstGeom>
-          <a:noFill/>
-          <a:ln/>
-        </p:spPr>
-        <p:txBody>
-          <a:bodyPr wrap="square" lIns="0" tIns="0" rIns="0" bIns="0" rtlCol="0" anchor="t"/>
-          <a:lstStyle/>
-          <a:p>
-            <a:pPr indent="0" marL="0">
-              <a:lnSpc>
-                <a:spcPct val="105000"/>
-              </a:lnSpc>
-              <a:buNone/>
-            </a:pPr>
-            <a:r>
-              <a:rPr lang="en-US" sz="1150" dirty="0">
-                <a:solidFill>
-                  <a:srgbClr val="1E2A33"/>
-                </a:solidFill>
-                <a:latin typeface="Garamond" pitchFamily="34" charset="0"/>
-                <a:ea typeface="Garamond" pitchFamily="34" charset="-122"/>
-                <a:cs typeface="Garamond" pitchFamily="34" charset="-120"/>
-              </a:rPr>
-              <a:t>Antennas, sensor booms, and masts must stow small and deploy reliably. Every spacecraft class, from CubeSats to flagship observatories, is an addressable socket for SABER mechanisms.</a:t>
-            </a:r>
-            <a:endParaRPr lang="en-US" sz="1150" dirty="0"/>
-          </a:p>
-        </p:txBody>
-      </p:sp>
-      <p:sp>
-        <p:nvSpPr>
-          <p:cNvPr id="14" name="Text 10"/>
-          <p:cNvSpPr/>
-          <p:nvPr/>
-        </p:nvSpPr>
-        <p:spPr>
-          <a:xfrm>
-            <a:off x="7178040" y="4343400"/>
-            <a:ext cx="4114800" cy="274320"/>
+              <a:t>$20.4 billion in 2025</a:t>
+            </a:r>
+            <a:endParaRPr lang="en-US" sz="1550" dirty="0"/>
+          </a:p>
+        </p:txBody>
+      </p:sp>
+      <p:sp>
+        <p:nvSpPr>
+          <p:cNvPr id="20" name="Text 6"/>
+          <p:cNvSpPr/>
+          <p:nvPr/>
+        </p:nvSpPr>
+        <p:spPr>
+          <a:xfrm>
+            <a:off x="7315200" y="3694176"/>
+            <a:ext cx="3566160" cy="402336"/>
           </a:xfrm>
           <a:prstGeom prst="rect">
             <a:avLst/>
@@ -3854,7 +3973,111 @@
               <a:buNone/>
             </a:pPr>
             <a:r>
-              <a:rPr lang="en-US" sz="1350" b="1" dirty="0">
+              <a:rPr lang="en-US" sz="950" i="1" dirty="0">
+                <a:solidFill>
+                  <a:srgbClr val="5C6B76"/>
+                </a:solidFill>
+                <a:latin typeface="Garamond" pitchFamily="34" charset="0"/>
+                <a:ea typeface="Garamond" pitchFamily="34" charset="-122"/>
+                <a:cs typeface="Garamond" pitchFamily="34" charset="-120"/>
+              </a:rPr>
+              <a:t>Global commercial satellite manufacturing revenue (SIA and BryceTech, 2026)</a:t>
+            </a:r>
+            <a:endParaRPr lang="en-US" sz="950" dirty="0"/>
+          </a:p>
+        </p:txBody>
+      </p:sp>
+      <p:sp>
+        <p:nvSpPr>
+          <p:cNvPr id="21" name="Shape 4"/>
+          <p:cNvSpPr/>
+          <p:nvPr/>
+        </p:nvSpPr>
+        <p:spPr>
+          <a:xfrm>
+            <a:off x="7178040" y="4261104"/>
+            <a:ext cx="3520440" cy="1481328"/>
+          </a:xfrm>
+          <a:prstGeom prst="roundRect">
+            <a:avLst>
+              <a:gd name="adj" fmla="val 1724"/>
+            </a:avLst>
+          </a:prstGeom>
+          <a:solidFill>
+            <a:srgbClr val="F3F7FA"/>
+          </a:solidFill>
+          <a:ln/>
+        </p:spPr>
+        <p:txBody>
+          <a:bodyPr/>
+          <a:p/>
+        </p:txBody>
+      </p:sp>
+      <p:sp>
+        <p:nvSpPr>
+          <p:cNvPr id="22" name="Text 5"/>
+          <p:cNvSpPr/>
+          <p:nvPr/>
+        </p:nvSpPr>
+        <p:spPr>
+          <a:xfrm>
+            <a:off x="7315200" y="4352544"/>
+            <a:ext cx="3246120" cy="329184"/>
+          </a:xfrm>
+          <a:prstGeom prst="rect">
+            <a:avLst/>
+          </a:prstGeom>
+          <a:noFill/>
+          <a:ln/>
+        </p:spPr>
+        <p:txBody>
+          <a:bodyPr wrap="square" lIns="0" tIns="0" rIns="0" bIns="0" rtlCol="0" anchor="ctr"/>
+          <a:lstStyle/>
+          <a:p>
+            <a:pPr indent="0" marL="0">
+              <a:buNone/>
+            </a:pPr>
+            <a:r>
+              <a:rPr lang="en-US" sz="1050" b="1" dirty="0">
+                <a:solidFill>
+                  <a:srgbClr val="007BCB"/>
+                </a:solidFill>
+                <a:latin typeface="Garamond" pitchFamily="34" charset="0"/>
+                <a:ea typeface="Garamond" pitchFamily="34" charset="-122"/>
+                <a:cs typeface="Garamond" pitchFamily="34" charset="-120"/>
+              </a:rPr>
+              <a:t>SOM: DEPLOYABLE BOOMS, ANTENNAS, AND MECHANISMS</a:t>
+            </a:r>
+            <a:endParaRPr lang="en-US" sz="1050" dirty="0"/>
+          </a:p>
+        </p:txBody>
+      </p:sp>
+      <p:sp>
+        <p:nvSpPr>
+          <p:cNvPr id="23" name="Text 12"/>
+          <p:cNvSpPr/>
+          <p:nvPr/>
+        </p:nvSpPr>
+        <p:spPr>
+          <a:xfrm>
+            <a:off x="7315200" y="4718304"/>
+            <a:ext cx="3246120" cy="512064"/>
+          </a:xfrm>
+          <a:prstGeom prst="rect">
+            <a:avLst/>
+          </a:prstGeom>
+          <a:noFill/>
+          <a:ln/>
+        </p:spPr>
+        <p:txBody>
+          <a:bodyPr wrap="square" lIns="0" tIns="0" rIns="0" bIns="0" rtlCol="0" anchor="ctr"/>
+          <a:lstStyle/>
+          <a:p>
+            <a:pPr indent="0" marL="0">
+              <a:buNone/>
+            </a:pPr>
+            <a:r>
+              <a:rPr lang="en-US" sz="1550" b="1" dirty="0">
                 <a:solidFill>
                   <a:srgbClr val="10222F"/>
                 </a:solidFill>
@@ -3862,51 +4085,87 @@
                 <a:ea typeface="Garamond" pitchFamily="34" charset="-122"/>
                 <a:cs typeface="Garamond" pitchFamily="34" charset="-120"/>
               </a:rPr>
-              <a:t>Recurring lunar demand</a:t>
-            </a:r>
-            <a:endParaRPr lang="en-US" sz="1350" dirty="0"/>
-          </a:p>
-        </p:txBody>
-      </p:sp>
-      <p:sp>
-        <p:nvSpPr>
-          <p:cNvPr id="15" name="Text 11"/>
-          <p:cNvSpPr/>
-          <p:nvPr/>
-        </p:nvSpPr>
-        <p:spPr>
-          <a:xfrm>
-            <a:off x="7178040" y="4645152"/>
-            <a:ext cx="4160520" cy="1005840"/>
-          </a:xfrm>
-          <a:prstGeom prst="rect">
-            <a:avLst/>
-          </a:prstGeom>
-          <a:noFill/>
-          <a:ln/>
-        </p:spPr>
-        <p:txBody>
-          <a:bodyPr wrap="square" lIns="0" tIns="0" rIns="0" bIns="0" rtlCol="0" anchor="t"/>
-          <a:lstStyle/>
-          <a:p>
-            <a:pPr indent="0" marL="0">
-              <a:lnSpc>
-                <a:spcPct val="105000"/>
-              </a:lnSpc>
-              <a:buNone/>
-            </a:pPr>
-            <a:r>
-              <a:rPr lang="en-US" sz="1150" dirty="0">
-                <a:solidFill>
-                  <a:srgbClr val="1E2A33"/>
-                </a:solidFill>
-                <a:latin typeface="Garamond" pitchFamily="34" charset="0"/>
-                <a:ea typeface="Garamond" pitchFamily="34" charset="-122"/>
-                <a:cs typeface="Garamond" pitchFamily="34" charset="-120"/>
-              </a:rPr>
-              <a:t>NASA CLPS and commercial lunar programs are creating a repeat purchase market for payload sensors and deployables, with Heliospace hardware already flown on the first landings.</a:t>
-            </a:r>
-            <a:endParaRPr lang="en-US" sz="1150" dirty="0"/>
+              <a:t>16,900 small satellites, 2026 to 2035E</a:t>
+            </a:r>
+            <a:endParaRPr lang="en-US" sz="1550" dirty="0"/>
+          </a:p>
+        </p:txBody>
+      </p:sp>
+      <p:sp>
+        <p:nvSpPr>
+          <p:cNvPr id="24" name="Text 6"/>
+          <p:cNvSpPr/>
+          <p:nvPr/>
+        </p:nvSpPr>
+        <p:spPr>
+          <a:xfrm>
+            <a:off x="7315200" y="5248656"/>
+            <a:ext cx="3246120" cy="457200"/>
+          </a:xfrm>
+          <a:prstGeom prst="rect">
+            <a:avLst/>
+          </a:prstGeom>
+          <a:noFill/>
+          <a:ln/>
+        </p:spPr>
+        <p:txBody>
+          <a:bodyPr wrap="square" lIns="0" tIns="0" rIns="0" bIns="0" rtlCol="0" anchor="ctr"/>
+          <a:lstStyle/>
+          <a:p>
+            <a:pPr indent="0" marL="0">
+              <a:buNone/>
+            </a:pPr>
+            <a:r>
+              <a:rPr lang="en-US" sz="950" i="1" dirty="0">
+                <a:solidFill>
+                  <a:srgbClr val="5C6B76"/>
+                </a:solidFill>
+                <a:latin typeface="Garamond" pitchFamily="34" charset="0"/>
+                <a:ea typeface="Garamond" pitchFamily="34" charset="-122"/>
+                <a:cs typeface="Garamond" pitchFamily="34" charset="-120"/>
+              </a:rPr>
+              <a:t>Forecast for launch (Novaspace). No independent estimate is published for this niche; it is presented qualitatively.</a:t>
+            </a:r>
+            <a:endParaRPr lang="en-US" sz="950" dirty="0"/>
+          </a:p>
+        </p:txBody>
+      </p:sp>
+      <p:sp>
+        <p:nvSpPr>
+          <p:cNvPr id="25" name="Text 5"/>
+          <p:cNvSpPr/>
+          <p:nvPr/>
+        </p:nvSpPr>
+        <p:spPr>
+          <a:xfrm>
+            <a:off x="7178040" y="5897880"/>
+            <a:ext cx="4160520" cy="411480"/>
+          </a:xfrm>
+          <a:prstGeom prst="rect">
+            <a:avLst/>
+          </a:prstGeom>
+          <a:noFill/>
+          <a:ln/>
+        </p:spPr>
+        <p:txBody>
+          <a:bodyPr wrap="square" lIns="0" tIns="0" rIns="0" bIns="0" rtlCol="0" anchor="ctr"/>
+          <a:lstStyle/>
+          <a:p>
+            <a:pPr indent="0" marL="0">
+              <a:buNone/>
+            </a:pPr>
+            <a:r>
+              <a:rPr lang="en-US" sz="900" i="1" dirty="0">
+                <a:solidFill>
+                  <a:srgbClr val="5C6B76"/>
+                </a:solidFill>
+                <a:latin typeface="Garamond" pitchFamily="34" charset="0"/>
+                <a:ea typeface="Garamond" pitchFamily="34" charset="-122"/>
+                <a:cs typeface="Garamond" pitchFamily="34" charset="-120"/>
+              </a:rPr>
+              <a:t>Sources: World Economic Forum and McKinsey, 2024; SIA and BryceTech, State of the Satellite Industry Report, 2026; Novaspace, Satellites to be Built and Launched, 2025.</a:t>
+            </a:r>
+            <a:endParaRPr lang="en-US" sz="900" dirty="0"/>
           </a:p>
         </p:txBody>
       </p:sp>
@@ -9104,7 +9363,7 @@
 </p:sld>
 </file>
 
-<file path=ppt/slides/slide18.xml><?xml version="1.0" encoding="utf-8"?>
+<file path=ppt/slides/slide17.xml><?xml version="1.0" encoding="utf-8"?>
 <p:sld xmlns:a="http://schemas.openxmlformats.org/drawingml/2006/main" xmlns:r="http://schemas.openxmlformats.org/officeDocument/2006/relationships" xmlns:p="http://schemas.openxmlformats.org/presentationml/2006/main">
   <p:cSld name="Slide 16">
     <p:spTree>

</xml_diff>

<commit_message>
Use full company profile, product line, and why-customers-choose content
Co-authored-by: anthonyleedu <anthonyleedu@users.noreply.github.com>
</commit_message>
<xml_diff>
--- a/Heliospace_Investor_Overview.pptx
+++ b/Heliospace_Investor_Overview.pptx
@@ -4383,7 +4383,7 @@
       </p:sp>
       <p:sp>
         <p:nvSpPr>
-          <p:cNvPr id="7" name="Shape 4"/>
+          <p:cNvPr id="30" name="Shape 4"/>
           <p:cNvSpPr/>
           <p:nvPr/>
         </p:nvSpPr>
@@ -4407,7 +4407,7 @@
       </p:sp>
       <p:sp>
         <p:nvSpPr>
-          <p:cNvPr id="8" name="Text 5"/>
+          <p:cNvPr id="31" name="Text 5"/>
           <p:cNvSpPr/>
           <p:nvPr/>
         </p:nvSpPr>
@@ -4446,14 +4446,14 @@
       </p:sp>
       <p:sp>
         <p:nvSpPr>
-          <p:cNvPr id="9" name="Text 6"/>
+          <p:cNvPr id="32" name="Text 6"/>
           <p:cNvSpPr/>
           <p:nvPr/>
         </p:nvSpPr>
         <p:spPr>
           <a:xfrm>
             <a:off x="1325880" y="1417320"/>
-            <a:ext cx="5120640" cy="274320"/>
+            <a:ext cx="4617720" cy="274320"/>
           </a:xfrm>
           <a:prstGeom prst="rect">
             <a:avLst/>
@@ -4485,14 +4485,14 @@
       </p:sp>
       <p:sp>
         <p:nvSpPr>
-          <p:cNvPr id="10" name="Text 7"/>
-          <p:cNvSpPr/>
-          <p:nvPr/>
-        </p:nvSpPr>
-        <p:spPr>
-          <a:xfrm>
-            <a:off x="1325880" y="1728216"/>
-            <a:ext cx="5166360" cy="658368"/>
+          <p:cNvPr id="33" name="Text 7"/>
+          <p:cNvSpPr/>
+          <p:nvPr/>
+        </p:nvSpPr>
+        <p:spPr>
+          <a:xfrm>
+            <a:off x="1325880" y="1700784"/>
+            <a:ext cx="4617720" cy="1280160"/>
           </a:xfrm>
           <a:prstGeom prst="rect">
             <a:avLst/>
@@ -4519,7 +4519,7 @@
                 <a:ea typeface="Garamond" pitchFamily="34" charset="-122"/>
                 <a:cs typeface="Garamond" pitchFamily="34" charset="-120"/>
               </a:rPr>
-              <a:t>More than 40 space flight missions and more than 125 instruments and systems built and deployed, including hardware on NASA's Europa Clipper and support for the James Webb Space Telescope.</a:t>
+              <a:t>Helio has supported more than 40 space flight missions and built and deployed more than 125 instruments and systems, giving customers confidence that its hardware can survive demanding space environments. Its technology has been used on major missions, including NASA's Europa Clipper and support activities related to the James Webb Space Telescope.</a:t>
             </a:r>
             <a:endParaRPr lang="en-US" sz="1100" dirty="0"/>
           </a:p>
@@ -4527,13 +4527,13 @@
       </p:sp>
       <p:sp>
         <p:nvSpPr>
-          <p:cNvPr id="11" name="Shape 8"/>
-          <p:cNvSpPr/>
-          <p:nvPr/>
-        </p:nvSpPr>
-        <p:spPr>
-          <a:xfrm>
-            <a:off x="822960" y="2414016"/>
+          <p:cNvPr id="34" name="Shape 4"/>
+          <p:cNvSpPr/>
+          <p:nvPr/>
+        </p:nvSpPr>
+        <p:spPr>
+          <a:xfrm>
+            <a:off x="822960" y="3154680"/>
             <a:ext cx="347472" cy="347472"/>
           </a:xfrm>
           <a:prstGeom prst="ellipse">
@@ -4551,13 +4551,13 @@
       </p:sp>
       <p:sp>
         <p:nvSpPr>
-          <p:cNvPr id="12" name="Text 9"/>
-          <p:cNvSpPr/>
-          <p:nvPr/>
-        </p:nvSpPr>
-        <p:spPr>
-          <a:xfrm>
-            <a:off x="822960" y="2414016"/>
+          <p:cNvPr id="35" name="Text 5"/>
+          <p:cNvSpPr/>
+          <p:nvPr/>
+        </p:nvSpPr>
+        <p:spPr>
+          <a:xfrm>
+            <a:off x="822960" y="3154680"/>
             <a:ext cx="347472" cy="347472"/>
           </a:xfrm>
           <a:prstGeom prst="rect">
@@ -4590,14 +4590,14 @@
       </p:sp>
       <p:sp>
         <p:nvSpPr>
-          <p:cNvPr id="13" name="Text 10"/>
-          <p:cNvSpPr/>
-          <p:nvPr/>
-        </p:nvSpPr>
-        <p:spPr>
-          <a:xfrm>
-            <a:off x="1325880" y="2386584"/>
-            <a:ext cx="5120640" cy="274320"/>
+          <p:cNvPr id="36" name="Text 6"/>
+          <p:cNvSpPr/>
+          <p:nvPr/>
+        </p:nvSpPr>
+        <p:spPr>
+          <a:xfrm>
+            <a:off x="1325880" y="3127248"/>
+            <a:ext cx="4617720" cy="274320"/>
           </a:xfrm>
           <a:prstGeom prst="rect">
             <a:avLst/>
@@ -4629,14 +4629,14 @@
       </p:sp>
       <p:sp>
         <p:nvSpPr>
-          <p:cNvPr id="14" name="Text 11"/>
-          <p:cNvSpPr/>
-          <p:nvPr/>
-        </p:nvSpPr>
-        <p:spPr>
-          <a:xfrm>
-            <a:off x="1325880" y="2697480"/>
-            <a:ext cx="5166360" cy="658368"/>
+          <p:cNvPr id="37" name="Text 7"/>
+          <p:cNvSpPr/>
+          <p:nvPr/>
+        </p:nvSpPr>
+        <p:spPr>
+          <a:xfrm>
+            <a:off x="1325880" y="3410712"/>
+            <a:ext cx="4617720" cy="1280160"/>
           </a:xfrm>
           <a:prstGeom prst="rect">
             <a:avLst/>
@@ -4663,7 +4663,7 @@
                 <a:ea typeface="Garamond" pitchFamily="34" charset="-122"/>
                 <a:cs typeface="Garamond" pitchFamily="34" charset="-120"/>
               </a:rPr>
-              <a:t>Custom deployable antennas, sensors, large deployable structures, spacecraft mechanisms, and systems engineering, built to work reliably in extreme conditions where repair is impossible.</a:t>
+              <a:t>Space missions often require custom solutions rather than off the shelf products. Helio focuses on deployable antennas, sensors, large deployable structures, spacecraft mechanisms, and systems engineering and design. Customers choose Helio because these components must work reliably in extreme conditions where repair is impossible.</a:t>
             </a:r>
             <a:endParaRPr lang="en-US" sz="1100" dirty="0"/>
           </a:p>
@@ -4671,13 +4671,13 @@
       </p:sp>
       <p:sp>
         <p:nvSpPr>
-          <p:cNvPr id="15" name="Shape 12"/>
-          <p:cNvSpPr/>
-          <p:nvPr/>
-        </p:nvSpPr>
-        <p:spPr>
-          <a:xfrm>
-            <a:off x="822960" y="3383280"/>
+          <p:cNvPr id="38" name="Shape 4"/>
+          <p:cNvSpPr/>
+          <p:nvPr/>
+        </p:nvSpPr>
+        <p:spPr>
+          <a:xfrm>
+            <a:off x="822960" y="4864608"/>
             <a:ext cx="347472" cy="347472"/>
           </a:xfrm>
           <a:prstGeom prst="ellipse">
@@ -4695,13 +4695,13 @@
       </p:sp>
       <p:sp>
         <p:nvSpPr>
-          <p:cNvPr id="16" name="Text 13"/>
-          <p:cNvSpPr/>
-          <p:nvPr/>
-        </p:nvSpPr>
-        <p:spPr>
-          <a:xfrm>
-            <a:off x="822960" y="3383280"/>
+          <p:cNvPr id="39" name="Text 5"/>
+          <p:cNvSpPr/>
+          <p:nvPr/>
+        </p:nvSpPr>
+        <p:spPr>
+          <a:xfrm>
+            <a:off x="822960" y="4864608"/>
             <a:ext cx="347472" cy="347472"/>
           </a:xfrm>
           <a:prstGeom prst="rect">
@@ -4734,14 +4734,14 @@
       </p:sp>
       <p:sp>
         <p:nvSpPr>
-          <p:cNvPr id="17" name="Text 14"/>
-          <p:cNvSpPr/>
-          <p:nvPr/>
-        </p:nvSpPr>
-        <p:spPr>
-          <a:xfrm>
-            <a:off x="1325880" y="3355848"/>
-            <a:ext cx="5120640" cy="274320"/>
+          <p:cNvPr id="40" name="Text 6"/>
+          <p:cNvSpPr/>
+          <p:nvPr/>
+        </p:nvSpPr>
+        <p:spPr>
+          <a:xfrm>
+            <a:off x="1325880" y="4837176"/>
+            <a:ext cx="4617720" cy="274320"/>
           </a:xfrm>
           <a:prstGeom prst="rect">
             <a:avLst/>
@@ -4773,14 +4773,14 @@
       </p:sp>
       <p:sp>
         <p:nvSpPr>
-          <p:cNvPr id="18" name="Text 15"/>
-          <p:cNvSpPr/>
-          <p:nvPr/>
-        </p:nvSpPr>
-        <p:spPr>
-          <a:xfrm>
-            <a:off x="1325880" y="3666744"/>
-            <a:ext cx="5166360" cy="658368"/>
+          <p:cNvPr id="41" name="Text 7"/>
+          <p:cNvSpPr/>
+          <p:nvPr/>
+        </p:nvSpPr>
+        <p:spPr>
+          <a:xfrm>
+            <a:off x="1325880" y="5120640"/>
+            <a:ext cx="4617720" cy="1005840"/>
           </a:xfrm>
           <a:prstGeom prst="rect">
             <a:avLst/>
@@ -4807,7 +4807,7 @@
                 <a:ea typeface="Garamond" pitchFamily="34" charset="-122"/>
                 <a:cs typeface="Garamond" pitchFamily="34" charset="-120"/>
               </a:rPr>
-              <a:t>A record of successful missions and a problem solver approach to difficult hardware challenges reduce technical risk where failure is extremely expensive.</a:t>
+              <a:t>Space agencies and aerospace companies value suppliers with previous successful missions because failures in space are extremely expensive. Helio positions itself as a problem solver for difficult space hardware challenges, helping customers reduce technical risk.</a:t>
             </a:r>
             <a:endParaRPr lang="en-US" sz="1100" dirty="0"/>
           </a:p>
@@ -4815,13 +4815,13 @@
       </p:sp>
       <p:sp>
         <p:nvSpPr>
-          <p:cNvPr id="19" name="Shape 16"/>
-          <p:cNvSpPr/>
-          <p:nvPr/>
-        </p:nvSpPr>
-        <p:spPr>
-          <a:xfrm>
-            <a:off x="822960" y="4352544"/>
+          <p:cNvPr id="42" name="Shape 4"/>
+          <p:cNvSpPr/>
+          <p:nvPr/>
+        </p:nvSpPr>
+        <p:spPr>
+          <a:xfrm>
+            <a:off x="6217920" y="1444752"/>
             <a:ext cx="347472" cy="347472"/>
           </a:xfrm>
           <a:prstGeom prst="ellipse">
@@ -4839,13 +4839,13 @@
       </p:sp>
       <p:sp>
         <p:nvSpPr>
-          <p:cNvPr id="20" name="Text 17"/>
-          <p:cNvSpPr/>
-          <p:nvPr/>
-        </p:nvSpPr>
-        <p:spPr>
-          <a:xfrm>
-            <a:off x="822960" y="4352544"/>
+          <p:cNvPr id="43" name="Text 5"/>
+          <p:cNvSpPr/>
+          <p:nvPr/>
+        </p:nvSpPr>
+        <p:spPr>
+          <a:xfrm>
+            <a:off x="6217920" y="1444752"/>
             <a:ext cx="347472" cy="347472"/>
           </a:xfrm>
           <a:prstGeom prst="rect">
@@ -4878,14 +4878,14 @@
       </p:sp>
       <p:sp>
         <p:nvSpPr>
-          <p:cNvPr id="21" name="Text 18"/>
-          <p:cNvSpPr/>
-          <p:nvPr/>
-        </p:nvSpPr>
-        <p:spPr>
-          <a:xfrm>
-            <a:off x="1325880" y="4325112"/>
-            <a:ext cx="5120640" cy="274320"/>
+          <p:cNvPr id="44" name="Text 6"/>
+          <p:cNvSpPr/>
+          <p:nvPr/>
+        </p:nvSpPr>
+        <p:spPr>
+          <a:xfrm>
+            <a:off x="6720840" y="1417320"/>
+            <a:ext cx="4617720" cy="274320"/>
           </a:xfrm>
           <a:prstGeom prst="rect">
             <a:avLst/>
@@ -4917,14 +4917,14 @@
       </p:sp>
       <p:sp>
         <p:nvSpPr>
-          <p:cNvPr id="22" name="Text 19"/>
-          <p:cNvSpPr/>
-          <p:nvPr/>
-        </p:nvSpPr>
-        <p:spPr>
-          <a:xfrm>
-            <a:off x="1325880" y="4636008"/>
-            <a:ext cx="5166360" cy="658368"/>
+          <p:cNvPr id="45" name="Text 7"/>
+          <p:cNvSpPr/>
+          <p:nvPr/>
+        </p:nvSpPr>
+        <p:spPr>
+          <a:xfrm>
+            <a:off x="6720840" y="1700784"/>
+            <a:ext cx="4617720" cy="1234440"/>
           </a:xfrm>
           <a:prstGeom prst="rect">
             <a:avLst/>
@@ -4951,7 +4951,7 @@
                 <a:ea typeface="Garamond" pitchFamily="34" charset="-122"/>
                 <a:cs typeface="Garamond" pitchFamily="34" charset="-120"/>
               </a:rPr>
-              <a:t>Development of space based solar power systems designed to collect solar energy in orbit and transmit power to Earth, a pathway toward next generation space infrastructure.</a:t>
+              <a:t>Beyond current space hardware, Helio is developing space based solar power systems designed to collect solar energy in orbit and transmit power to Earth. Customers and partners interested in future space infrastructure value Helio's combination of existing engineering capability and long term energy technology goals.</a:t>
             </a:r>
             <a:endParaRPr lang="en-US" sz="1100" dirty="0"/>
           </a:p>
@@ -4959,1141 +4959,13 @@
       </p:sp>
       <p:sp>
         <p:nvSpPr>
-          <p:cNvPr id="23" name="Text 20"/>
-          <p:cNvSpPr/>
-          <p:nvPr/>
-        </p:nvSpPr>
-        <p:spPr>
-          <a:xfrm>
-            <a:off x="7040880" y="1508760"/>
-            <a:ext cx="4297680" cy="274320"/>
-          </a:xfrm>
-          <a:prstGeom prst="rect">
-            <a:avLst/>
-          </a:prstGeom>
-          <a:noFill/>
-          <a:ln/>
-        </p:spPr>
-        <p:txBody>
-          <a:bodyPr wrap="square" lIns="0" tIns="0" rIns="0" bIns="0" rtlCol="0" anchor="ctr"/>
-          <a:lstStyle/>
-          <a:p>
-            <a:pPr indent="0" marL="0">
-              <a:buNone/>
-            </a:pPr>
-            <a:r>
-              <a:rPr lang="en-US" sz="1350" b="1" dirty="0">
-                <a:solidFill>
-                  <a:srgbClr val="10222F"/>
-                </a:solidFill>
-                <a:latin typeface="Garamond" pitchFamily="34" charset="0"/>
-                <a:ea typeface="Garamond" pitchFamily="34" charset="-122"/>
-                <a:cs typeface="Garamond" pitchFamily="34" charset="-120"/>
-              </a:rPr>
-              <a:t>Release mechanism versus typical SMA devices</a:t>
-            </a:r>
-            <a:endParaRPr lang="en-US" sz="1350" dirty="0"/>
-          </a:p>
-        </p:txBody>
-      </p:sp>
-      <p:graphicFrame>
-        <p:nvGraphicFramePr>
-          <p:cNvPr id="13" name="Table 0"/>
-          <p:cNvGraphicFramePr>
-            <a:graphicFrameLocks noGrp="1"/>
-          </p:cNvGraphicFramePr>
-          <p:nvPr>
-            <p:extLst>
-              <p:ext uri="{D42A27DB-BD31-4B8C-83A1-F6EECF244321}">
-                <p14:modId xmlns:p14="http://schemas.microsoft.com/office/powerpoint/2010/main" val="1579011935"/>
-              </p:ext>
-            </p:extLst>
-          </p:nvPr>
-        </p:nvGraphicFramePr>
-        <p:xfrm>
-          <a:off x="7040880" y="1874520"/>
-          <a:ext cx="4315968" cy="914400"/>
-        </p:xfrm>
-        <a:graphic>
-          <a:graphicData uri="http://schemas.openxmlformats.org/drawingml/2006/table">
-            <a:tbl>
-              <a:tblPr/>
-              <a:tblGrid>
-                <a:gridCol w="1481328"/>
-                <a:gridCol w="1417320"/>
-                <a:gridCol w="1417320"/>
-              </a:tblGrid>
-              <a:tr h="566928">
-                <a:tc>
-                  <a:txBody>
-                    <a:bodyPr/>
-                    <a:lstStyle/>
-                    <a:p>
-                      <a:pPr indent="0" marL="0">
-                        <a:buNone/>
-                      </a:pPr>
-                      <a:endParaRPr lang="en-US" sz="950" dirty="0">
-                        <a:latin typeface="Garamond" charset="0"/>
-                        <a:ea typeface="Garamond" charset="0"/>
-                        <a:cs typeface="Garamond" charset="0"/>
-                      </a:endParaRPr>
-                    </a:p>
-                  </a:txBody>
-                  <a:tcPr marL="45720" marR="45720" marT="45720" marB="45720" anchor="ctr">
-                    <a:lnL w="6350" cap="flat" cmpd="sng" algn="ctr">
-                      <a:solidFill>
-                        <a:srgbClr val="C6D2DA"/>
-                      </a:solidFill>
-                      <a:prstDash val="solid"/>
-                      <a:round/>
-                      <a:headEnd type="none" w="med" len="med"/>
-                      <a:tailEnd type="none" w="med" len="med"/>
-                    </a:lnL>
-                    <a:lnR w="6350" cap="flat" cmpd="sng" algn="ctr">
-                      <a:solidFill>
-                        <a:srgbClr val="C6D2DA"/>
-                      </a:solidFill>
-                      <a:prstDash val="solid"/>
-                      <a:round/>
-                      <a:headEnd type="none" w="med" len="med"/>
-                      <a:tailEnd type="none" w="med" len="med"/>
-                    </a:lnR>
-                    <a:lnT w="6350" cap="flat" cmpd="sng" algn="ctr">
-                      <a:solidFill>
-                        <a:srgbClr val="C6D2DA"/>
-                      </a:solidFill>
-                      <a:prstDash val="solid"/>
-                      <a:round/>
-                      <a:headEnd type="none" w="med" len="med"/>
-                      <a:tailEnd type="none" w="med" len="med"/>
-                    </a:lnT>
-                    <a:lnB w="6350" cap="flat" cmpd="sng" algn="ctr">
-                      <a:solidFill>
-                        <a:srgbClr val="C6D2DA"/>
-                      </a:solidFill>
-                      <a:prstDash val="solid"/>
-                      <a:round/>
-                      <a:headEnd type="none" w="med" len="med"/>
-                      <a:tailEnd type="none" w="med" len="med"/>
-                    </a:lnB>
-                    <a:solidFill>
-                      <a:srgbClr val="10222F"/>
-                    </a:solidFill>
-                  </a:tcPr>
-                </a:tc>
-                <a:tc>
-                  <a:txBody>
-                    <a:bodyPr/>
-                    <a:lstStyle/>
-                    <a:p>
-                      <a:pPr indent="0" marL="0">
-                        <a:buNone/>
-                      </a:pPr>
-                      <a:r>
-                        <a:rPr lang="en-US" sz="950" b="1" dirty="0">
-                          <a:solidFill>
-                            <a:srgbClr val="FFFFFF"/>
-                          </a:solidFill>
-                          <a:latin typeface="Garamond" pitchFamily="34" charset="0"/>
-                          <a:ea typeface="Garamond" pitchFamily="34" charset="-122"/>
-                          <a:cs typeface="Garamond" pitchFamily="34" charset="-120"/>
-                        </a:rPr>
-                        <a:t>Heliospace</a:t>
-                      </a:r>
-                      <a:endParaRPr lang="en-US" sz="950" dirty="0">
-                        <a:latin typeface="Garamond" charset="0"/>
-                        <a:ea typeface="Garamond" charset="0"/>
-                        <a:cs typeface="Garamond" charset="0"/>
-                      </a:endParaRPr>
-                    </a:p>
-                  </a:txBody>
-                  <a:tcPr marL="45720" marR="45720" marT="45720" marB="45720" anchor="ctr">
-                    <a:lnL w="6350" cap="flat" cmpd="sng" algn="ctr">
-                      <a:solidFill>
-                        <a:srgbClr val="C6D2DA"/>
-                      </a:solidFill>
-                      <a:prstDash val="solid"/>
-                      <a:round/>
-                      <a:headEnd type="none" w="med" len="med"/>
-                      <a:tailEnd type="none" w="med" len="med"/>
-                    </a:lnL>
-                    <a:lnR w="6350" cap="flat" cmpd="sng" algn="ctr">
-                      <a:solidFill>
-                        <a:srgbClr val="C6D2DA"/>
-                      </a:solidFill>
-                      <a:prstDash val="solid"/>
-                      <a:round/>
-                      <a:headEnd type="none" w="med" len="med"/>
-                      <a:tailEnd type="none" w="med" len="med"/>
-                    </a:lnR>
-                    <a:lnT w="6350" cap="flat" cmpd="sng" algn="ctr">
-                      <a:solidFill>
-                        <a:srgbClr val="C6D2DA"/>
-                      </a:solidFill>
-                      <a:prstDash val="solid"/>
-                      <a:round/>
-                      <a:headEnd type="none" w="med" len="med"/>
-                      <a:tailEnd type="none" w="med" len="med"/>
-                    </a:lnT>
-                    <a:lnB w="6350" cap="flat" cmpd="sng" algn="ctr">
-                      <a:solidFill>
-                        <a:srgbClr val="C6D2DA"/>
-                      </a:solidFill>
-                      <a:prstDash val="solid"/>
-                      <a:round/>
-                      <a:headEnd type="none" w="med" len="med"/>
-                      <a:tailEnd type="none" w="med" len="med"/>
-                    </a:lnB>
-                    <a:solidFill>
-                      <a:srgbClr val="10222F"/>
-                    </a:solidFill>
-                  </a:tcPr>
-                </a:tc>
-                <a:tc>
-                  <a:txBody>
-                    <a:bodyPr/>
-                    <a:lstStyle/>
-                    <a:p>
-                      <a:pPr indent="0" marL="0">
-                        <a:buNone/>
-                      </a:pPr>
-                      <a:r>
-                        <a:rPr lang="en-US" sz="950" b="1" dirty="0">
-                          <a:solidFill>
-                            <a:srgbClr val="FFFFFF"/>
-                          </a:solidFill>
-                          <a:latin typeface="Garamond" pitchFamily="34" charset="0"/>
-                          <a:ea typeface="Garamond" pitchFamily="34" charset="-122"/>
-                          <a:cs typeface="Garamond" pitchFamily="34" charset="-120"/>
-                        </a:rPr>
-                        <a:t>Typical SMA HDRM</a:t>
-                      </a:r>
-                      <a:endParaRPr lang="en-US" sz="950" dirty="0">
-                        <a:latin typeface="Garamond" charset="0"/>
-                        <a:ea typeface="Garamond" charset="0"/>
-                        <a:cs typeface="Garamond" charset="0"/>
-                      </a:endParaRPr>
-                    </a:p>
-                  </a:txBody>
-                  <a:tcPr marL="45720" marR="45720" marT="45720" marB="45720" anchor="ctr">
-                    <a:lnL w="6350" cap="flat" cmpd="sng" algn="ctr">
-                      <a:solidFill>
-                        <a:srgbClr val="C6D2DA"/>
-                      </a:solidFill>
-                      <a:prstDash val="solid"/>
-                      <a:round/>
-                      <a:headEnd type="none" w="med" len="med"/>
-                      <a:tailEnd type="none" w="med" len="med"/>
-                    </a:lnL>
-                    <a:lnR w="6350" cap="flat" cmpd="sng" algn="ctr">
-                      <a:solidFill>
-                        <a:srgbClr val="C6D2DA"/>
-                      </a:solidFill>
-                      <a:prstDash val="solid"/>
-                      <a:round/>
-                      <a:headEnd type="none" w="med" len="med"/>
-                      <a:tailEnd type="none" w="med" len="med"/>
-                    </a:lnR>
-                    <a:lnT w="6350" cap="flat" cmpd="sng" algn="ctr">
-                      <a:solidFill>
-                        <a:srgbClr val="C6D2DA"/>
-                      </a:solidFill>
-                      <a:prstDash val="solid"/>
-                      <a:round/>
-                      <a:headEnd type="none" w="med" len="med"/>
-                      <a:tailEnd type="none" w="med" len="med"/>
-                    </a:lnT>
-                    <a:lnB w="6350" cap="flat" cmpd="sng" algn="ctr">
-                      <a:solidFill>
-                        <a:srgbClr val="C6D2DA"/>
-                      </a:solidFill>
-                      <a:prstDash val="solid"/>
-                      <a:round/>
-                      <a:headEnd type="none" w="med" len="med"/>
-                      <a:tailEnd type="none" w="med" len="med"/>
-                    </a:lnB>
-                    <a:solidFill>
-                      <a:srgbClr val="10222F"/>
-                    </a:solidFill>
-                  </a:tcPr>
-                </a:tc>
-              </a:tr>
-              <a:tr h="566928">
-                <a:tc>
-                  <a:txBody>
-                    <a:bodyPr/>
-                    <a:lstStyle/>
-                    <a:p>
-                      <a:pPr indent="0" marL="0">
-                        <a:buNone/>
-                      </a:pPr>
-                      <a:r>
-                        <a:rPr lang="en-US" sz="950" b="1" dirty="0">
-                          <a:solidFill>
-                            <a:srgbClr val="10222F"/>
-                          </a:solidFill>
-                          <a:latin typeface="Garamond" pitchFamily="34" charset="0"/>
-                          <a:ea typeface="Garamond" pitchFamily="34" charset="-122"/>
-                          <a:cs typeface="Garamond" pitchFamily="34" charset="-120"/>
-                        </a:rPr>
-                        <a:t>Pre deploy temperature</a:t>
-                      </a:r>
-                      <a:endParaRPr lang="en-US" sz="950" dirty="0">
-                        <a:latin typeface="Garamond" charset="0"/>
-                        <a:ea typeface="Garamond" charset="0"/>
-                        <a:cs typeface="Garamond" charset="0"/>
-                      </a:endParaRPr>
-                    </a:p>
-                  </a:txBody>
-                  <a:tcPr marL="45720" marR="45720" marT="45720" marB="45720" anchor="ctr">
-                    <a:lnL w="6350" cap="flat" cmpd="sng" algn="ctr">
-                      <a:solidFill>
-                        <a:srgbClr val="C6D2DA"/>
-                      </a:solidFill>
-                      <a:prstDash val="solid"/>
-                      <a:round/>
-                      <a:headEnd type="none" w="med" len="med"/>
-                      <a:tailEnd type="none" w="med" len="med"/>
-                    </a:lnL>
-                    <a:lnR w="6350" cap="flat" cmpd="sng" algn="ctr">
-                      <a:solidFill>
-                        <a:srgbClr val="C6D2DA"/>
-                      </a:solidFill>
-                      <a:prstDash val="solid"/>
-                      <a:round/>
-                      <a:headEnd type="none" w="med" len="med"/>
-                      <a:tailEnd type="none" w="med" len="med"/>
-                    </a:lnR>
-                    <a:lnT w="6350" cap="flat" cmpd="sng" algn="ctr">
-                      <a:solidFill>
-                        <a:srgbClr val="C6D2DA"/>
-                      </a:solidFill>
-                      <a:prstDash val="solid"/>
-                      <a:round/>
-                      <a:headEnd type="none" w="med" len="med"/>
-                      <a:tailEnd type="none" w="med" len="med"/>
-                    </a:lnT>
-                    <a:lnB w="6350" cap="flat" cmpd="sng" algn="ctr">
-                      <a:solidFill>
-                        <a:srgbClr val="C6D2DA"/>
-                      </a:solidFill>
-                      <a:prstDash val="solid"/>
-                      <a:round/>
-                      <a:headEnd type="none" w="med" len="med"/>
-                      <a:tailEnd type="none" w="med" len="med"/>
-                    </a:lnB>
-                    <a:solidFill>
-                      <a:srgbClr val="F3F7FA"/>
-                    </a:solidFill>
-                  </a:tcPr>
-                </a:tc>
-                <a:tc>
-                  <a:txBody>
-                    <a:bodyPr/>
-                    <a:lstStyle/>
-                    <a:p>
-                      <a:pPr indent="0" marL="0">
-                        <a:buNone/>
-                      </a:pPr>
-                      <a:r>
-                        <a:rPr lang="en-US" sz="950" dirty="0">
-                          <a:solidFill>
-                            <a:srgbClr val="1E2A33"/>
-                          </a:solidFill>
-                          <a:latin typeface="Garamond" pitchFamily="34" charset="0"/>
-                          <a:ea typeface="Garamond" pitchFamily="34" charset="-122"/>
-                          <a:cs typeface="Garamond" pitchFamily="34" charset="-120"/>
-                        </a:rPr>
-                        <a:t>Above 150 C</a:t>
-                      </a:r>
-                      <a:endParaRPr lang="en-US" sz="950" dirty="0">
-                        <a:latin typeface="Garamond" charset="0"/>
-                        <a:ea typeface="Garamond" charset="0"/>
-                        <a:cs typeface="Garamond" charset="0"/>
-                      </a:endParaRPr>
-                    </a:p>
-                  </a:txBody>
-                  <a:tcPr marL="45720" marR="45720" marT="45720" marB="45720" anchor="ctr">
-                    <a:lnL w="6350" cap="flat" cmpd="sng" algn="ctr">
-                      <a:solidFill>
-                        <a:srgbClr val="C6D2DA"/>
-                      </a:solidFill>
-                      <a:prstDash val="solid"/>
-                      <a:round/>
-                      <a:headEnd type="none" w="med" len="med"/>
-                      <a:tailEnd type="none" w="med" len="med"/>
-                    </a:lnL>
-                    <a:lnR w="6350" cap="flat" cmpd="sng" algn="ctr">
-                      <a:solidFill>
-                        <a:srgbClr val="C6D2DA"/>
-                      </a:solidFill>
-                      <a:prstDash val="solid"/>
-                      <a:round/>
-                      <a:headEnd type="none" w="med" len="med"/>
-                      <a:tailEnd type="none" w="med" len="med"/>
-                    </a:lnR>
-                    <a:lnT w="6350" cap="flat" cmpd="sng" algn="ctr">
-                      <a:solidFill>
-                        <a:srgbClr val="C6D2DA"/>
-                      </a:solidFill>
-                      <a:prstDash val="solid"/>
-                      <a:round/>
-                      <a:headEnd type="none" w="med" len="med"/>
-                      <a:tailEnd type="none" w="med" len="med"/>
-                    </a:lnT>
-                    <a:lnB w="6350" cap="flat" cmpd="sng" algn="ctr">
-                      <a:solidFill>
-                        <a:srgbClr val="C6D2DA"/>
-                      </a:solidFill>
-                      <a:prstDash val="solid"/>
-                      <a:round/>
-                      <a:headEnd type="none" w="med" len="med"/>
-                      <a:tailEnd type="none" w="med" len="med"/>
-                    </a:lnB>
-                    <a:solidFill>
-                      <a:srgbClr val="F3F7FA"/>
-                    </a:solidFill>
-                  </a:tcPr>
-                </a:tc>
-                <a:tc>
-                  <a:txBody>
-                    <a:bodyPr/>
-                    <a:lstStyle/>
-                    <a:p>
-                      <a:pPr indent="0" marL="0">
-                        <a:buNone/>
-                      </a:pPr>
-                      <a:r>
-                        <a:rPr lang="en-US" sz="950" dirty="0">
-                          <a:solidFill>
-                            <a:srgbClr val="1E2A33"/>
-                          </a:solidFill>
-                          <a:latin typeface="Garamond" pitchFamily="34" charset="0"/>
-                          <a:ea typeface="Garamond" pitchFamily="34" charset="-122"/>
-                          <a:cs typeface="Garamond" pitchFamily="34" charset="-120"/>
-                        </a:rPr>
-                        <a:t>90 to 120 C</a:t>
-                      </a:r>
-                      <a:endParaRPr lang="en-US" sz="950" dirty="0">
-                        <a:latin typeface="Garamond" charset="0"/>
-                        <a:ea typeface="Garamond" charset="0"/>
-                        <a:cs typeface="Garamond" charset="0"/>
-                      </a:endParaRPr>
-                    </a:p>
-                  </a:txBody>
-                  <a:tcPr marL="45720" marR="45720" marT="45720" marB="45720" anchor="ctr">
-                    <a:lnL w="6350" cap="flat" cmpd="sng" algn="ctr">
-                      <a:solidFill>
-                        <a:srgbClr val="C6D2DA"/>
-                      </a:solidFill>
-                      <a:prstDash val="solid"/>
-                      <a:round/>
-                      <a:headEnd type="none" w="med" len="med"/>
-                      <a:tailEnd type="none" w="med" len="med"/>
-                    </a:lnL>
-                    <a:lnR w="6350" cap="flat" cmpd="sng" algn="ctr">
-                      <a:solidFill>
-                        <a:srgbClr val="C6D2DA"/>
-                      </a:solidFill>
-                      <a:prstDash val="solid"/>
-                      <a:round/>
-                      <a:headEnd type="none" w="med" len="med"/>
-                      <a:tailEnd type="none" w="med" len="med"/>
-                    </a:lnR>
-                    <a:lnT w="6350" cap="flat" cmpd="sng" algn="ctr">
-                      <a:solidFill>
-                        <a:srgbClr val="C6D2DA"/>
-                      </a:solidFill>
-                      <a:prstDash val="solid"/>
-                      <a:round/>
-                      <a:headEnd type="none" w="med" len="med"/>
-                      <a:tailEnd type="none" w="med" len="med"/>
-                    </a:lnT>
-                    <a:lnB w="6350" cap="flat" cmpd="sng" algn="ctr">
-                      <a:solidFill>
-                        <a:srgbClr val="C6D2DA"/>
-                      </a:solidFill>
-                      <a:prstDash val="solid"/>
-                      <a:round/>
-                      <a:headEnd type="none" w="med" len="med"/>
-                      <a:tailEnd type="none" w="med" len="med"/>
-                    </a:lnB>
-                    <a:solidFill>
-                      <a:srgbClr val="F3F7FA"/>
-                    </a:solidFill>
-                  </a:tcPr>
-                </a:tc>
-              </a:tr>
-              <a:tr h="566928">
-                <a:tc>
-                  <a:txBody>
-                    <a:bodyPr/>
-                    <a:lstStyle/>
-                    <a:p>
-                      <a:pPr indent="0" marL="0">
-                        <a:buNone/>
-                      </a:pPr>
-                      <a:r>
-                        <a:rPr lang="en-US" sz="950" b="1" dirty="0">
-                          <a:solidFill>
-                            <a:srgbClr val="10222F"/>
-                          </a:solidFill>
-                          <a:latin typeface="Garamond" pitchFamily="34" charset="0"/>
-                          <a:ea typeface="Garamond" pitchFamily="34" charset="-122"/>
-                          <a:cs typeface="Garamond" pitchFamily="34" charset="-120"/>
-                        </a:rPr>
-                        <a:t>Stowed length</a:t>
-                      </a:r>
-                      <a:endParaRPr lang="en-US" sz="950" dirty="0">
-                        <a:latin typeface="Garamond" charset="0"/>
-                        <a:ea typeface="Garamond" charset="0"/>
-                        <a:cs typeface="Garamond" charset="0"/>
-                      </a:endParaRPr>
-                    </a:p>
-                  </a:txBody>
-                  <a:tcPr marL="45720" marR="45720" marT="45720" marB="45720" anchor="ctr">
-                    <a:lnL w="6350" cap="flat" cmpd="sng" algn="ctr">
-                      <a:solidFill>
-                        <a:srgbClr val="C6D2DA"/>
-                      </a:solidFill>
-                      <a:prstDash val="solid"/>
-                      <a:round/>
-                      <a:headEnd type="none" w="med" len="med"/>
-                      <a:tailEnd type="none" w="med" len="med"/>
-                    </a:lnL>
-                    <a:lnR w="6350" cap="flat" cmpd="sng" algn="ctr">
-                      <a:solidFill>
-                        <a:srgbClr val="C6D2DA"/>
-                      </a:solidFill>
-                      <a:prstDash val="solid"/>
-                      <a:round/>
-                      <a:headEnd type="none" w="med" len="med"/>
-                      <a:tailEnd type="none" w="med" len="med"/>
-                    </a:lnR>
-                    <a:lnT w="6350" cap="flat" cmpd="sng" algn="ctr">
-                      <a:solidFill>
-                        <a:srgbClr val="C6D2DA"/>
-                      </a:solidFill>
-                      <a:prstDash val="solid"/>
-                      <a:round/>
-                      <a:headEnd type="none" w="med" len="med"/>
-                      <a:tailEnd type="none" w="med" len="med"/>
-                    </a:lnT>
-                    <a:lnB w="6350" cap="flat" cmpd="sng" algn="ctr">
-                      <a:solidFill>
-                        <a:srgbClr val="C6D2DA"/>
-                      </a:solidFill>
-                      <a:prstDash val="solid"/>
-                      <a:round/>
-                      <a:headEnd type="none" w="med" len="med"/>
-                      <a:tailEnd type="none" w="med" len="med"/>
-                    </a:lnB>
-                    <a:solidFill>
-                      <a:srgbClr val="FFFFFF"/>
-                    </a:solidFill>
-                  </a:tcPr>
-                </a:tc>
-                <a:tc>
-                  <a:txBody>
-                    <a:bodyPr/>
-                    <a:lstStyle/>
-                    <a:p>
-                      <a:pPr indent="0" marL="0">
-                        <a:buNone/>
-                      </a:pPr>
-                      <a:r>
-                        <a:rPr lang="en-US" sz="950" dirty="0">
-                          <a:solidFill>
-                            <a:srgbClr val="1E2A33"/>
-                          </a:solidFill>
-                          <a:latin typeface="Garamond" pitchFamily="34" charset="0"/>
-                          <a:ea typeface="Garamond" pitchFamily="34" charset="-122"/>
-                          <a:cs typeface="Garamond" pitchFamily="34" charset="-120"/>
-                        </a:rPr>
-                        <a:t>About one third of comparable devices</a:t>
-                      </a:r>
-                      <a:endParaRPr lang="en-US" sz="950" dirty="0">
-                        <a:latin typeface="Garamond" charset="0"/>
-                        <a:ea typeface="Garamond" charset="0"/>
-                        <a:cs typeface="Garamond" charset="0"/>
-                      </a:endParaRPr>
-                    </a:p>
-                  </a:txBody>
-                  <a:tcPr marL="45720" marR="45720" marT="45720" marB="45720" anchor="ctr">
-                    <a:lnL w="6350" cap="flat" cmpd="sng" algn="ctr">
-                      <a:solidFill>
-                        <a:srgbClr val="C6D2DA"/>
-                      </a:solidFill>
-                      <a:prstDash val="solid"/>
-                      <a:round/>
-                      <a:headEnd type="none" w="med" len="med"/>
-                      <a:tailEnd type="none" w="med" len="med"/>
-                    </a:lnL>
-                    <a:lnR w="6350" cap="flat" cmpd="sng" algn="ctr">
-                      <a:solidFill>
-                        <a:srgbClr val="C6D2DA"/>
-                      </a:solidFill>
-                      <a:prstDash val="solid"/>
-                      <a:round/>
-                      <a:headEnd type="none" w="med" len="med"/>
-                      <a:tailEnd type="none" w="med" len="med"/>
-                    </a:lnR>
-                    <a:lnT w="6350" cap="flat" cmpd="sng" algn="ctr">
-                      <a:solidFill>
-                        <a:srgbClr val="C6D2DA"/>
-                      </a:solidFill>
-                      <a:prstDash val="solid"/>
-                      <a:round/>
-                      <a:headEnd type="none" w="med" len="med"/>
-                      <a:tailEnd type="none" w="med" len="med"/>
-                    </a:lnT>
-                    <a:lnB w="6350" cap="flat" cmpd="sng" algn="ctr">
-                      <a:solidFill>
-                        <a:srgbClr val="C6D2DA"/>
-                      </a:solidFill>
-                      <a:prstDash val="solid"/>
-                      <a:round/>
-                      <a:headEnd type="none" w="med" len="med"/>
-                      <a:tailEnd type="none" w="med" len="med"/>
-                    </a:lnB>
-                    <a:solidFill>
-                      <a:srgbClr val="FFFFFF"/>
-                    </a:solidFill>
-                  </a:tcPr>
-                </a:tc>
-                <a:tc>
-                  <a:txBody>
-                    <a:bodyPr/>
-                    <a:lstStyle/>
-                    <a:p>
-                      <a:pPr indent="0" marL="0">
-                        <a:buNone/>
-                      </a:pPr>
-                      <a:r>
-                        <a:rPr lang="en-US" sz="950" dirty="0">
-                          <a:solidFill>
-                            <a:srgbClr val="1E2A33"/>
-                          </a:solidFill>
-                          <a:latin typeface="Garamond" pitchFamily="34" charset="0"/>
-                          <a:ea typeface="Garamond" pitchFamily="34" charset="-122"/>
-                          <a:cs typeface="Garamond" pitchFamily="34" charset="-120"/>
-                        </a:rPr>
-                        <a:t>About 3x axial height</a:t>
-                      </a:r>
-                      <a:endParaRPr lang="en-US" sz="950" dirty="0">
-                        <a:latin typeface="Garamond" charset="0"/>
-                        <a:ea typeface="Garamond" charset="0"/>
-                        <a:cs typeface="Garamond" charset="0"/>
-                      </a:endParaRPr>
-                    </a:p>
-                  </a:txBody>
-                  <a:tcPr marL="45720" marR="45720" marT="45720" marB="45720" anchor="ctr">
-                    <a:lnL w="6350" cap="flat" cmpd="sng" algn="ctr">
-                      <a:solidFill>
-                        <a:srgbClr val="C6D2DA"/>
-                      </a:solidFill>
-                      <a:prstDash val="solid"/>
-                      <a:round/>
-                      <a:headEnd type="none" w="med" len="med"/>
-                      <a:tailEnd type="none" w="med" len="med"/>
-                    </a:lnL>
-                    <a:lnR w="6350" cap="flat" cmpd="sng" algn="ctr">
-                      <a:solidFill>
-                        <a:srgbClr val="C6D2DA"/>
-                      </a:solidFill>
-                      <a:prstDash val="solid"/>
-                      <a:round/>
-                      <a:headEnd type="none" w="med" len="med"/>
-                      <a:tailEnd type="none" w="med" len="med"/>
-                    </a:lnR>
-                    <a:lnT w="6350" cap="flat" cmpd="sng" algn="ctr">
-                      <a:solidFill>
-                        <a:srgbClr val="C6D2DA"/>
-                      </a:solidFill>
-                      <a:prstDash val="solid"/>
-                      <a:round/>
-                      <a:headEnd type="none" w="med" len="med"/>
-                      <a:tailEnd type="none" w="med" len="med"/>
-                    </a:lnT>
-                    <a:lnB w="6350" cap="flat" cmpd="sng" algn="ctr">
-                      <a:solidFill>
-                        <a:srgbClr val="C6D2DA"/>
-                      </a:solidFill>
-                      <a:prstDash val="solid"/>
-                      <a:round/>
-                      <a:headEnd type="none" w="med" len="med"/>
-                      <a:tailEnd type="none" w="med" len="med"/>
-                    </a:lnB>
-                    <a:solidFill>
-                      <a:srgbClr val="FFFFFF"/>
-                    </a:solidFill>
-                  </a:tcPr>
-                </a:tc>
-              </a:tr>
-              <a:tr h="566928">
-                <a:tc>
-                  <a:txBody>
-                    <a:bodyPr/>
-                    <a:lstStyle/>
-                    <a:p>
-                      <a:pPr indent="0" marL="0">
-                        <a:buNone/>
-                      </a:pPr>
-                      <a:r>
-                        <a:rPr lang="en-US" sz="950" b="1" dirty="0">
-                          <a:solidFill>
-                            <a:srgbClr val="10222F"/>
-                          </a:solidFill>
-                          <a:latin typeface="Garamond" pitchFamily="34" charset="0"/>
-                          <a:ea typeface="Garamond" pitchFamily="34" charset="-122"/>
-                          <a:cs typeface="Garamond" pitchFamily="34" charset="-120"/>
-                        </a:rPr>
-                        <a:t>Redundancy</a:t>
-                      </a:r>
-                      <a:endParaRPr lang="en-US" sz="950" dirty="0">
-                        <a:latin typeface="Garamond" charset="0"/>
-                        <a:ea typeface="Garamond" charset="0"/>
-                        <a:cs typeface="Garamond" charset="0"/>
-                      </a:endParaRPr>
-                    </a:p>
-                  </a:txBody>
-                  <a:tcPr marL="45720" marR="45720" marT="45720" marB="45720" anchor="ctr">
-                    <a:lnL w="6350" cap="flat" cmpd="sng" algn="ctr">
-                      <a:solidFill>
-                        <a:srgbClr val="C6D2DA"/>
-                      </a:solidFill>
-                      <a:prstDash val="solid"/>
-                      <a:round/>
-                      <a:headEnd type="none" w="med" len="med"/>
-                      <a:tailEnd type="none" w="med" len="med"/>
-                    </a:lnL>
-                    <a:lnR w="6350" cap="flat" cmpd="sng" algn="ctr">
-                      <a:solidFill>
-                        <a:srgbClr val="C6D2DA"/>
-                      </a:solidFill>
-                      <a:prstDash val="solid"/>
-                      <a:round/>
-                      <a:headEnd type="none" w="med" len="med"/>
-                      <a:tailEnd type="none" w="med" len="med"/>
-                    </a:lnR>
-                    <a:lnT w="6350" cap="flat" cmpd="sng" algn="ctr">
-                      <a:solidFill>
-                        <a:srgbClr val="C6D2DA"/>
-                      </a:solidFill>
-                      <a:prstDash val="solid"/>
-                      <a:round/>
-                      <a:headEnd type="none" w="med" len="med"/>
-                      <a:tailEnd type="none" w="med" len="med"/>
-                    </a:lnT>
-                    <a:lnB w="6350" cap="flat" cmpd="sng" algn="ctr">
-                      <a:solidFill>
-                        <a:srgbClr val="C6D2DA"/>
-                      </a:solidFill>
-                      <a:prstDash val="solid"/>
-                      <a:round/>
-                      <a:headEnd type="none" w="med" len="med"/>
-                      <a:tailEnd type="none" w="med" len="med"/>
-                    </a:lnB>
-                    <a:solidFill>
-                      <a:srgbClr val="F3F7FA"/>
-                    </a:solidFill>
-                  </a:tcPr>
-                </a:tc>
-                <a:tc>
-                  <a:txBody>
-                    <a:bodyPr/>
-                    <a:lstStyle/>
-                    <a:p>
-                      <a:pPr indent="0" marL="0">
-                        <a:buNone/>
-                      </a:pPr>
-                      <a:r>
-                        <a:rPr lang="en-US" sz="950" dirty="0">
-                          <a:solidFill>
-                            <a:srgbClr val="1E2A33"/>
-                          </a:solidFill>
-                          <a:latin typeface="Garamond" pitchFamily="34" charset="0"/>
-                          <a:ea typeface="Garamond" pitchFamily="34" charset="-122"/>
-                          <a:cs typeface="Garamond" pitchFamily="34" charset="-120"/>
-                        </a:rPr>
-                        <a:t>Redundant circuits and actuation</a:t>
-                      </a:r>
-                      <a:endParaRPr lang="en-US" sz="950" dirty="0">
-                        <a:latin typeface="Garamond" charset="0"/>
-                        <a:ea typeface="Garamond" charset="0"/>
-                        <a:cs typeface="Garamond" charset="0"/>
-                      </a:endParaRPr>
-                    </a:p>
-                  </a:txBody>
-                  <a:tcPr marL="45720" marR="45720" marT="45720" marB="45720" anchor="ctr">
-                    <a:lnL w="6350" cap="flat" cmpd="sng" algn="ctr">
-                      <a:solidFill>
-                        <a:srgbClr val="C6D2DA"/>
-                      </a:solidFill>
-                      <a:prstDash val="solid"/>
-                      <a:round/>
-                      <a:headEnd type="none" w="med" len="med"/>
-                      <a:tailEnd type="none" w="med" len="med"/>
-                    </a:lnL>
-                    <a:lnR w="6350" cap="flat" cmpd="sng" algn="ctr">
-                      <a:solidFill>
-                        <a:srgbClr val="C6D2DA"/>
-                      </a:solidFill>
-                      <a:prstDash val="solid"/>
-                      <a:round/>
-                      <a:headEnd type="none" w="med" len="med"/>
-                      <a:tailEnd type="none" w="med" len="med"/>
-                    </a:lnR>
-                    <a:lnT w="6350" cap="flat" cmpd="sng" algn="ctr">
-                      <a:solidFill>
-                        <a:srgbClr val="C6D2DA"/>
-                      </a:solidFill>
-                      <a:prstDash val="solid"/>
-                      <a:round/>
-                      <a:headEnd type="none" w="med" len="med"/>
-                      <a:tailEnd type="none" w="med" len="med"/>
-                    </a:lnT>
-                    <a:lnB w="6350" cap="flat" cmpd="sng" algn="ctr">
-                      <a:solidFill>
-                        <a:srgbClr val="C6D2DA"/>
-                      </a:solidFill>
-                      <a:prstDash val="solid"/>
-                      <a:round/>
-                      <a:headEnd type="none" w="med" len="med"/>
-                      <a:tailEnd type="none" w="med" len="med"/>
-                    </a:lnB>
-                    <a:solidFill>
-                      <a:srgbClr val="F3F7FA"/>
-                    </a:solidFill>
-                  </a:tcPr>
-                </a:tc>
-                <a:tc>
-                  <a:txBody>
-                    <a:bodyPr/>
-                    <a:lstStyle/>
-                    <a:p>
-                      <a:pPr indent="0" marL="0">
-                        <a:buNone/>
-                      </a:pPr>
-                      <a:r>
-                        <a:rPr lang="en-US" sz="950" dirty="0">
-                          <a:solidFill>
-                            <a:srgbClr val="1E2A33"/>
-                          </a:solidFill>
-                          <a:latin typeface="Garamond" pitchFamily="34" charset="0"/>
-                          <a:ea typeface="Garamond" pitchFamily="34" charset="-122"/>
-                          <a:cs typeface="Garamond" pitchFamily="34" charset="-120"/>
-                        </a:rPr>
-                        <a:t>Not redundant at this size</a:t>
-                      </a:r>
-                      <a:endParaRPr lang="en-US" sz="950" dirty="0">
-                        <a:latin typeface="Garamond" charset="0"/>
-                        <a:ea typeface="Garamond" charset="0"/>
-                        <a:cs typeface="Garamond" charset="0"/>
-                      </a:endParaRPr>
-                    </a:p>
-                  </a:txBody>
-                  <a:tcPr marL="45720" marR="45720" marT="45720" marB="45720" anchor="ctr">
-                    <a:lnL w="6350" cap="flat" cmpd="sng" algn="ctr">
-                      <a:solidFill>
-                        <a:srgbClr val="C6D2DA"/>
-                      </a:solidFill>
-                      <a:prstDash val="solid"/>
-                      <a:round/>
-                      <a:headEnd type="none" w="med" len="med"/>
-                      <a:tailEnd type="none" w="med" len="med"/>
-                    </a:lnL>
-                    <a:lnR w="6350" cap="flat" cmpd="sng" algn="ctr">
-                      <a:solidFill>
-                        <a:srgbClr val="C6D2DA"/>
-                      </a:solidFill>
-                      <a:prstDash val="solid"/>
-                      <a:round/>
-                      <a:headEnd type="none" w="med" len="med"/>
-                      <a:tailEnd type="none" w="med" len="med"/>
-                    </a:lnR>
-                    <a:lnT w="6350" cap="flat" cmpd="sng" algn="ctr">
-                      <a:solidFill>
-                        <a:srgbClr val="C6D2DA"/>
-                      </a:solidFill>
-                      <a:prstDash val="solid"/>
-                      <a:round/>
-                      <a:headEnd type="none" w="med" len="med"/>
-                      <a:tailEnd type="none" w="med" len="med"/>
-                    </a:lnT>
-                    <a:lnB w="6350" cap="flat" cmpd="sng" algn="ctr">
-                      <a:solidFill>
-                        <a:srgbClr val="C6D2DA"/>
-                      </a:solidFill>
-                      <a:prstDash val="solid"/>
-                      <a:round/>
-                      <a:headEnd type="none" w="med" len="med"/>
-                      <a:tailEnd type="none" w="med" len="med"/>
-                    </a:lnB>
-                    <a:solidFill>
-                      <a:srgbClr val="F3F7FA"/>
-                    </a:solidFill>
-                  </a:tcPr>
-                </a:tc>
-              </a:tr>
-              <a:tr h="566928">
-                <a:tc>
-                  <a:txBody>
-                    <a:bodyPr/>
-                    <a:lstStyle/>
-                    <a:p>
-                      <a:pPr indent="0" marL="0">
-                        <a:buNone/>
-                      </a:pPr>
-                      <a:r>
-                        <a:rPr lang="en-US" sz="950" b="1" dirty="0">
-                          <a:solidFill>
-                            <a:srgbClr val="10222F"/>
-                          </a:solidFill>
-                          <a:latin typeface="Garamond" pitchFamily="34" charset="0"/>
-                          <a:ea typeface="Garamond" pitchFamily="34" charset="-122"/>
-                          <a:cs typeface="Garamond" pitchFamily="34" charset="-120"/>
-                        </a:rPr>
-                        <a:t>Reuse</a:t>
-                      </a:r>
-                      <a:endParaRPr lang="en-US" sz="950" dirty="0">
-                        <a:latin typeface="Garamond" charset="0"/>
-                        <a:ea typeface="Garamond" charset="0"/>
-                        <a:cs typeface="Garamond" charset="0"/>
-                      </a:endParaRPr>
-                    </a:p>
-                  </a:txBody>
-                  <a:tcPr marL="45720" marR="45720" marT="45720" marB="45720" anchor="ctr">
-                    <a:lnL w="6350" cap="flat" cmpd="sng" algn="ctr">
-                      <a:solidFill>
-                        <a:srgbClr val="C6D2DA"/>
-                      </a:solidFill>
-                      <a:prstDash val="solid"/>
-                      <a:round/>
-                      <a:headEnd type="none" w="med" len="med"/>
-                      <a:tailEnd type="none" w="med" len="med"/>
-                    </a:lnL>
-                    <a:lnR w="6350" cap="flat" cmpd="sng" algn="ctr">
-                      <a:solidFill>
-                        <a:srgbClr val="C6D2DA"/>
-                      </a:solidFill>
-                      <a:prstDash val="solid"/>
-                      <a:round/>
-                      <a:headEnd type="none" w="med" len="med"/>
-                      <a:tailEnd type="none" w="med" len="med"/>
-                    </a:lnR>
-                    <a:lnT w="6350" cap="flat" cmpd="sng" algn="ctr">
-                      <a:solidFill>
-                        <a:srgbClr val="C6D2DA"/>
-                      </a:solidFill>
-                      <a:prstDash val="solid"/>
-                      <a:round/>
-                      <a:headEnd type="none" w="med" len="med"/>
-                      <a:tailEnd type="none" w="med" len="med"/>
-                    </a:lnT>
-                    <a:lnB w="6350" cap="flat" cmpd="sng" algn="ctr">
-                      <a:solidFill>
-                        <a:srgbClr val="C6D2DA"/>
-                      </a:solidFill>
-                      <a:prstDash val="solid"/>
-                      <a:round/>
-                      <a:headEnd type="none" w="med" len="med"/>
-                      <a:tailEnd type="none" w="med" len="med"/>
-                    </a:lnB>
-                    <a:solidFill>
-                      <a:srgbClr val="FFFFFF"/>
-                    </a:solidFill>
-                  </a:tcPr>
-                </a:tc>
-                <a:tc>
-                  <a:txBody>
-                    <a:bodyPr/>
-                    <a:lstStyle/>
-                    <a:p>
-                      <a:pPr indent="0" marL="0">
-                        <a:buNone/>
-                      </a:pPr>
-                      <a:r>
-                        <a:rPr lang="en-US" sz="950" dirty="0">
-                          <a:solidFill>
-                            <a:srgbClr val="1E2A33"/>
-                          </a:solidFill>
-                          <a:latin typeface="Garamond" pitchFamily="34" charset="0"/>
-                          <a:ea typeface="Garamond" pitchFamily="34" charset="-122"/>
-                          <a:cs typeface="Garamond" pitchFamily="34" charset="-120"/>
-                        </a:rPr>
-                        <a:t>Re usable, non explosive</a:t>
-                      </a:r>
-                      <a:endParaRPr lang="en-US" sz="950" dirty="0">
-                        <a:latin typeface="Garamond" charset="0"/>
-                        <a:ea typeface="Garamond" charset="0"/>
-                        <a:cs typeface="Garamond" charset="0"/>
-                      </a:endParaRPr>
-                    </a:p>
-                  </a:txBody>
-                  <a:tcPr marL="45720" marR="45720" marT="45720" marB="45720" anchor="ctr">
-                    <a:lnL w="6350" cap="flat" cmpd="sng" algn="ctr">
-                      <a:solidFill>
-                        <a:srgbClr val="C6D2DA"/>
-                      </a:solidFill>
-                      <a:prstDash val="solid"/>
-                      <a:round/>
-                      <a:headEnd type="none" w="med" len="med"/>
-                      <a:tailEnd type="none" w="med" len="med"/>
-                    </a:lnL>
-                    <a:lnR w="6350" cap="flat" cmpd="sng" algn="ctr">
-                      <a:solidFill>
-                        <a:srgbClr val="C6D2DA"/>
-                      </a:solidFill>
-                      <a:prstDash val="solid"/>
-                      <a:round/>
-                      <a:headEnd type="none" w="med" len="med"/>
-                      <a:tailEnd type="none" w="med" len="med"/>
-                    </a:lnR>
-                    <a:lnT w="6350" cap="flat" cmpd="sng" algn="ctr">
-                      <a:solidFill>
-                        <a:srgbClr val="C6D2DA"/>
-                      </a:solidFill>
-                      <a:prstDash val="solid"/>
-                      <a:round/>
-                      <a:headEnd type="none" w="med" len="med"/>
-                      <a:tailEnd type="none" w="med" len="med"/>
-                    </a:lnT>
-                    <a:lnB w="6350" cap="flat" cmpd="sng" algn="ctr">
-                      <a:solidFill>
-                        <a:srgbClr val="C6D2DA"/>
-                      </a:solidFill>
-                      <a:prstDash val="solid"/>
-                      <a:round/>
-                      <a:headEnd type="none" w="med" len="med"/>
-                      <a:tailEnd type="none" w="med" len="med"/>
-                    </a:lnB>
-                    <a:solidFill>
-                      <a:srgbClr val="FFFFFF"/>
-                    </a:solidFill>
-                  </a:tcPr>
-                </a:tc>
-                <a:tc>
-                  <a:txBody>
-                    <a:bodyPr/>
-                    <a:lstStyle/>
-                    <a:p>
-                      <a:pPr indent="0" marL="0">
-                        <a:buNone/>
-                      </a:pPr>
-                      <a:r>
-                        <a:rPr lang="en-US" sz="950" dirty="0">
-                          <a:solidFill>
-                            <a:srgbClr val="1E2A33"/>
-                          </a:solidFill>
-                          <a:latin typeface="Garamond" pitchFamily="34" charset="0"/>
-                          <a:ea typeface="Garamond" pitchFamily="34" charset="-122"/>
-                          <a:cs typeface="Garamond" pitchFamily="34" charset="-120"/>
-                        </a:rPr>
-                        <a:t>Single use or custom</a:t>
-                      </a:r>
-                      <a:endParaRPr lang="en-US" sz="950" dirty="0">
-                        <a:latin typeface="Garamond" charset="0"/>
-                        <a:ea typeface="Garamond" charset="0"/>
-                        <a:cs typeface="Garamond" charset="0"/>
-                      </a:endParaRPr>
-                    </a:p>
-                  </a:txBody>
-                  <a:tcPr marL="45720" marR="45720" marT="45720" marB="45720" anchor="ctr">
-                    <a:lnL w="6350" cap="flat" cmpd="sng" algn="ctr">
-                      <a:solidFill>
-                        <a:srgbClr val="C6D2DA"/>
-                      </a:solidFill>
-                      <a:prstDash val="solid"/>
-                      <a:round/>
-                      <a:headEnd type="none" w="med" len="med"/>
-                      <a:tailEnd type="none" w="med" len="med"/>
-                    </a:lnL>
-                    <a:lnR w="6350" cap="flat" cmpd="sng" algn="ctr">
-                      <a:solidFill>
-                        <a:srgbClr val="C6D2DA"/>
-                      </a:solidFill>
-                      <a:prstDash val="solid"/>
-                      <a:round/>
-                      <a:headEnd type="none" w="med" len="med"/>
-                      <a:tailEnd type="none" w="med" len="med"/>
-                    </a:lnR>
-                    <a:lnT w="6350" cap="flat" cmpd="sng" algn="ctr">
-                      <a:solidFill>
-                        <a:srgbClr val="C6D2DA"/>
-                      </a:solidFill>
-                      <a:prstDash val="solid"/>
-                      <a:round/>
-                      <a:headEnd type="none" w="med" len="med"/>
-                      <a:tailEnd type="none" w="med" len="med"/>
-                    </a:lnT>
-                    <a:lnB w="6350" cap="flat" cmpd="sng" algn="ctr">
-                      <a:solidFill>
-                        <a:srgbClr val="C6D2DA"/>
-                      </a:solidFill>
-                      <a:prstDash val="solid"/>
-                      <a:round/>
-                      <a:headEnd type="none" w="med" len="med"/>
-                      <a:tailEnd type="none" w="med" len="med"/>
-                    </a:lnB>
-                    <a:solidFill>
-                      <a:srgbClr val="FFFFFF"/>
-                    </a:solidFill>
-                  </a:tcPr>
-                </a:tc>
-              </a:tr>
-            </a:tbl>
-          </a:graphicData>
-        </a:graphic>
-      </p:graphicFrame>
-      <p:sp>
-        <p:nvSpPr>
-          <p:cNvPr id="25" name="Text 21"/>
-          <p:cNvSpPr/>
-          <p:nvPr/>
-        </p:nvSpPr>
-        <p:spPr>
-          <a:xfrm>
-            <a:off x="7040880" y="4846320"/>
-            <a:ext cx="4297680" cy="256032"/>
-          </a:xfrm>
-          <a:prstGeom prst="rect">
-            <a:avLst/>
-          </a:prstGeom>
-          <a:noFill/>
-          <a:ln/>
-        </p:spPr>
-        <p:txBody>
-          <a:bodyPr wrap="square" lIns="0" tIns="0" rIns="0" bIns="0" rtlCol="0" anchor="ctr"/>
-          <a:lstStyle/>
-          <a:p>
-            <a:pPr indent="0" marL="0">
-              <a:buNone/>
-            </a:pPr>
-            <a:r>
-              <a:rPr lang="en-US" sz="900" i="1" dirty="0">
-                <a:solidFill>
-                  <a:srgbClr val="5C6B76"/>
-                </a:solidFill>
-                <a:latin typeface="Garamond" pitchFamily="34" charset="0"/>
-                <a:ea typeface="Garamond" pitchFamily="34" charset="-122"/>
-                <a:cs typeface="Garamond" pitchFamily="34" charset="-120"/>
-              </a:rPr>
-              <a:t>Source: Heliospace SB2 development program comparison.</a:t>
-            </a:r>
-            <a:endParaRPr lang="en-US" sz="900" dirty="0"/>
-          </a:p>
-        </p:txBody>
-      </p:sp>
-      <p:sp>
-        <p:nvSpPr>
-          <p:cNvPr id="26" name="Shape 4"/>
-          <p:cNvSpPr/>
-          <p:nvPr/>
-        </p:nvSpPr>
-        <p:spPr>
-          <a:xfrm>
-            <a:off x="822960" y="5321808"/>
+          <p:cNvPr id="46" name="Shape 4"/>
+          <p:cNvSpPr/>
+          <p:nvPr/>
+        </p:nvSpPr>
+        <p:spPr>
+          <a:xfrm>
+            <a:off x="6217920" y="3099816"/>
             <a:ext cx="347472" cy="347472"/>
           </a:xfrm>
           <a:prstGeom prst="ellipse">
@@ -6111,13 +4983,13 @@
       </p:sp>
       <p:sp>
         <p:nvSpPr>
-          <p:cNvPr id="27" name="Text 5"/>
-          <p:cNvSpPr/>
-          <p:nvPr/>
-        </p:nvSpPr>
-        <p:spPr>
-          <a:xfrm>
-            <a:off x="822960" y="5321808"/>
+          <p:cNvPr id="47" name="Text 5"/>
+          <p:cNvSpPr/>
+          <p:nvPr/>
+        </p:nvSpPr>
+        <p:spPr>
+          <a:xfrm>
+            <a:off x="6217920" y="3099816"/>
             <a:ext cx="347472" cy="347472"/>
           </a:xfrm>
           <a:prstGeom prst="rect">
@@ -6150,14 +5022,14 @@
       </p:sp>
       <p:sp>
         <p:nvSpPr>
-          <p:cNvPr id="28" name="Text 6"/>
-          <p:cNvSpPr/>
-          <p:nvPr/>
-        </p:nvSpPr>
-        <p:spPr>
-          <a:xfrm>
-            <a:off x="1325880" y="5294376"/>
-            <a:ext cx="5120640" cy="274320"/>
+          <p:cNvPr id="48" name="Text 6"/>
+          <p:cNvSpPr/>
+          <p:nvPr/>
+        </p:nvSpPr>
+        <p:spPr>
+          <a:xfrm>
+            <a:off x="6720840" y="3072384"/>
+            <a:ext cx="4617720" cy="548640"/>
           </a:xfrm>
           <a:prstGeom prst="rect">
             <a:avLst/>
@@ -6181,7 +5053,7 @@
                 <a:ea typeface="Garamond" pitchFamily="34" charset="-122"/>
                 <a:cs typeface="Garamond" pitchFamily="34" charset="-120"/>
               </a:rPr>
-              <a:t>A flexible partner</a:t>
+              <a:t>Flexible partner for government and commercial customers</a:t>
             </a:r>
             <a:endParaRPr lang="en-US" sz="1450" dirty="0"/>
           </a:p>
@@ -6189,14 +5061,14 @@
       </p:sp>
       <p:sp>
         <p:nvSpPr>
-          <p:cNvPr id="29" name="Text 7"/>
-          <p:cNvSpPr/>
-          <p:nvPr/>
-        </p:nvSpPr>
-        <p:spPr>
-          <a:xfrm>
-            <a:off x="1325880" y="5605272"/>
-            <a:ext cx="5166360" cy="658368"/>
+          <p:cNvPr id="49" name="Text 7"/>
+          <p:cNvSpPr/>
+          <p:nvPr/>
+        </p:nvSpPr>
+        <p:spPr>
+          <a:xfrm>
+            <a:off x="6720840" y="3657600"/>
+            <a:ext cx="4617720" cy="777240"/>
           </a:xfrm>
           <a:prstGeom prst="rect">
             <a:avLst/>
@@ -6223,9 +5095,121 @@
                 <a:ea typeface="Garamond" pitchFamily="34" charset="-122"/>
                 <a:cs typeface="Garamond" pitchFamily="34" charset="-120"/>
               </a:rPr>
-              <a:t>Customized systems rather than only standardized products, for government agencies, private aerospace companies, universities, and research organizations.</a:t>
+              <a:t>Helio works with government agencies, private aerospace companies, universities, and research organizations, providing customized systems rather than only standardized products.</a:t>
             </a:r>
             <a:endParaRPr lang="en-US" sz="1100" dirty="0"/>
+          </a:p>
+        </p:txBody>
+      </p:sp>
+      <p:sp>
+        <p:nvSpPr>
+          <p:cNvPr id="50" name="Shape 20"/>
+          <p:cNvSpPr/>
+          <p:nvPr/>
+        </p:nvSpPr>
+        <p:spPr>
+          <a:xfrm>
+            <a:off x="6217920" y="4663440"/>
+            <a:ext cx="5148072" cy="1325880"/>
+          </a:xfrm>
+          <a:prstGeom prst="roundRect">
+            <a:avLst>
+              <a:gd name="adj" fmla="val 3704"/>
+            </a:avLst>
+          </a:prstGeom>
+          <a:solidFill>
+            <a:srgbClr val="EDF3F8"/>
+          </a:solidFill>
+          <a:ln w="9525">
+            <a:solidFill>
+              <a:srgbClr val="C6D2DA"/>
+            </a:solidFill>
+            <a:prstDash val="solid"/>
+          </a:ln>
+        </p:spPr>
+        <p:txBody>
+          <a:bodyPr/>
+          <a:p/>
+        </p:txBody>
+      </p:sp>
+      <p:sp>
+        <p:nvSpPr>
+          <p:cNvPr id="51" name="Text 21"/>
+          <p:cNvSpPr/>
+          <p:nvPr/>
+        </p:nvSpPr>
+        <p:spPr>
+          <a:xfrm>
+            <a:off x="6400800" y="4791456"/>
+            <a:ext cx="4754880" cy="256032"/>
+          </a:xfrm>
+          <a:prstGeom prst="rect">
+            <a:avLst/>
+          </a:prstGeom>
+          <a:noFill/>
+          <a:ln/>
+        </p:spPr>
+        <p:txBody>
+          <a:bodyPr wrap="square" lIns="0" tIns="0" rIns="0" bIns="0" rtlCol="0" anchor="ctr"/>
+          <a:lstStyle/>
+          <a:p>
+            <a:pPr indent="0" marL="0">
+              <a:buNone/>
+            </a:pPr>
+            <a:r>
+              <a:rPr lang="en-US" sz="1250" b="1" dirty="0">
+                <a:solidFill>
+                  <a:srgbClr val="10222F"/>
+                </a:solidFill>
+                <a:latin typeface="Garamond" pitchFamily="34" charset="0"/>
+                <a:ea typeface="Garamond" pitchFamily="34" charset="-122"/>
+                <a:cs typeface="Garamond" pitchFamily="34" charset="-120"/>
+              </a:rPr>
+              <a:t>In summary</a:t>
+            </a:r>
+            <a:endParaRPr lang="en-US" sz="1250" dirty="0"/>
+          </a:p>
+        </p:txBody>
+      </p:sp>
+      <p:sp>
+        <p:nvSpPr>
+          <p:cNvPr id="52" name="Text 22"/>
+          <p:cNvSpPr/>
+          <p:nvPr/>
+        </p:nvSpPr>
+        <p:spPr>
+          <a:xfrm>
+            <a:off x="6400800" y="5084064"/>
+            <a:ext cx="4754880" cy="822960"/>
+          </a:xfrm>
+          <a:prstGeom prst="rect">
+            <a:avLst/>
+          </a:prstGeom>
+          <a:noFill/>
+          <a:ln/>
+        </p:spPr>
+        <p:txBody>
+          <a:bodyPr wrap="square" lIns="0" tIns="0" rIns="0" bIns="0" rtlCol="0" anchor="t"/>
+          <a:lstStyle/>
+          <a:p>
+            <a:pPr indent="0" marL="0">
+              <a:lnSpc>
+                <a:spcPct val="102000"/>
+              </a:lnSpc>
+              <a:buNone/>
+            </a:pPr>
+            <a:r>
+              <a:rPr lang="en-US" sz="1050" dirty="0">
+                <a:solidFill>
+                  <a:srgbClr val="1E2A33"/>
+                </a:solidFill>
+                <a:latin typeface="Garamond" pitchFamily="34" charset="0"/>
+                <a:ea typeface="Garamond" pitchFamily="34" charset="-122"/>
+                <a:cs typeface="Garamond" pitchFamily="34" charset="-120"/>
+              </a:rPr>
+              <a:t>Customers choose Helio because it offers proven space qualified hardware, specialized engineering skills, mission reliability, and a pathway toward next generation space infrastructure.</a:t>
+            </a:r>
+            <a:endParaRPr lang="en-US" sz="1050" dirty="0"/>
           </a:p>
         </p:txBody>
       </p:sp>
@@ -9929,8 +8913,8 @@
         </p:nvSpPr>
         <p:spPr>
           <a:xfrm>
-            <a:off x="822960" y="1463040"/>
-            <a:ext cx="5440680" cy="1325880"/>
+            <a:off x="822960" y="1417320"/>
+            <a:ext cx="5440680" cy="1828800"/>
           </a:xfrm>
           <a:prstGeom prst="rect">
             <a:avLst/>
@@ -9957,7 +8941,7 @@
                 <a:ea typeface="Garamond" pitchFamily="34" charset="-122"/>
                 <a:cs typeface="Garamond" pitchFamily="34" charset="-120"/>
               </a:rPr>
-              <a:t>Helio is pioneering a new class of energy infrastructure: space based power systems, or power plants in space, that capture solar energy beyond Earth's atmosphere and beam it safely and efficiently to the surface. Our vision is to establish orbital energy platforms as a foundational layer of the global power grid, delivering uninterrupted, carbon free electricity at scale.</a:t>
+              <a:t>Helio is pioneering a new class of energy infrastructure: space based power systems, known as power plants in space, that capture solar energy beyond Earth's atmosphere and beam it safely and efficiently to the surface. Our vision is to establish orbital energy platforms as a foundational layer of the global power grid, delivering uninterrupted, carbon free electricity at scale and reshaping how nations power cities, industries, and critical systems.</a:t>
             </a:r>
             <a:endParaRPr lang="en-US" sz="1350" dirty="0"/>
           </a:p>
@@ -9971,8 +8955,8 @@
         </p:nvSpPr>
         <p:spPr>
           <a:xfrm>
-            <a:off x="822960" y="2880360"/>
-            <a:ext cx="5440680" cy="1097280"/>
+            <a:off x="822960" y="3310128"/>
+            <a:ext cx="5440680" cy="1188720"/>
           </a:xfrm>
           <a:prstGeom prst="rect">
             <a:avLst/>
@@ -9999,7 +8983,7 @@
                 <a:ea typeface="Garamond" pitchFamily="34" charset="-122"/>
                 <a:cs typeface="Garamond" pitchFamily="34" charset="-120"/>
               </a:rPr>
-              <a:t>Founded in 2018, Helio delivers cutting edge aerospace hardware, systems engineering, and mission services, supporting NASA, private companies, universities, and global space agencies. A trusted partner to more than a dozen organizations worldwide, with products operating from the Sun to Jupiter.</a:t>
+              <a:t>Since being founded in 2018, Helio has specialized in delivering cutting edge aerospace hardware, systems engineering, and mission services. From small scale projects to flagship space missions, we support NASA, private companies, universities, and global space agencies to achieve success in space.</a:t>
             </a:r>
             <a:endParaRPr lang="en-US" sz="1350" dirty="0"/>
           </a:p>
@@ -10013,8 +8997,8 @@
         </p:nvSpPr>
         <p:spPr>
           <a:xfrm>
-            <a:off x="822960" y="4160520"/>
-            <a:ext cx="2651760" cy="457200"/>
+            <a:off x="6537960" y="4846320"/>
+            <a:ext cx="2331720" cy="438912"/>
           </a:xfrm>
           <a:prstGeom prst="rect">
             <a:avLst/>
@@ -10052,8 +9036,8 @@
         </p:nvSpPr>
         <p:spPr>
           <a:xfrm>
-            <a:off x="822960" y="4617720"/>
-            <a:ext cx="2560320" cy="502920"/>
+            <a:off x="6537960" y="5285232"/>
+            <a:ext cx="2331720" cy="256032"/>
           </a:xfrm>
           <a:prstGeom prst="rect">
             <a:avLst/>
@@ -10091,8 +9075,8 @@
         </p:nvSpPr>
         <p:spPr>
           <a:xfrm>
-            <a:off x="3611880" y="4160520"/>
-            <a:ext cx="2651760" cy="457200"/>
+            <a:off x="9052560" y="4846320"/>
+            <a:ext cx="2331720" cy="438912"/>
           </a:xfrm>
           <a:prstGeom prst="rect">
             <a:avLst/>
@@ -10130,8 +9114,8 @@
         </p:nvSpPr>
         <p:spPr>
           <a:xfrm>
-            <a:off x="3611880" y="4617720"/>
-            <a:ext cx="2560320" cy="502920"/>
+            <a:off x="9052560" y="5285232"/>
+            <a:ext cx="2331720" cy="256032"/>
           </a:xfrm>
           <a:prstGeom prst="rect">
             <a:avLst/>
@@ -10169,8 +9153,8 @@
         </p:nvSpPr>
         <p:spPr>
           <a:xfrm>
-            <a:off x="822960" y="5212080"/>
-            <a:ext cx="2651760" cy="457200"/>
+            <a:off x="6537960" y="5623560"/>
+            <a:ext cx="2331720" cy="438912"/>
           </a:xfrm>
           <a:prstGeom prst="rect">
             <a:avLst/>
@@ -10208,8 +9192,8 @@
         </p:nvSpPr>
         <p:spPr>
           <a:xfrm>
-            <a:off x="822960" y="5669280"/>
-            <a:ext cx="2560320" cy="502920"/>
+            <a:off x="6537960" y="6062472"/>
+            <a:ext cx="2331720" cy="256032"/>
           </a:xfrm>
           <a:prstGeom prst="rect">
             <a:avLst/>
@@ -10247,8 +9231,8 @@
         </p:nvSpPr>
         <p:spPr>
           <a:xfrm>
-            <a:off x="3611880" y="5212080"/>
-            <a:ext cx="2651760" cy="457200"/>
+            <a:off x="9052560" y="5623560"/>
+            <a:ext cx="2331720" cy="438912"/>
           </a:xfrm>
           <a:prstGeom prst="rect">
             <a:avLst/>
@@ -10286,8 +9270,8 @@
         </p:nvSpPr>
         <p:spPr>
           <a:xfrm>
-            <a:off x="3611880" y="5669280"/>
-            <a:ext cx="2560320" cy="502920"/>
+            <a:off x="9052560" y="6062472"/>
+            <a:ext cx="2331720" cy="256032"/>
           </a:xfrm>
           <a:prstGeom prst="rect">
             <a:avLst/>
@@ -10333,8 +9317,8 @@
         </p:blipFill>
         <p:spPr>
           <a:xfrm>
-            <a:off x="6537960" y="1463040"/>
-            <a:ext cx="4828032" cy="3602736"/>
+            <a:off x="7018020" y="1417320"/>
+            <a:ext cx="3867912" cy="2886282"/>
           </a:xfrm>
           <a:prstGeom prst="rect">
             <a:avLst/>
@@ -10349,8 +9333,8 @@
         </p:nvSpPr>
         <p:spPr>
           <a:xfrm>
-            <a:off x="6537960" y="1463040"/>
-            <a:ext cx="4828032" cy="3602736"/>
+            <a:off x="7018020" y="1417320"/>
+            <a:ext cx="3867912" cy="2886282"/>
           </a:xfrm>
           <a:prstGeom prst="rect">
             <a:avLst/>
@@ -10375,8 +9359,8 @@
         </p:nvSpPr>
         <p:spPr>
           <a:xfrm>
-            <a:off x="6537960" y="5138928"/>
-            <a:ext cx="4828032" cy="274320"/>
+            <a:off x="6537960" y="4370832"/>
+            <a:ext cx="4828032" cy="384048"/>
           </a:xfrm>
           <a:prstGeom prst="rect">
             <a:avLst/>
@@ -10403,6 +9387,48 @@
               <a:t>Europa Clipper with Heliospace built REASON radar antennas deployed. Image credit: NASA.</a:t>
             </a:r>
             <a:endParaRPr lang="en-US" sz="950" dirty="0"/>
+          </a:p>
+        </p:txBody>
+      </p:sp>
+      <p:sp>
+        <p:nvSpPr>
+          <p:cNvPr id="20" name="Text 5"/>
+          <p:cNvSpPr/>
+          <p:nvPr/>
+        </p:nvSpPr>
+        <p:spPr>
+          <a:xfrm>
+            <a:off x="822960" y="4553712"/>
+            <a:ext cx="5440680" cy="1600200"/>
+          </a:xfrm>
+          <a:prstGeom prst="rect">
+            <a:avLst/>
+          </a:prstGeom>
+          <a:noFill/>
+          <a:ln/>
+        </p:spPr>
+        <p:txBody>
+          <a:bodyPr wrap="square" lIns="0" tIns="0" rIns="0" bIns="0" rtlCol="0" anchor="t"/>
+          <a:lstStyle/>
+          <a:p>
+            <a:pPr indent="0" marL="0">
+              <a:lnSpc>
+                <a:spcPct val="108000"/>
+              </a:lnSpc>
+              <a:buNone/>
+            </a:pPr>
+            <a:r>
+              <a:rPr lang="en-US" sz="1350" dirty="0">
+                <a:solidFill>
+                  <a:srgbClr val="1E2A33"/>
+                </a:solidFill>
+                <a:latin typeface="Garamond" pitchFamily="34" charset="0"/>
+                <a:ea typeface="Garamond" pitchFamily="34" charset="-122"/>
+                <a:cs typeface="Garamond" pitchFamily="34" charset="-120"/>
+              </a:rPr>
+              <a:t>We are proud to be a trusted partner to over a dozen space agencies, organizations, and companies across the globe. Our products can be found operating from the Sun to Jupiter. From NASA and the European Space Agency to emerging private aerospace firms and academic institutions, we collaborate with some of the most innovative and forward thinking players in the space industry.</a:t>
+            </a:r>
+            <a:endParaRPr lang="en-US" sz="1350" dirty="0"/>
           </a:p>
         </p:txBody>
       </p:sp>
@@ -11230,7 +10256,7 @@
                 <a:ea typeface="Garamond" pitchFamily="34" charset="-122"/>
                 <a:cs typeface="Garamond" pitchFamily="34" charset="-120"/>
               </a:rPr>
-              <a:t>Wireless energy transmission designed to beam solar energy from orbit to Earth</a:t>
+              <a:t>Wireless energy transmission systems intended to beam solar energy from orbit to Earth</a:t>
             </a:r>
             <a:endParaRPr lang="en-US" sz="1100" dirty="0"/>
           </a:p>
@@ -11362,6 +10388,45 @@
               <a:t>Licensing of proprietary space technologies</a:t>
             </a:r>
             <a:endParaRPr lang="en-US" sz="1100" dirty="0"/>
+          </a:p>
+        </p:txBody>
+      </p:sp>
+      <p:sp>
+        <p:nvSpPr>
+          <p:cNvPr id="23" name="Text 5"/>
+          <p:cNvSpPr/>
+          <p:nvPr/>
+        </p:nvSpPr>
+        <p:spPr>
+          <a:xfrm>
+            <a:off x="822960" y="6254496"/>
+            <a:ext cx="10543032" cy="237744"/>
+          </a:xfrm>
+          <a:prstGeom prst="rect">
+            <a:avLst/>
+          </a:prstGeom>
+          <a:noFill/>
+          <a:ln/>
+        </p:spPr>
+        <p:txBody>
+          <a:bodyPr wrap="square" lIns="0" tIns="0" rIns="0" bIns="0" rtlCol="0" anchor="ctr"/>
+          <a:lstStyle/>
+          <a:p>
+            <a:pPr indent="0" marL="0">
+              <a:buNone/>
+            </a:pPr>
+            <a:r>
+              <a:rPr lang="en-US" sz="900" i="1" dirty="0">
+                <a:solidFill>
+                  <a:srgbClr val="5C6B76"/>
+                </a:solidFill>
+                <a:latin typeface="Garamond" pitchFamily="34" charset="0"/>
+                <a:ea typeface="Garamond" pitchFamily="34" charset="-122"/>
+                <a:cs typeface="Garamond" pitchFamily="34" charset="-120"/>
+              </a:rPr>
+              <a:t>Heritage examples: hardware for missions such as NASA's Europa Clipper, James Webb Space Telescope program support, solar science missions, and lunar related systems.</a:t>
+            </a:r>
+            <a:endParaRPr lang="en-US" sz="900" dirty="0"/>
           </a:p>
         </p:txBody>
       </p:sp>

</xml_diff>

<commit_message>
Remove China Strategy slides, add clients roster, keep only Rocky's contact
Co-authored-by: anthonyleedu <anthonyleedu@users.noreply.github.com>
</commit_message>
<xml_diff>
--- a/Heliospace_Investor_Overview.pptx
+++ b/Heliospace_Investor_Overview.pptx
@@ -19,8 +19,6 @@
     <p:sldId id="267" r:id="rId13"/>
     <p:sldId id="268" r:id="rId14"/>
     <p:sldId id="269" r:id="rId15"/>
-    <p:sldId id="272" r:id="rId23"/>
-    <p:sldId id="273" r:id="rId24"/>
     <p:sldId id="271" r:id="rId17"/>
   </p:sldIdLst>
   <p:notesMasterIdLst>
@@ -5458,7 +5456,7 @@
                 <a:ea typeface="Garamond" pitchFamily="34" charset="-122"/>
                 <a:cs typeface="Garamond" pitchFamily="34" charset="-120"/>
               </a:rPr>
-              <a:t>Civil space science</a:t>
+              <a:t>Space agencies and programs</a:t>
             </a:r>
             <a:endParaRPr lang="en-US" sz="1350" dirty="0"/>
           </a:p>
@@ -5497,7 +5495,7 @@
                 <a:ea typeface="Garamond" pitchFamily="34" charset="-122"/>
                 <a:cs typeface="Garamond" pitchFamily="34" charset="-120"/>
               </a:rPr>
-              <a:t>NASA JPL, NASA Goddard, Caltech, UC Berkeley Space Sciences Laboratory</a:t>
+              <a:t>NASA, NASA JPL, NASA Goddard Space Flight Center, CNES, and the NASA SBIR and STTR America's Seed Fund</a:t>
             </a:r>
             <a:endParaRPr lang="en-US" sz="1150" dirty="0"/>
           </a:p>
@@ -5536,7 +5534,7 @@
                 <a:ea typeface="Garamond" pitchFamily="34" charset="-122"/>
                 <a:cs typeface="Garamond" pitchFamily="34" charset="-120"/>
               </a:rPr>
-              <a:t>Commercial lunar</a:t>
+              <a:t>Commercial aerospace</a:t>
             </a:r>
             <a:endParaRPr lang="en-US" sz="1350" dirty="0"/>
           </a:p>
@@ -5575,7 +5573,7 @@
                 <a:ea typeface="Garamond" pitchFamily="34" charset="-122"/>
                 <a:cs typeface="Garamond" pitchFamily="34" charset="-120"/>
               </a:rPr>
-              <a:t>Firefly Aerospace, Intuitive Machines, SwRI, Draper and iSpace mission teams</a:t>
+              <a:t>Firefly Aerospace, Intuitive Machines, Honeybee Robotics, Blue Origin, Aerodyne, and ASES</a:t>
             </a:r>
             <a:endParaRPr lang="en-US" sz="1150" dirty="0"/>
           </a:p>
@@ -5614,7 +5612,7 @@
                 <a:ea typeface="Garamond" pitchFamily="34" charset="-122"/>
                 <a:cs typeface="Garamond" pitchFamily="34" charset="-120"/>
               </a:rPr>
-              <a:t>Flagship programs</a:t>
+              <a:t>Research institutions and universities</a:t>
             </a:r>
             <a:endParaRPr lang="en-US" sz="1350" dirty="0"/>
           </a:p>
@@ -5653,7 +5651,7 @@
                 <a:ea typeface="Garamond" pitchFamily="34" charset="-122"/>
                 <a:cs typeface="Garamond" pitchFamily="34" charset="-120"/>
               </a:rPr>
-              <a:t>James Webb Space Telescope support; Mars Sample Return concept studies</a:t>
+              <a:t>Southwest Research Institute, UC Berkeley, Columbia University, and Embry-Riddle Aeronautical University</a:t>
             </a:r>
             <a:endParaRPr lang="en-US" sz="1150" dirty="0"/>
           </a:p>
@@ -5692,7 +5690,7 @@
                 <a:ea typeface="Garamond" pitchFamily="34" charset="-122"/>
                 <a:cs typeface="Garamond" pitchFamily="34" charset="-120"/>
               </a:rPr>
-              <a:t>Commercial and philanthropic</a:t>
+              <a:t>Science and philanthropic initiatives</a:t>
             </a:r>
             <a:endParaRPr lang="en-US" sz="1350" dirty="0"/>
           </a:p>
@@ -5731,7 +5729,7 @@
                 <a:ea typeface="Garamond" pitchFamily="34" charset="-122"/>
                 <a:cs typeface="Garamond" pitchFamily="34" charset="-120"/>
               </a:rPr>
-              <a:t>Honeybee Robotics and Blue Origin lander work; Breakthrough Foundation farside mission</a:t>
+              <a:t>Breakthrough Listen and Earth Guard</a:t>
             </a:r>
             <a:endParaRPr lang="en-US" sz="1150" dirty="0"/>
           </a:p>
@@ -6946,1407 +6944,6 @@
 </p:sld>
 </file>
 
-<file path=ppt/slides/slide15.xml><?xml version="1.0" encoding="utf-8"?>
-<p:sld xmlns:a="http://schemas.openxmlformats.org/drawingml/2006/main" xmlns:p="http://schemas.openxmlformats.org/presentationml/2006/main" xmlns:r="http://schemas.openxmlformats.org/officeDocument/2006/relationships">
-  <p:cSld>
-    <p:spTree>
-      <p:nvGrpSpPr>
-        <p:cNvPr id="1" name=""/>
-        <p:cNvGrpSpPr/>
-        <p:nvPr/>
-      </p:nvGrpSpPr>
-      <p:grpSpPr/>
-      <p:sp>
-        <p:nvSpPr>
-          <p:cNvPr id="2" name="Text 0"/>
-          <p:cNvSpPr/>
-          <p:nvPr/>
-        </p:nvSpPr>
-        <p:spPr>
-          <a:xfrm>
-            <a:off x="822960" y="457200"/>
-            <a:ext cx="7772400" cy="274320"/>
-          </a:xfrm>
-          <a:prstGeom prst="rect">
-            <a:avLst/>
-          </a:prstGeom>
-          <a:noFill/>
-          <a:ln/>
-        </p:spPr>
-        <p:txBody>
-          <a:bodyPr wrap="square" lIns="0" tIns="0" rIns="0" bIns="0" rtlCol="0" anchor="ctr"/>
-          <a:lstStyle/>
-          <a:p>
-            <a:pPr indent="0" marL="0">
-              <a:buNone/>
-            </a:pPr>
-            <a:r>
-              <a:rPr lang="en-US" sz="1100" b="1" spc="300" kern="0" dirty="0">
-                <a:solidFill>
-                  <a:srgbClr val="007BCB"/>
-                </a:solidFill>
-                <a:latin typeface="Garamond" pitchFamily="34" charset="0"/>
-                <a:ea typeface="Garamond" pitchFamily="34" charset="-122"/>
-                <a:cs typeface="Garamond" pitchFamily="34" charset="-120"/>
-              </a:rPr>
-              <a:t>CHINA STRATEGY</a:t>
-            </a:r>
-            <a:endParaRPr lang="en-US" sz="1100" dirty="0"/>
-          </a:p>
-        </p:txBody>
-      </p:sp>
-      <p:sp>
-        <p:nvSpPr>
-          <p:cNvPr id="3" name="Text 1"/>
-          <p:cNvSpPr/>
-          <p:nvPr/>
-        </p:nvSpPr>
-        <p:spPr>
-          <a:xfrm>
-            <a:off x="822960" y="713232"/>
-            <a:ext cx="8961120" cy="566928"/>
-          </a:xfrm>
-          <a:prstGeom prst="rect">
-            <a:avLst/>
-          </a:prstGeom>
-          <a:noFill/>
-          <a:ln/>
-        </p:spPr>
-        <p:txBody>
-          <a:bodyPr wrap="square" lIns="0" tIns="0" rIns="0" bIns="0" rtlCol="0" anchor="ctr"/>
-          <a:lstStyle/>
-          <a:p>
-            <a:pPr indent="0" marL="0">
-              <a:buNone/>
-            </a:pPr>
-            <a:r>
-              <a:rPr lang="en-US" sz="2900" b="1" dirty="0">
-                <a:solidFill>
-                  <a:srgbClr val="10222F"/>
-                </a:solidFill>
-                <a:latin typeface="Garamond" pitchFamily="34" charset="0"/>
-                <a:ea typeface="Garamond" pitchFamily="34" charset="-122"/>
-                <a:cs typeface="Garamond" pitchFamily="34" charset="-120"/>
-              </a:rPr>
-              <a:t>A Disciplined Two Phase Approach</a:t>
-            </a:r>
-            <a:endParaRPr lang="en-US" sz="2900" dirty="0"/>
-          </a:p>
-        </p:txBody>
-      </p:sp>
-      <p:pic>
-        <p:nvPicPr>
-          <p:cNvPr id="4" name="Image 0" descr="assets/logo_dark.jpg">    </p:cNvPr>
-          <p:cNvPicPr>
-            <a:picLocks noChangeAspect="1"/>
-          </p:cNvPicPr>
-          <p:nvPr/>
-        </p:nvPicPr>
-        <p:blipFill>
-          <a:blip r:embed="rId2"/>
-          <a:stretch>
-            <a:fillRect/>
-          </a:stretch>
-        </p:blipFill>
-        <p:spPr>
-          <a:xfrm>
-            <a:off x="10058400" y="475488"/>
-            <a:ext cx="1325880" cy="372161"/>
-          </a:xfrm>
-          <a:prstGeom prst="rect">
-            <a:avLst/>
-          </a:prstGeom>
-        </p:spPr>
-      </p:pic>
-      <p:sp>
-        <p:nvSpPr>
-          <p:cNvPr id="5" name="Text 2"/>
-          <p:cNvSpPr/>
-          <p:nvPr/>
-        </p:nvSpPr>
-        <p:spPr>
-          <a:xfrm>
-            <a:off x="822960" y="6492240"/>
-            <a:ext cx="5943600" cy="237744"/>
-          </a:xfrm>
-          <a:prstGeom prst="rect">
-            <a:avLst/>
-          </a:prstGeom>
-          <a:noFill/>
-          <a:ln/>
-        </p:spPr>
-        <p:txBody>
-          <a:bodyPr wrap="square" lIns="0" tIns="0" rIns="0" bIns="0" rtlCol="0" anchor="ctr"/>
-          <a:lstStyle/>
-          <a:p>
-            <a:pPr indent="0" marL="0">
-              <a:buNone/>
-            </a:pPr>
-            <a:r>
-              <a:rPr lang="en-US" sz="850" dirty="0">
-                <a:solidFill>
-                  <a:srgbClr val="5C6B76"/>
-                </a:solidFill>
-                <a:latin typeface="Garamond" pitchFamily="34" charset="0"/>
-                <a:ea typeface="Garamond" pitchFamily="34" charset="-122"/>
-                <a:cs typeface="Garamond" pitchFamily="34" charset="-120"/>
-              </a:rPr>
-              <a:t>Heliospace Corporation   |   Proprietary and Confidential</a:t>
-            </a:r>
-            <a:endParaRPr lang="en-US" sz="850" dirty="0"/>
-          </a:p>
-        </p:txBody>
-      </p:sp>
-      <p:sp>
-        <p:nvSpPr>
-          <p:cNvPr id="6" name="Text 3"/>
-          <p:cNvSpPr/>
-          <p:nvPr/>
-        </p:nvSpPr>
-        <p:spPr>
-          <a:xfrm>
-            <a:off x="11064240" y="6492240"/>
-            <a:ext cx="320040" cy="237744"/>
-          </a:xfrm>
-          <a:prstGeom prst="rect">
-            <a:avLst/>
-          </a:prstGeom>
-          <a:noFill/>
-          <a:ln/>
-        </p:spPr>
-        <p:txBody>
-          <a:bodyPr wrap="square" lIns="0" tIns="0" rIns="0" bIns="0" rtlCol="0" anchor="ctr"/>
-          <a:lstStyle/>
-          <a:p>
-            <a:pPr algn="r" indent="0" marL="0">
-              <a:buNone/>
-            </a:pPr>
-            <a:r>
-              <a:rPr lang="en-US" sz="850" dirty="0">
-                <a:solidFill>
-                  <a:srgbClr val="5C6B76"/>
-                </a:solidFill>
-                <a:latin typeface="Garamond" pitchFamily="34" charset="0"/>
-                <a:ea typeface="Garamond" pitchFamily="34" charset="-122"/>
-                <a:cs typeface="Garamond" pitchFamily="34" charset="-120"/>
-              </a:rPr>
-              <a:t>15</a:t>
-            </a:r>
-            <a:endParaRPr lang="en-US" sz="850" dirty="0"/>
-          </a:p>
-        </p:txBody>
-      </p:sp>
-      <p:sp>
-        <p:nvSpPr>
-          <p:cNvPr id="7" name="Text 4"/>
-          <p:cNvSpPr/>
-          <p:nvPr/>
-        </p:nvSpPr>
-        <p:spPr>
-          <a:xfrm>
-            <a:off x="822960" y="1353312"/>
-            <a:ext cx="10424160" cy="320040"/>
-          </a:xfrm>
-          <a:prstGeom prst="rect">
-            <a:avLst/>
-          </a:prstGeom>
-          <a:noFill/>
-          <a:ln/>
-        </p:spPr>
-        <p:txBody>
-          <a:bodyPr wrap="square" lIns="0" tIns="0" rIns="0" bIns="0" rtlCol="0" anchor="ctr"/>
-          <a:lstStyle/>
-          <a:p>
-            <a:pPr indent="0" marL="0">
-              <a:buNone/>
-            </a:pPr>
-            <a:r>
-              <a:rPr lang="en-US" sz="1300" dirty="0">
-                <a:solidFill>
-                  <a:srgbClr val="5C6B76"/>
-                </a:solidFill>
-                <a:latin typeface="Garamond" pitchFamily="34" charset="0"/>
-                <a:ea typeface="Garamond" pitchFamily="34" charset="-122"/>
-                <a:cs typeface="Garamond" pitchFamily="34" charset="-120"/>
-              </a:rPr>
-              <a:t>Market entry is sequenced in two phases, with production investment committed only after the quality of orders has been confirmed.</a:t>
-            </a:r>
-            <a:endParaRPr lang="en-US" sz="1300" dirty="0"/>
-          </a:p>
-        </p:txBody>
-      </p:sp>
-      <p:sp>
-        <p:nvSpPr>
-          <p:cNvPr id="8" name="Shape 4"/>
-          <p:cNvSpPr/>
-          <p:nvPr/>
-        </p:nvSpPr>
-        <p:spPr>
-          <a:xfrm>
-            <a:off x="822960" y="1874519"/>
-            <a:ext cx="5175504" cy="3429000"/>
-          </a:xfrm>
-          <a:prstGeom prst="roundRect">
-            <a:avLst>
-              <a:gd name="adj" fmla="val 1724"/>
-            </a:avLst>
-          </a:prstGeom>
-          <a:solidFill>
-            <a:srgbClr val="F3F7FA"/>
-          </a:solidFill>
-          <a:ln/>
-        </p:spPr>
-        <p:txBody>
-          <a:bodyPr/>
-          <a:p/>
-        </p:txBody>
-      </p:sp>
-      <p:sp>
-        <p:nvSpPr>
-          <p:cNvPr id="9" name="Shape 5"/>
-          <p:cNvSpPr/>
-          <p:nvPr/>
-        </p:nvSpPr>
-        <p:spPr>
-          <a:xfrm>
-            <a:off x="1005840" y="2075687"/>
-            <a:ext cx="384048" cy="384048"/>
-          </a:xfrm>
-          <a:prstGeom prst="ellipse">
-            <a:avLst/>
-          </a:prstGeom>
-          <a:solidFill>
-            <a:srgbClr val="007BCB"/>
-          </a:solidFill>
-          <a:ln/>
-        </p:spPr>
-        <p:txBody>
-          <a:bodyPr/>
-          <a:p/>
-        </p:txBody>
-      </p:sp>
-      <p:sp>
-        <p:nvSpPr>
-          <p:cNvPr id="10" name="Text 6"/>
-          <p:cNvSpPr/>
-          <p:nvPr/>
-        </p:nvSpPr>
-        <p:spPr>
-          <a:xfrm>
-            <a:off x="1005840" y="2075687"/>
-            <a:ext cx="384048" cy="384048"/>
-          </a:xfrm>
-          <a:prstGeom prst="rect">
-            <a:avLst/>
-          </a:prstGeom>
-          <a:noFill/>
-          <a:ln/>
-        </p:spPr>
-        <p:txBody>
-          <a:bodyPr wrap="square" lIns="0" tIns="0" rIns="0" bIns="0" rtlCol="0" anchor="ctr"/>
-          <a:lstStyle/>
-          <a:p>
-            <a:pPr algn="ctr" indent="0" marL="0">
-              <a:buNone/>
-            </a:pPr>
-            <a:r>
-              <a:rPr lang="en-US" sz="1500" b="1" dirty="0">
-                <a:solidFill>
-                  <a:srgbClr val="FFFFFF"/>
-                </a:solidFill>
-                <a:latin typeface="Garamond" pitchFamily="34" charset="0"/>
-                <a:ea typeface="Garamond" pitchFamily="34" charset="-122"/>
-                <a:cs typeface="Garamond" pitchFamily="34" charset="-120"/>
-              </a:rPr>
-              <a:t>1</a:t>
-            </a:r>
-            <a:endParaRPr lang="en-US" sz="1500" dirty="0"/>
-          </a:p>
-        </p:txBody>
-      </p:sp>
-      <p:sp>
-        <p:nvSpPr>
-          <p:cNvPr id="11" name="Text 7"/>
-          <p:cNvSpPr/>
-          <p:nvPr/>
-        </p:nvSpPr>
-        <p:spPr>
-          <a:xfrm>
-            <a:off x="1005840" y="2606039"/>
-            <a:ext cx="4809744" cy="640080"/>
-          </a:xfrm>
-          <a:prstGeom prst="rect">
-            <a:avLst/>
-          </a:prstGeom>
-          <a:noFill/>
-          <a:ln/>
-        </p:spPr>
-        <p:txBody>
-          <a:bodyPr wrap="square" lIns="0" tIns="0" rIns="0" bIns="0" rtlCol="0" anchor="ctr"/>
-          <a:lstStyle/>
-          <a:p>
-            <a:pPr indent="0" marL="0">
-              <a:buNone/>
-            </a:pPr>
-            <a:r>
-              <a:rPr lang="en-US" sz="1550" b="1" dirty="0">
-                <a:solidFill>
-                  <a:srgbClr val="10222F"/>
-                </a:solidFill>
-                <a:latin typeface="Garamond" pitchFamily="34" charset="0"/>
-                <a:ea typeface="Garamond" pitchFamily="34" charset="-122"/>
-                <a:cs typeface="Garamond" pitchFamily="34" charset="-120"/>
-              </a:rPr>
-              <a:t>Sell to Overseas Clients and Take Orders</a:t>
-            </a:r>
-            <a:endParaRPr lang="en-US" sz="1550" dirty="0"/>
-          </a:p>
-        </p:txBody>
-      </p:sp>
-      <p:sp>
-        <p:nvSpPr>
-          <p:cNvPr id="12" name="Text 8"/>
-          <p:cNvSpPr/>
-          <p:nvPr/>
-        </p:nvSpPr>
-        <p:spPr>
-          <a:xfrm>
-            <a:off x="1005840" y="3337559"/>
-            <a:ext cx="4809744" cy="2194560"/>
-          </a:xfrm>
-          <a:prstGeom prst="rect">
-            <a:avLst/>
-          </a:prstGeom>
-          <a:noFill/>
-          <a:ln/>
-        </p:spPr>
-        <p:txBody>
-          <a:bodyPr wrap="square" lIns="0" tIns="0" rIns="0" bIns="0" rtlCol="0" anchor="t"/>
-          <a:lstStyle/>
-          <a:p>
-            <a:pPr indent="0" marL="0">
-              <a:lnSpc>
-                <a:spcPct val="106000"/>
-              </a:lnSpc>
-              <a:buNone/>
-            </a:pPr>
-            <a:r>
-              <a:rPr lang="en-US" sz="1100" dirty="0">
-                <a:solidFill>
-                  <a:srgbClr val="1E2A33"/>
-                </a:solidFill>
-                <a:latin typeface="Garamond" pitchFamily="34" charset="0"/>
-                <a:ea typeface="Garamond" pitchFamily="34" charset="-122"/>
-                <a:cs typeface="Garamond" pitchFamily="34" charset="-120"/>
-              </a:rPr>
-              <a:t>Sell products to overseas clients, establish a base of export customers, and convert engagement into a firm order book. Every component in the current portfolio is available for sale to overseas clients, allowing revenue capture from existing product lines without new development.</a:t>
-            </a:r>
-            <a:endParaRPr lang="en-US" sz="1100" dirty="0"/>
-          </a:p>
-        </p:txBody>
-      </p:sp>
-      <p:sp>
-        <p:nvSpPr>
-          <p:cNvPr id="13" name="Shape 4"/>
-          <p:cNvSpPr/>
-          <p:nvPr/>
-        </p:nvSpPr>
-        <p:spPr>
-          <a:xfrm>
-            <a:off x="6190488" y="1874519"/>
-            <a:ext cx="5175504" cy="3429000"/>
-          </a:xfrm>
-          <a:prstGeom prst="roundRect">
-            <a:avLst>
-              <a:gd name="adj" fmla="val 1724"/>
-            </a:avLst>
-          </a:prstGeom>
-          <a:solidFill>
-            <a:srgbClr val="F3F7FA"/>
-          </a:solidFill>
-          <a:ln/>
-        </p:spPr>
-        <p:txBody>
-          <a:bodyPr/>
-          <a:p/>
-        </p:txBody>
-      </p:sp>
-      <p:sp>
-        <p:nvSpPr>
-          <p:cNvPr id="14" name="Shape 5"/>
-          <p:cNvSpPr/>
-          <p:nvPr/>
-        </p:nvSpPr>
-        <p:spPr>
-          <a:xfrm>
-            <a:off x="6373368" y="2075687"/>
-            <a:ext cx="384048" cy="384048"/>
-          </a:xfrm>
-          <a:prstGeom prst="ellipse">
-            <a:avLst/>
-          </a:prstGeom>
-          <a:solidFill>
-            <a:srgbClr val="007BCB"/>
-          </a:solidFill>
-          <a:ln/>
-        </p:spPr>
-        <p:txBody>
-          <a:bodyPr/>
-          <a:p/>
-        </p:txBody>
-      </p:sp>
-      <p:sp>
-        <p:nvSpPr>
-          <p:cNvPr id="15" name="Text 6"/>
-          <p:cNvSpPr/>
-          <p:nvPr/>
-        </p:nvSpPr>
-        <p:spPr>
-          <a:xfrm>
-            <a:off x="6373368" y="2075687"/>
-            <a:ext cx="384048" cy="384048"/>
-          </a:xfrm>
-          <a:prstGeom prst="rect">
-            <a:avLst/>
-          </a:prstGeom>
-          <a:noFill/>
-          <a:ln/>
-        </p:spPr>
-        <p:txBody>
-          <a:bodyPr wrap="square" lIns="0" tIns="0" rIns="0" bIns="0" rtlCol="0" anchor="ctr"/>
-          <a:lstStyle/>
-          <a:p>
-            <a:pPr algn="ctr" indent="0" marL="0">
-              <a:buNone/>
-            </a:pPr>
-            <a:r>
-              <a:rPr lang="en-US" sz="1500" b="1" dirty="0">
-                <a:solidFill>
-                  <a:srgbClr val="FFFFFF"/>
-                </a:solidFill>
-                <a:latin typeface="Garamond" pitchFamily="34" charset="0"/>
-                <a:ea typeface="Garamond" pitchFamily="34" charset="-122"/>
-                <a:cs typeface="Garamond" pitchFamily="34" charset="-120"/>
-              </a:rPr>
-              <a:t>2</a:t>
-            </a:r>
-            <a:endParaRPr lang="en-US" sz="1500" dirty="0"/>
-          </a:p>
-        </p:txBody>
-      </p:sp>
-      <p:sp>
-        <p:nvSpPr>
-          <p:cNvPr id="16" name="Text 7"/>
-          <p:cNvSpPr/>
-          <p:nvPr/>
-        </p:nvSpPr>
-        <p:spPr>
-          <a:xfrm>
-            <a:off x="6373368" y="2606039"/>
-            <a:ext cx="4809744" cy="640080"/>
-          </a:xfrm>
-          <a:prstGeom prst="rect">
-            <a:avLst/>
-          </a:prstGeom>
-          <a:noFill/>
-          <a:ln/>
-        </p:spPr>
-        <p:txBody>
-          <a:bodyPr wrap="square" lIns="0" tIns="0" rIns="0" bIns="0" rtlCol="0" anchor="ctr"/>
-          <a:lstStyle/>
-          <a:p>
-            <a:pPr indent="0" marL="0">
-              <a:buNone/>
-            </a:pPr>
-            <a:r>
-              <a:rPr lang="en-US" sz="1550" b="1" dirty="0">
-                <a:solidFill>
-                  <a:srgbClr val="10222F"/>
-                </a:solidFill>
-                <a:latin typeface="Garamond" pitchFamily="34" charset="0"/>
-                <a:ea typeface="Garamond" pitchFamily="34" charset="-122"/>
-                <a:cs typeface="Garamond" pitchFamily="34" charset="-120"/>
-              </a:rPr>
-              <a:t>Establish Supply Chain and Volume Production in China</a:t>
-            </a:r>
-            <a:endParaRPr lang="en-US" sz="1550" dirty="0"/>
-          </a:p>
-        </p:txBody>
-      </p:sp>
-      <p:sp>
-        <p:nvSpPr>
-          <p:cNvPr id="17" name="Text 8"/>
-          <p:cNvSpPr/>
-          <p:nvPr/>
-        </p:nvSpPr>
-        <p:spPr>
-          <a:xfrm>
-            <a:off x="6373368" y="3337559"/>
-            <a:ext cx="4809744" cy="2194560"/>
-          </a:xfrm>
-          <a:prstGeom prst="rect">
-            <a:avLst/>
-          </a:prstGeom>
-          <a:noFill/>
-          <a:ln/>
-        </p:spPr>
-        <p:txBody>
-          <a:bodyPr wrap="square" lIns="0" tIns="0" rIns="0" bIns="0" rtlCol="0" anchor="t"/>
-          <a:lstStyle/>
-          <a:p>
-            <a:pPr indent="0" marL="0">
-              <a:lnSpc>
-                <a:spcPct val="106000"/>
-              </a:lnSpc>
-              <a:buNone/>
-            </a:pPr>
-            <a:r>
-              <a:rPr lang="en-US" sz="1100" dirty="0">
-                <a:solidFill>
-                  <a:srgbClr val="1E2A33"/>
-                </a:solidFill>
-                <a:latin typeface="Garamond" pitchFamily="34" charset="0"/>
-                <a:ea typeface="Garamond" pitchFamily="34" charset="-122"/>
-                <a:cs typeface="Garamond" pitchFamily="34" charset="-120"/>
-              </a:rPr>
-              <a:t>Once the quality of orders has been confirmed, establish a dedicated supply chain in China and stand up large scale production capacity. Volume manufacturing then serves the export order book with consistent quality and competitive cost.</a:t>
-            </a:r>
-            <a:endParaRPr lang="en-US" sz="1100" dirty="0"/>
-          </a:p>
-        </p:txBody>
-      </p:sp>
-      <p:sp>
-        <p:nvSpPr>
-          <p:cNvPr id="18" name="Text 22"/>
-          <p:cNvSpPr/>
-          <p:nvPr/>
-        </p:nvSpPr>
-        <p:spPr>
-          <a:xfrm>
-            <a:off x="822960" y="5577840"/>
-            <a:ext cx="10543032" cy="365760"/>
-          </a:xfrm>
-          <a:prstGeom prst="rect">
-            <a:avLst/>
-          </a:prstGeom>
-          <a:noFill/>
-          <a:ln/>
-        </p:spPr>
-        <p:txBody>
-          <a:bodyPr wrap="square" lIns="0" tIns="0" rIns="0" bIns="0" rtlCol="0" anchor="t"/>
-          <a:lstStyle/>
-          <a:p>
-            <a:pPr indent="0" marL="0">
-              <a:lnSpc>
-                <a:spcPct val="102000"/>
-              </a:lnSpc>
-              <a:buNone/>
-            </a:pPr>
-            <a:r>
-              <a:rPr lang="en-US" sz="1050" dirty="0">
-                <a:solidFill>
-                  <a:srgbClr val="1E2A33"/>
-                </a:solidFill>
-                <a:latin typeface="Garamond" pitchFamily="34" charset="0"/>
-                <a:ea typeface="Garamond" pitchFamily="34" charset="-122"/>
-                <a:cs typeface="Garamond" pitchFamily="34" charset="-120"/>
-              </a:rPr>
-              <a:t>Capital deployment in Phase Two is gated on confirmed order quality, keeping production capacity aligned with demonstrated demand.</a:t>
-            </a:r>
-            <a:endParaRPr lang="en-US" sz="1050" dirty="0"/>
-          </a:p>
-        </p:txBody>
-      </p:sp>
-    </p:spTree>
-  </p:cSld>
-  <p:clrMapOvr>
-    <a:masterClrMapping/>
-  </p:clrMapOvr>
-</p:sld>
-</file>
-
-<file path=ppt/slides/slide16.xml><?xml version="1.0" encoding="utf-8"?>
-<p:sld xmlns:a="http://schemas.openxmlformats.org/drawingml/2006/main" xmlns:p="http://schemas.openxmlformats.org/presentationml/2006/main" xmlns:r="http://schemas.openxmlformats.org/officeDocument/2006/relationships">
-  <p:cSld>
-    <p:spTree>
-      <p:nvGrpSpPr>
-        <p:cNvPr id="1" name=""/>
-        <p:cNvGrpSpPr/>
-        <p:nvPr/>
-      </p:nvGrpSpPr>
-      <p:grpSpPr/>
-      <p:sp>
-        <p:nvSpPr>
-          <p:cNvPr id="2" name="Text 0"/>
-          <p:cNvSpPr/>
-          <p:nvPr/>
-        </p:nvSpPr>
-        <p:spPr>
-          <a:xfrm>
-            <a:off x="822960" y="457200"/>
-            <a:ext cx="7772400" cy="274320"/>
-          </a:xfrm>
-          <a:prstGeom prst="rect">
-            <a:avLst/>
-          </a:prstGeom>
-          <a:noFill/>
-          <a:ln/>
-        </p:spPr>
-        <p:txBody>
-          <a:bodyPr wrap="square" lIns="0" tIns="0" rIns="0" bIns="0" rtlCol="0" anchor="ctr"/>
-          <a:lstStyle/>
-          <a:p>
-            <a:pPr indent="0" marL="0">
-              <a:buNone/>
-            </a:pPr>
-            <a:r>
-              <a:rPr lang="en-US" sz="1100" b="1" spc="300" kern="0" dirty="0">
-                <a:solidFill>
-                  <a:srgbClr val="007BCB"/>
-                </a:solidFill>
-                <a:latin typeface="Garamond" pitchFamily="34" charset="0"/>
-                <a:ea typeface="Garamond" pitchFamily="34" charset="-122"/>
-                <a:cs typeface="Garamond" pitchFamily="34" charset="-120"/>
-              </a:rPr>
-              <a:t>CHINA STRATEGY</a:t>
-            </a:r>
-            <a:endParaRPr lang="en-US" sz="1100" dirty="0"/>
-          </a:p>
-        </p:txBody>
-      </p:sp>
-      <p:sp>
-        <p:nvSpPr>
-          <p:cNvPr id="3" name="Text 1"/>
-          <p:cNvSpPr/>
-          <p:nvPr/>
-        </p:nvSpPr>
-        <p:spPr>
-          <a:xfrm>
-            <a:off x="822960" y="713232"/>
-            <a:ext cx="8961120" cy="566928"/>
-          </a:xfrm>
-          <a:prstGeom prst="rect">
-            <a:avLst/>
-          </a:prstGeom>
-          <a:noFill/>
-          <a:ln/>
-        </p:spPr>
-        <p:txBody>
-          <a:bodyPr wrap="square" lIns="0" tIns="0" rIns="0" bIns="0" rtlCol="0" anchor="ctr"/>
-          <a:lstStyle/>
-          <a:p>
-            <a:pPr indent="0" marL="0">
-              <a:buNone/>
-            </a:pPr>
-            <a:r>
-              <a:rPr lang="en-US" sz="2900" b="1" dirty="0">
-                <a:solidFill>
-                  <a:srgbClr val="10222F"/>
-                </a:solidFill>
-                <a:latin typeface="Garamond" pitchFamily="34" charset="0"/>
-                <a:ea typeface="Garamond" pitchFamily="34" charset="-122"/>
-                <a:cs typeface="Garamond" pitchFamily="34" charset="-120"/>
-              </a:rPr>
-              <a:t>Competitive Position and Route to Market</a:t>
-            </a:r>
-            <a:endParaRPr lang="en-US" sz="2900" dirty="0"/>
-          </a:p>
-        </p:txBody>
-      </p:sp>
-      <p:pic>
-        <p:nvPicPr>
-          <p:cNvPr id="4" name="Image 0" descr="assets/logo_dark.jpg">    </p:cNvPr>
-          <p:cNvPicPr>
-            <a:picLocks noChangeAspect="1"/>
-          </p:cNvPicPr>
-          <p:nvPr/>
-        </p:nvPicPr>
-        <p:blipFill>
-          <a:blip r:embed="rId2"/>
-          <a:stretch>
-            <a:fillRect/>
-          </a:stretch>
-        </p:blipFill>
-        <p:spPr>
-          <a:xfrm>
-            <a:off x="10058400" y="475488"/>
-            <a:ext cx="1325880" cy="372161"/>
-          </a:xfrm>
-          <a:prstGeom prst="rect">
-            <a:avLst/>
-          </a:prstGeom>
-        </p:spPr>
-      </p:pic>
-      <p:sp>
-        <p:nvSpPr>
-          <p:cNvPr id="5" name="Text 2"/>
-          <p:cNvSpPr/>
-          <p:nvPr/>
-        </p:nvSpPr>
-        <p:spPr>
-          <a:xfrm>
-            <a:off x="822960" y="6492240"/>
-            <a:ext cx="5943600" cy="237744"/>
-          </a:xfrm>
-          <a:prstGeom prst="rect">
-            <a:avLst/>
-          </a:prstGeom>
-          <a:noFill/>
-          <a:ln/>
-        </p:spPr>
-        <p:txBody>
-          <a:bodyPr wrap="square" lIns="0" tIns="0" rIns="0" bIns="0" rtlCol="0" anchor="ctr"/>
-          <a:lstStyle/>
-          <a:p>
-            <a:pPr indent="0" marL="0">
-              <a:buNone/>
-            </a:pPr>
-            <a:r>
-              <a:rPr lang="en-US" sz="850" dirty="0">
-                <a:solidFill>
-                  <a:srgbClr val="5C6B76"/>
-                </a:solidFill>
-                <a:latin typeface="Garamond" pitchFamily="34" charset="0"/>
-                <a:ea typeface="Garamond" pitchFamily="34" charset="-122"/>
-                <a:cs typeface="Garamond" pitchFamily="34" charset="-120"/>
-              </a:rPr>
-              <a:t>Heliospace Corporation   |   Proprietary and Confidential</a:t>
-            </a:r>
-            <a:endParaRPr lang="en-US" sz="850" dirty="0"/>
-          </a:p>
-        </p:txBody>
-      </p:sp>
-      <p:sp>
-        <p:nvSpPr>
-          <p:cNvPr id="6" name="Text 3"/>
-          <p:cNvSpPr/>
-          <p:nvPr/>
-        </p:nvSpPr>
-        <p:spPr>
-          <a:xfrm>
-            <a:off x="11064240" y="6492240"/>
-            <a:ext cx="320040" cy="237744"/>
-          </a:xfrm>
-          <a:prstGeom prst="rect">
-            <a:avLst/>
-          </a:prstGeom>
-          <a:noFill/>
-          <a:ln/>
-        </p:spPr>
-        <p:txBody>
-          <a:bodyPr wrap="square" lIns="0" tIns="0" rIns="0" bIns="0" rtlCol="0" anchor="ctr"/>
-          <a:lstStyle/>
-          <a:p>
-            <a:pPr algn="r" indent="0" marL="0">
-              <a:buNone/>
-            </a:pPr>
-            <a:r>
-              <a:rPr lang="en-US" sz="850" dirty="0">
-                <a:solidFill>
-                  <a:srgbClr val="5C6B76"/>
-                </a:solidFill>
-                <a:latin typeface="Garamond" pitchFamily="34" charset="0"/>
-                <a:ea typeface="Garamond" pitchFamily="34" charset="-122"/>
-                <a:cs typeface="Garamond" pitchFamily="34" charset="-120"/>
-              </a:rPr>
-              <a:t>16</a:t>
-            </a:r>
-            <a:endParaRPr lang="en-US" sz="850" dirty="0"/>
-          </a:p>
-        </p:txBody>
-      </p:sp>
-      <p:sp>
-        <p:nvSpPr>
-          <p:cNvPr id="7" name="Text 4"/>
-          <p:cNvSpPr/>
-          <p:nvPr/>
-        </p:nvSpPr>
-        <p:spPr>
-          <a:xfrm>
-            <a:off x="822960" y="1353312"/>
-            <a:ext cx="10424160" cy="320040"/>
-          </a:xfrm>
-          <a:prstGeom prst="rect">
-            <a:avLst/>
-          </a:prstGeom>
-          <a:noFill/>
-          <a:ln/>
-        </p:spPr>
-        <p:txBody>
-          <a:bodyPr wrap="square" lIns="0" tIns="0" rIns="0" bIns="0" rtlCol="0" anchor="ctr"/>
-          <a:lstStyle/>
-          <a:p>
-            <a:pPr indent="0" marL="0">
-              <a:buNone/>
-            </a:pPr>
-            <a:r>
-              <a:rPr lang="en-US" sz="1300" dirty="0">
-                <a:solidFill>
-                  <a:srgbClr val="5C6B76"/>
-                </a:solidFill>
-                <a:latin typeface="Garamond" pitchFamily="34" charset="0"/>
-                <a:ea typeface="Garamond" pitchFamily="34" charset="-122"/>
-                <a:cs typeface="Garamond" pitchFamily="34" charset="-120"/>
-              </a:rPr>
-              <a:t>A proven supplier with marquee clients, differentiated products, and a clear route to serving Chinese customers.</a:t>
-            </a:r>
-            <a:endParaRPr lang="en-US" sz="1300" dirty="0"/>
-          </a:p>
-        </p:txBody>
-      </p:sp>
-      <p:sp>
-        <p:nvSpPr>
-          <p:cNvPr id="8" name="Text 4"/>
-          <p:cNvSpPr/>
-          <p:nvPr/>
-        </p:nvSpPr>
-        <p:spPr>
-          <a:xfrm>
-            <a:off x="822960" y="1828800"/>
-            <a:ext cx="5175504" cy="256032"/>
-          </a:xfrm>
-          <a:prstGeom prst="rect">
-            <a:avLst/>
-          </a:prstGeom>
-          <a:noFill/>
-          <a:ln/>
-        </p:spPr>
-        <p:txBody>
-          <a:bodyPr wrap="square" lIns="0" tIns="0" rIns="0" bIns="0" rtlCol="0" anchor="ctr"/>
-          <a:lstStyle/>
-          <a:p>
-            <a:pPr indent="0" marL="0">
-              <a:buNone/>
-            </a:pPr>
-            <a:r>
-              <a:rPr lang="en-US" sz="1350" b="1" dirty="0">
-                <a:solidFill>
-                  <a:srgbClr val="007BCB"/>
-                </a:solidFill>
-                <a:latin typeface="Garamond" pitchFamily="34" charset="0"/>
-                <a:ea typeface="Garamond" pitchFamily="34" charset="-122"/>
-                <a:cs typeface="Garamond" pitchFamily="34" charset="-120"/>
-              </a:rPr>
-              <a:t>Why Heliospace is competitive</a:t>
-            </a:r>
-            <a:endParaRPr lang="en-US" sz="1350" dirty="0"/>
-          </a:p>
-        </p:txBody>
-      </p:sp>
-      <p:sp>
-        <p:nvSpPr>
-          <p:cNvPr id="9" name="Text 5"/>
-          <p:cNvSpPr/>
-          <p:nvPr/>
-        </p:nvSpPr>
-        <p:spPr>
-          <a:xfrm>
-            <a:off x="822960" y="2121408"/>
-            <a:ext cx="5175504" cy="914400"/>
-          </a:xfrm>
-          <a:prstGeom prst="rect">
-            <a:avLst/>
-          </a:prstGeom>
-          <a:noFill/>
-          <a:ln/>
-        </p:spPr>
-        <p:txBody>
-          <a:bodyPr wrap="square" lIns="0" tIns="0" rIns="0" bIns="0" rtlCol="0" anchor="t"/>
-          <a:lstStyle/>
-          <a:p>
-            <a:pPr indent="0" marL="0">
-              <a:buNone/>
-            </a:pPr>
-            <a:r>
-              <a:rPr lang="en-US" sz="1150" dirty="0">
-                <a:solidFill>
-                  <a:srgbClr val="1E2A33"/>
-                </a:solidFill>
-                <a:latin typeface="Garamond" pitchFamily="34" charset="0"/>
-                <a:ea typeface="Garamond" pitchFamily="34" charset="-122"/>
-                <a:cs typeface="Garamond" pitchFamily="34" charset="-120"/>
-              </a:rPr>
-              <a:t>Decades of flight heritage with NASA and ESA, an in house boom forming capability that removes supplier risk, and a lean cost structure that delivers fully qualified hardware at competitive prices and short lead times.</a:t>
-            </a:r>
-            <a:endParaRPr lang="en-US" sz="1150" dirty="0"/>
-          </a:p>
-        </p:txBody>
-      </p:sp>
-      <p:sp>
-        <p:nvSpPr>
-          <p:cNvPr id="10" name="Text 4"/>
-          <p:cNvSpPr/>
-          <p:nvPr/>
-        </p:nvSpPr>
-        <p:spPr>
-          <a:xfrm>
-            <a:off x="822960" y="3200400"/>
-            <a:ext cx="5175504" cy="256032"/>
-          </a:xfrm>
-          <a:prstGeom prst="rect">
-            <a:avLst/>
-          </a:prstGeom>
-          <a:noFill/>
-          <a:ln/>
-        </p:spPr>
-        <p:txBody>
-          <a:bodyPr wrap="square" lIns="0" tIns="0" rIns="0" bIns="0" rtlCol="0" anchor="ctr"/>
-          <a:lstStyle/>
-          <a:p>
-            <a:pPr indent="0" marL="0">
-              <a:buNone/>
-            </a:pPr>
-            <a:r>
-              <a:rPr lang="en-US" sz="1350" b="1" dirty="0">
-                <a:solidFill>
-                  <a:srgbClr val="007BCB"/>
-                </a:solidFill>
-                <a:latin typeface="Garamond" pitchFamily="34" charset="0"/>
-                <a:ea typeface="Garamond" pitchFamily="34" charset="-122"/>
-                <a:cs typeface="Garamond" pitchFamily="34" charset="-120"/>
-              </a:rPr>
-              <a:t>An established client base</a:t>
-            </a:r>
-            <a:endParaRPr lang="en-US" sz="1350" dirty="0"/>
-          </a:p>
-        </p:txBody>
-      </p:sp>
-      <p:sp>
-        <p:nvSpPr>
-          <p:cNvPr id="11" name="Text 5"/>
-          <p:cNvSpPr/>
-          <p:nvPr/>
-        </p:nvSpPr>
-        <p:spPr>
-          <a:xfrm>
-            <a:off x="822960" y="3493008"/>
-            <a:ext cx="5175504" cy="1051560"/>
-          </a:xfrm>
-          <a:prstGeom prst="rect">
-            <a:avLst/>
-          </a:prstGeom>
-          <a:noFill/>
-          <a:ln/>
-        </p:spPr>
-        <p:txBody>
-          <a:bodyPr wrap="square" lIns="0" tIns="0" rIns="0" bIns="0" rtlCol="0" anchor="t"/>
-          <a:lstStyle/>
-          <a:p>
-            <a:pPr indent="0" marL="0">
-              <a:buNone/>
-            </a:pPr>
-            <a:r>
-              <a:rPr lang="en-US" sz="1150" dirty="0">
-                <a:solidFill>
-                  <a:srgbClr val="1E2A33"/>
-                </a:solidFill>
-                <a:latin typeface="Garamond" pitchFamily="34" charset="0"/>
-                <a:ea typeface="Garamond" pitchFamily="34" charset="-122"/>
-                <a:cs typeface="Garamond" pitchFamily="34" charset="-120"/>
-              </a:rPr>
-              <a:t>NASA JPL, NASA Goddard, Caltech, UC Berkeley Space Sciences Laboratory, Firefly Aerospace, Intuitive Machines, SwRI, and Blue Origin, with hardware operating on Europa Clipper, Solar Orbiter, and the first commercial lunar landings.</a:t>
-            </a:r>
-            <a:endParaRPr lang="en-US" sz="1150" dirty="0"/>
-          </a:p>
-        </p:txBody>
-      </p:sp>
-      <p:sp>
-        <p:nvSpPr>
-          <p:cNvPr id="12" name="Text 4"/>
-          <p:cNvSpPr/>
-          <p:nvPr/>
-        </p:nvSpPr>
-        <p:spPr>
-          <a:xfrm>
-            <a:off x="822960" y="4709160"/>
-            <a:ext cx="5175504" cy="256032"/>
-          </a:xfrm>
-          <a:prstGeom prst="rect">
-            <a:avLst/>
-          </a:prstGeom>
-          <a:noFill/>
-          <a:ln/>
-        </p:spPr>
-        <p:txBody>
-          <a:bodyPr wrap="square" lIns="0" tIns="0" rIns="0" bIns="0" rtlCol="0" anchor="ctr"/>
-          <a:lstStyle/>
-          <a:p>
-            <a:pPr indent="0" marL="0">
-              <a:buNone/>
-            </a:pPr>
-            <a:r>
-              <a:rPr lang="en-US" sz="1350" b="1" dirty="0">
-                <a:solidFill>
-                  <a:srgbClr val="007BCB"/>
-                </a:solidFill>
-                <a:latin typeface="Garamond" pitchFamily="34" charset="0"/>
-                <a:ea typeface="Garamond" pitchFamily="34" charset="-122"/>
-                <a:cs typeface="Garamond" pitchFamily="34" charset="-120"/>
-              </a:rPr>
-              <a:t>Why customers choose us</a:t>
-            </a:r>
-            <a:endParaRPr lang="en-US" sz="1350" dirty="0"/>
-          </a:p>
-        </p:txBody>
-      </p:sp>
-      <p:sp>
-        <p:nvSpPr>
-          <p:cNvPr id="13" name="Text 5"/>
-          <p:cNvSpPr/>
-          <p:nvPr/>
-        </p:nvSpPr>
-        <p:spPr>
-          <a:xfrm>
-            <a:off x="822960" y="5001768"/>
-            <a:ext cx="5175504" cy="914400"/>
-          </a:xfrm>
-          <a:prstGeom prst="rect">
-            <a:avLst/>
-          </a:prstGeom>
-          <a:noFill/>
-          <a:ln/>
-        </p:spPr>
-        <p:txBody>
-          <a:bodyPr wrap="square" lIns="0" tIns="0" rIns="0" bIns="0" rtlCol="0" anchor="t"/>
-          <a:lstStyle/>
-          <a:p>
-            <a:pPr indent="0" marL="0">
-              <a:buNone/>
-            </a:pPr>
-            <a:r>
-              <a:rPr lang="en-US" sz="1150" dirty="0">
-                <a:solidFill>
-                  <a:srgbClr val="1E2A33"/>
-                </a:solidFill>
-                <a:latin typeface="Garamond" pitchFamily="34" charset="0"/>
-                <a:ea typeface="Garamond" pitchFamily="34" charset="-122"/>
-                <a:cs typeface="Garamond" pitchFamily="34" charset="-120"/>
-              </a:rPr>
-              <a:t>Supplier of record on marquee missions, on schedule delivery for launch critical payloads, and repeat awards across programs and platforms.</a:t>
-            </a:r>
-            <a:endParaRPr lang="en-US" sz="1150" dirty="0"/>
-          </a:p>
-        </p:txBody>
-      </p:sp>
-      <p:sp>
-        <p:nvSpPr>
-          <p:cNvPr id="14" name="Text 4"/>
-          <p:cNvSpPr/>
-          <p:nvPr/>
-        </p:nvSpPr>
-        <p:spPr>
-          <a:xfrm>
-            <a:off x="6190488" y="1828800"/>
-            <a:ext cx="5175504" cy="256032"/>
-          </a:xfrm>
-          <a:prstGeom prst="rect">
-            <a:avLst/>
-          </a:prstGeom>
-          <a:noFill/>
-          <a:ln/>
-        </p:spPr>
-        <p:txBody>
-          <a:bodyPr wrap="square" lIns="0" tIns="0" rIns="0" bIns="0" rtlCol="0" anchor="ctr"/>
-          <a:lstStyle/>
-          <a:p>
-            <a:pPr indent="0" marL="0">
-              <a:buNone/>
-            </a:pPr>
-            <a:r>
-              <a:rPr lang="en-US" sz="1350" b="1" dirty="0">
-                <a:solidFill>
-                  <a:srgbClr val="007BCB"/>
-                </a:solidFill>
-                <a:latin typeface="Garamond" pitchFamily="34" charset="0"/>
-                <a:ea typeface="Garamond" pitchFamily="34" charset="-122"/>
-                <a:cs typeface="Garamond" pitchFamily="34" charset="-120"/>
-              </a:rPr>
-              <a:t>Why our products are competitive</a:t>
-            </a:r>
-            <a:endParaRPr lang="en-US" sz="1350" dirty="0"/>
-          </a:p>
-        </p:txBody>
-      </p:sp>
-      <p:sp>
-        <p:nvSpPr>
-          <p:cNvPr id="15" name="Text 13"/>
-          <p:cNvSpPr/>
-          <p:nvPr/>
-        </p:nvSpPr>
-        <p:spPr>
-          <a:xfrm>
-            <a:off x="6190488" y="2121408"/>
-            <a:ext cx="5175504" cy="1600200"/>
-          </a:xfrm>
-          <a:prstGeom prst="rect">
-            <a:avLst/>
-          </a:prstGeom>
-          <a:noFill/>
-          <a:ln/>
-        </p:spPr>
-        <p:txBody>
-          <a:bodyPr wrap="square" lIns="0" tIns="0" rIns="0" bIns="0" rtlCol="0" anchor="t"/>
-          <a:lstStyle/>
-          <a:p>
-            <a:pPr algn="l" marL="127000" indent="-127000">
-              <a:spcAft>
-                <a:spcPts val="400"/>
-              </a:spcAft>
-              <a:buSzPct val="100000"/>
-              <a:buChar char="•"/>
-            </a:pPr>
-            <a:r>
-              <a:rPr lang="en-US" sz="1100" dirty="0">
-                <a:solidFill>
-                  <a:srgbClr val="1E2A33"/>
-                </a:solidFill>
-                <a:latin typeface="Garamond" pitchFamily="34" charset="0"/>
-                <a:ea typeface="Garamond" pitchFamily="34" charset="-122"/>
-                <a:cs typeface="Garamond" pitchFamily="34" charset="-120"/>
-              </a:rPr>
-              <a:t>Stow ratios of up to 50:1, well beyond typical deployables</a:t>
-            </a:r>
-            <a:endParaRPr lang="en-US" sz="1100" dirty="0"/>
-          </a:p>
-          <a:p>
-            <a:pPr algn="l" marL="127000" indent="-127000">
-              <a:spcAft>
-                <a:spcPts val="400"/>
-              </a:spcAft>
-              <a:buSzPct val="100000"/>
-              <a:buChar char="•"/>
-            </a:pPr>
-            <a:r>
-              <a:rPr lang="en-US" sz="1100" dirty="0">
-                <a:solidFill>
-                  <a:srgbClr val="1E2A33"/>
-                </a:solidFill>
-                <a:latin typeface="Garamond" pitchFamily="34" charset="0"/>
-                <a:ea typeface="Garamond" pitchFamily="34" charset="-122"/>
-                <a:cs typeface="Garamond" pitchFamily="34" charset="-120"/>
-              </a:rPr>
-              <a:t>Operating range of -200 C to +200 C</a:t>
-            </a:r>
-            <a:endParaRPr lang="en-US" sz="1100" dirty="0"/>
-          </a:p>
-          <a:p>
-            <a:pPr algn="l" marL="127000" indent="-127000">
-              <a:spcAft>
-                <a:spcPts val="400"/>
-              </a:spcAft>
-              <a:buSzPct val="100000"/>
-              <a:buChar char="•"/>
-            </a:pPr>
-            <a:r>
-              <a:rPr lang="en-US" sz="1100" dirty="0">
-                <a:solidFill>
-                  <a:srgbClr val="1E2A33"/>
-                </a:solidFill>
-                <a:latin typeface="Garamond" pitchFamily="34" charset="0"/>
-                <a:ea typeface="Garamond" pitchFamily="34" charset="-122"/>
-                <a:cs typeface="Garamond" pitchFamily="34" charset="-120"/>
-              </a:rPr>
-              <a:t>Redundant, non explosive release with no ordnance handling</a:t>
-            </a:r>
-            <a:endParaRPr lang="en-US" sz="1100" dirty="0"/>
-          </a:p>
-          <a:p>
-            <a:pPr algn="l" marL="127000" indent="-127000">
-              <a:spcAft>
-                <a:spcPts val="400"/>
-              </a:spcAft>
-              <a:buSzPct val="100000"/>
-              <a:buChar char="•"/>
-            </a:pPr>
-            <a:r>
-              <a:rPr lang="en-US" sz="1100" dirty="0">
-                <a:solidFill>
-                  <a:srgbClr val="1E2A33"/>
-                </a:solidFill>
-                <a:latin typeface="Garamond" pitchFamily="34" charset="0"/>
-                <a:ea typeface="Garamond" pitchFamily="34" charset="-122"/>
-                <a:cs typeface="Garamond" pitchFamily="34" charset="-120"/>
-              </a:rPr>
-              <a:t>Lower mass and cost with lead times measured in weeks</a:t>
-            </a:r>
-            <a:endParaRPr lang="en-US" sz="1100" dirty="0"/>
-          </a:p>
-          <a:p>
-            <a:pPr algn="l" marL="127000" indent="-127000">
-              <a:spcAft>
-                <a:spcPts val="400"/>
-              </a:spcAft>
-              <a:buSzPct val="100000"/>
-              <a:buChar char="•"/>
-            </a:pPr>
-            <a:r>
-              <a:rPr lang="en-US" sz="1100" dirty="0">
-                <a:solidFill>
-                  <a:srgbClr val="1E2A33"/>
-                </a:solidFill>
-                <a:latin typeface="Garamond" pitchFamily="34" charset="0"/>
-                <a:ea typeface="Garamond" pitchFamily="34" charset="-122"/>
-                <a:cs typeface="Garamond" pitchFamily="34" charset="-120"/>
-              </a:rPr>
-              <a:t>Hundreds of successful operational deployments</a:t>
-            </a:r>
-            <a:endParaRPr lang="en-US" sz="1100" dirty="0"/>
-          </a:p>
-        </p:txBody>
-      </p:sp>
-      <p:sp>
-        <p:nvSpPr>
-          <p:cNvPr id="16" name="Text 4"/>
-          <p:cNvSpPr/>
-          <p:nvPr/>
-        </p:nvSpPr>
-        <p:spPr>
-          <a:xfrm>
-            <a:off x="6190488" y="3977639"/>
-            <a:ext cx="5175504" cy="256032"/>
-          </a:xfrm>
-          <a:prstGeom prst="rect">
-            <a:avLst/>
-          </a:prstGeom>
-          <a:noFill/>
-          <a:ln/>
-        </p:spPr>
-        <p:txBody>
-          <a:bodyPr wrap="square" lIns="0" tIns="0" rIns="0" bIns="0" rtlCol="0" anchor="ctr"/>
-          <a:lstStyle/>
-          <a:p>
-            <a:pPr indent="0" marL="0">
-              <a:buNone/>
-            </a:pPr>
-            <a:r>
-              <a:rPr lang="en-US" sz="1350" b="1" dirty="0">
-                <a:solidFill>
-                  <a:srgbClr val="007BCB"/>
-                </a:solidFill>
-                <a:latin typeface="Garamond" pitchFamily="34" charset="0"/>
-                <a:ea typeface="Garamond" pitchFamily="34" charset="-122"/>
-                <a:cs typeface="Garamond" pitchFamily="34" charset="-120"/>
-              </a:rPr>
-              <a:t>How we sell to Chinese clients</a:t>
-            </a:r>
-            <a:endParaRPr lang="en-US" sz="1350" dirty="0"/>
-          </a:p>
-        </p:txBody>
-      </p:sp>
-      <p:sp>
-        <p:nvSpPr>
-          <p:cNvPr id="17" name="Text 13"/>
-          <p:cNvSpPr/>
-          <p:nvPr/>
-        </p:nvSpPr>
-        <p:spPr>
-          <a:xfrm>
-            <a:off x="6190488" y="4270248"/>
-            <a:ext cx="5175504" cy="1463040"/>
-          </a:xfrm>
-          <a:prstGeom prst="rect">
-            <a:avLst/>
-          </a:prstGeom>
-          <a:noFill/>
-          <a:ln/>
-        </p:spPr>
-        <p:txBody>
-          <a:bodyPr wrap="square" lIns="0" tIns="0" rIns="0" bIns="0" rtlCol="0" anchor="t"/>
-          <a:lstStyle/>
-          <a:p>
-            <a:pPr algn="l" marL="127000" indent="-127000">
-              <a:spcAft>
-                <a:spcPts val="400"/>
-              </a:spcAft>
-              <a:buSzPct val="100000"/>
-              <a:buChar char="•"/>
-            </a:pPr>
-            <a:r>
-              <a:rPr lang="en-US" sz="1100" dirty="0">
-                <a:solidFill>
-                  <a:srgbClr val="1E2A33"/>
-                </a:solidFill>
-                <a:latin typeface="Garamond" pitchFamily="34" charset="0"/>
-                <a:ea typeface="Garamond" pitchFamily="34" charset="-122"/>
-                <a:cs typeface="Garamond" pitchFamily="34" charset="-120"/>
-              </a:rPr>
-              <a:t>Offer qualified products and components through export orders</a:t>
-            </a:r>
-            <a:endParaRPr lang="en-US" sz="1100" dirty="0"/>
-          </a:p>
-          <a:p>
-            <a:pPr algn="l" marL="127000" indent="-127000">
-              <a:spcAft>
-                <a:spcPts val="400"/>
-              </a:spcAft>
-              <a:buSzPct val="100000"/>
-              <a:buChar char="•"/>
-            </a:pPr>
-            <a:r>
-              <a:rPr lang="en-US" sz="1100" dirty="0">
-                <a:solidFill>
-                  <a:srgbClr val="1E2A33"/>
-                </a:solidFill>
-                <a:latin typeface="Garamond" pitchFamily="34" charset="0"/>
-                <a:ea typeface="Garamond" pitchFamily="34" charset="-122"/>
-                <a:cs typeface="Garamond" pitchFamily="34" charset="-120"/>
-              </a:rPr>
-              <a:t>Let delivered flight hardware demonstrate reliability and value</a:t>
-            </a:r>
-            <a:endParaRPr lang="en-US" sz="1100" dirty="0"/>
-          </a:p>
-          <a:p>
-            <a:pPr algn="l" marL="127000" indent="-127000">
-              <a:spcAft>
-                <a:spcPts val="400"/>
-              </a:spcAft>
-              <a:buSzPct val="100000"/>
-              <a:buChar char="•"/>
-            </a:pPr>
-            <a:r>
-              <a:rPr lang="en-US" sz="1100" dirty="0">
-                <a:solidFill>
-                  <a:srgbClr val="1E2A33"/>
-                </a:solidFill>
-                <a:latin typeface="Garamond" pitchFamily="34" charset="0"/>
-                <a:ea typeface="Garamond" pitchFamily="34" charset="-122"/>
-                <a:cs typeface="Garamond" pitchFamily="34" charset="-120"/>
-              </a:rPr>
-              <a:t>Provide catalog pricing and published interfaces for fast procurement</a:t>
-            </a:r>
-            <a:endParaRPr lang="en-US" sz="1100" dirty="0"/>
-          </a:p>
-          <a:p>
-            <a:pPr algn="l" marL="127000" indent="-127000">
-              <a:spcAft>
-                <a:spcPts val="400"/>
-              </a:spcAft>
-              <a:buSzPct val="100000"/>
-              <a:buChar char="•"/>
-            </a:pPr>
-            <a:r>
-              <a:rPr lang="en-US" sz="1100" dirty="0">
-                <a:solidFill>
-                  <a:srgbClr val="1E2A33"/>
-                </a:solidFill>
-                <a:latin typeface="Garamond" pitchFamily="34" charset="0"/>
-                <a:ea typeface="Garamond" pitchFamily="34" charset="-122"/>
-                <a:cs typeface="Garamond" pitchFamily="34" charset="-120"/>
-              </a:rPr>
-              <a:t>Scale a China based supply chain and production as order quality is confirmed</a:t>
-            </a:r>
-            <a:endParaRPr lang="en-US" sz="1100" dirty="0"/>
-          </a:p>
-        </p:txBody>
-      </p:sp>
-    </p:spTree>
-  </p:cSld>
-  <p:clrMapOvr>
-    <a:masterClrMapping/>
-  </p:clrMapOvr>
-</p:sld>
-</file>
-
 <file path=ppt/slides/slide17.xml><?xml version="1.0" encoding="utf-8"?>
 <p:sld xmlns:a="http://schemas.openxmlformats.org/drawingml/2006/main" xmlns:r="http://schemas.openxmlformats.org/officeDocument/2006/relationships" xmlns:p="http://schemas.openxmlformats.org/presentationml/2006/main">
   <p:cSld name="Slide 16">
@@ -8499,7 +7096,7 @@
         <p:spPr>
           <a:xfrm>
             <a:off x="822960" y="3657600"/>
-            <a:ext cx="5577840" cy="2286000"/>
+            <a:ext cx="5577840" cy="1463040"/>
           </a:xfrm>
           <a:prstGeom prst="roundRect">
             <a:avLst>
@@ -8532,7 +7129,7 @@
         <p:spPr>
           <a:xfrm>
             <a:off x="1097280" y="3886200"/>
-            <a:ext cx="5120640" cy="1874520"/>
+            <a:ext cx="5120640" cy="1005840"/>
           </a:xfrm>
           <a:prstGeom prst="rect">
             <a:avLst/>
@@ -8600,55 +7197,6 @@
                 <a:cs typeface="Garamond" pitchFamily="34" charset="-120"/>
               </a:rPr>
               <a:t>rocky@helio.space   |   19921169641</a:t>
-            </a:r>
-            <a:endParaRPr lang="en-US" sz="1700" dirty="0"/>
-          </a:p>
-          <a:p>
-            <a:pPr indent="0" marL="0">
-              <a:spcAft>
-                <a:spcPts val="500"/>
-              </a:spcAft>
-              <a:buNone/>
-            </a:pPr>
-            <a:endParaRPr lang="en-US" sz="1700" dirty="0"/>
-          </a:p>
-          <a:p>
-            <a:pPr indent="0" marL="0">
-              <a:spcAft>
-                <a:spcPts val="500"/>
-              </a:spcAft>
-              <a:buNone/>
-            </a:pPr>
-            <a:r>
-              <a:rPr lang="en-US" sz="1100" dirty="0">
-                <a:solidFill>
-                  <a:srgbClr val="DCE8F1"/>
-                </a:solidFill>
-                <a:latin typeface="Garamond" pitchFamily="34" charset="0"/>
-                <a:ea typeface="Garamond" pitchFamily="34" charset="-122"/>
-                <a:cs typeface="Garamond" pitchFamily="34" charset="-120"/>
-              </a:rPr>
-              <a:t>info@helio.space   |   (510) 545-2666   |   www.helio.space</a:t>
-            </a:r>
-            <a:endParaRPr lang="en-US" sz="1700" dirty="0"/>
-          </a:p>
-          <a:p>
-            <a:pPr indent="0" marL="0">
-              <a:spcAft>
-                <a:spcPts val="500"/>
-              </a:spcAft>
-              <a:buNone/>
-            </a:pPr>
-            <a:r>
-              <a:rPr lang="en-US" sz="1100" dirty="0">
-                <a:solidFill>
-                  <a:srgbClr val="DCE8F1"/>
-                </a:solidFill>
-                <a:latin typeface="Garamond" pitchFamily="34" charset="0"/>
-                <a:ea typeface="Garamond" pitchFamily="34" charset="-122"/>
-                <a:cs typeface="Garamond" pitchFamily="34" charset="-120"/>
-              </a:rPr>
-              <a:t>2448 Sixth Street, Berkeley, CA 94710</a:t>
             </a:r>
             <a:endParaRPr lang="en-US" sz="1700" dirty="0"/>
           </a:p>

</xml_diff>

<commit_message>
Add client and partner logo grid to client base slide
Co-authored-by: anthonyleedu <anthonyleedu@users.noreply.github.com>
</commit_message>
<xml_diff>
--- a/Heliospace_Investor_Overview.pptx
+++ b/Heliospace_Investor_Overview.pptx
@@ -5859,199 +5859,365 @@
           </a:p>
         </p:txBody>
       </p:sp>
+      <p:sp>
+        <p:nvSpPr>
+          <p:cNvPr id="19" name="Text 15"/>
+          <p:cNvSpPr/>
+          <p:nvPr/>
+        </p:nvSpPr>
+        <p:spPr>
+          <a:xfrm>
+            <a:off x="7360920" y="4160520"/>
+            <a:ext cx="4005072" cy="274320"/>
+          </a:xfrm>
+          <a:prstGeom prst="rect">
+            <a:avLst/>
+          </a:prstGeom>
+          <a:noFill/>
+          <a:ln/>
+        </p:spPr>
+        <p:txBody>
+          <a:bodyPr wrap="square" lIns="0" tIns="0" rIns="0" bIns="0" rtlCol="0" anchor="ctr"/>
+          <a:lstStyle/>
+          <a:p>
+            <a:pPr indent="0" marL="0">
+              <a:buNone/>
+            </a:pPr>
+            <a:r>
+              <a:rPr lang="en-US" sz="950" i="1" dirty="0">
+                <a:solidFill>
+                  <a:srgbClr val="5C6B76"/>
+                </a:solidFill>
+                <a:latin typeface="Garamond" pitchFamily="34" charset="0"/>
+                <a:ea typeface="Garamond" pitchFamily="34" charset="-122"/>
+                <a:cs typeface="Garamond" pitchFamily="34" charset="-120"/>
+              </a:rPr>
+              <a:t>Selected clients and partners.</a:t>
+            </a:r>
+            <a:endParaRPr lang="en-US" sz="950" dirty="0"/>
+          </a:p>
+        </p:txBody>
+      </p:sp>
+      <p:sp>
+        <p:nvSpPr>
+          <p:cNvPr id="20" name="Shape 16"/>
+          <p:cNvSpPr/>
+          <p:nvPr/>
+        </p:nvSpPr>
+        <p:spPr>
+          <a:xfrm>
+            <a:off x="7360920" y="4617720"/>
+            <a:ext cx="4005072" cy="1554480"/>
+          </a:xfrm>
+          <a:prstGeom prst="roundRect">
+            <a:avLst>
+              <a:gd name="adj" fmla="val 2941"/>
+            </a:avLst>
+          </a:prstGeom>
+          <a:solidFill>
+            <a:srgbClr val="F3F7FA"/>
+          </a:solidFill>
+          <a:ln/>
+        </p:spPr>
+        <p:txBody>
+          <a:bodyPr/>
+          <a:p/>
+        </p:txBody>
+      </p:sp>
+      <p:sp>
+        <p:nvSpPr>
+          <p:cNvPr id="21" name="Text 17"/>
+          <p:cNvSpPr/>
+          <p:nvPr/>
+        </p:nvSpPr>
+        <p:spPr>
+          <a:xfrm>
+            <a:off x="7589520" y="4828032"/>
+            <a:ext cx="1188720" cy="502920"/>
+          </a:xfrm>
+          <a:prstGeom prst="rect">
+            <a:avLst/>
+          </a:prstGeom>
+          <a:noFill/>
+          <a:ln/>
+        </p:spPr>
+        <p:txBody>
+          <a:bodyPr wrap="square" lIns="0" tIns="0" rIns="0" bIns="0" rtlCol="0" anchor="ctr"/>
+          <a:lstStyle/>
+          <a:p>
+            <a:pPr indent="0" marL="0">
+              <a:buNone/>
+            </a:pPr>
+            <a:r>
+              <a:rPr lang="en-US" sz="3000" b="1" dirty="0">
+                <a:solidFill>
+                  <a:srgbClr val="007BCB"/>
+                </a:solidFill>
+                <a:latin typeface="Garamond" pitchFamily="34" charset="0"/>
+                <a:ea typeface="Garamond" pitchFamily="34" charset="-122"/>
+                <a:cs typeface="Garamond" pitchFamily="34" charset="-120"/>
+              </a:rPr>
+              <a:t>10+</a:t>
+            </a:r>
+            <a:endParaRPr lang="en-US" sz="3000" dirty="0"/>
+          </a:p>
+        </p:txBody>
+      </p:sp>
+      <p:sp>
+        <p:nvSpPr>
+          <p:cNvPr id="22" name="Text 18"/>
+          <p:cNvSpPr/>
+          <p:nvPr/>
+        </p:nvSpPr>
+        <p:spPr>
+          <a:xfrm>
+            <a:off x="8732520" y="4864608"/>
+            <a:ext cx="2514600" cy="1097280"/>
+          </a:xfrm>
+          <a:prstGeom prst="rect">
+            <a:avLst/>
+          </a:prstGeom>
+          <a:noFill/>
+          <a:ln/>
+        </p:spPr>
+        <p:txBody>
+          <a:bodyPr wrap="square" lIns="0" tIns="0" rIns="0" bIns="0" rtlCol="0" anchor="t"/>
+          <a:lstStyle/>
+          <a:p>
+            <a:pPr indent="0" marL="0">
+              <a:buNone/>
+            </a:pPr>
+            <a:r>
+              <a:rPr lang="en-US" sz="1150" dirty="0">
+                <a:solidFill>
+                  <a:srgbClr val="1E2A33"/>
+                </a:solidFill>
+                <a:latin typeface="Garamond" pitchFamily="34" charset="0"/>
+                <a:ea typeface="Garamond" pitchFamily="34" charset="-122"/>
+                <a:cs typeface="Garamond" pitchFamily="34" charset="-120"/>
+              </a:rPr>
+              <a:t>missions supported across NASA, ESA, and commercial programs</a:t>
+            </a:r>
+            <a:endParaRPr lang="en-US" sz="1150" dirty="0"/>
+          </a:p>
+        </p:txBody>
+      </p:sp>
       <p:pic>
         <p:nvPicPr>
-          <p:cNvPr id="17" name="Image 1" descr="assets/s11_team.jpg">    </p:cNvPr>
+          <p:cNvPr id="23" name="Picture 22" descr="nasa.png"/>
           <p:cNvPicPr>
             <a:picLocks noChangeAspect="1"/>
           </p:cNvPicPr>
           <p:nvPr/>
         </p:nvPicPr>
         <p:blipFill>
-          <a:blip r:embed="rId2"/>
+          <a:blip r:embed="rId5"/>
           <a:stretch>
             <a:fillRect/>
           </a:stretch>
         </p:blipFill>
         <p:spPr>
           <a:xfrm>
-            <a:off x="7360920" y="1463040"/>
-            <a:ext cx="4005072" cy="2670048"/>
+            <a:off x="7689546" y="1618488"/>
+            <a:ext cx="677771" cy="566928"/>
           </a:xfrm>
           <a:prstGeom prst="rect">
             <a:avLst/>
           </a:prstGeom>
         </p:spPr>
       </p:pic>
-      <p:sp>
-        <p:nvSpPr>
-          <p:cNvPr id="18" name="Shape 14"/>
-          <p:cNvSpPr/>
-          <p:nvPr/>
-        </p:nvSpPr>
-        <p:spPr>
-          <a:xfrm>
-            <a:off x="7360920" y="1463040"/>
-            <a:ext cx="4005072" cy="2670048"/>
-          </a:xfrm>
-          <a:prstGeom prst="rect">
-            <a:avLst/>
-          </a:prstGeom>
-          <a:ln w="12700">
-            <a:solidFill>
-              <a:srgbClr val="C6D2DA"/>
-            </a:solidFill>
-            <a:prstDash val="solid"/>
-          </a:ln>
-        </p:spPr>
-        <p:txBody>
-          <a:bodyPr/>
-          <a:p/>
-        </p:txBody>
-      </p:sp>
-      <p:sp>
-        <p:nvSpPr>
-          <p:cNvPr id="19" name="Text 15"/>
-          <p:cNvSpPr/>
-          <p:nvPr/>
-        </p:nvSpPr>
-        <p:spPr>
-          <a:xfrm>
-            <a:off x="7360920" y="4160520"/>
-            <a:ext cx="4005072" cy="274320"/>
-          </a:xfrm>
-          <a:prstGeom prst="rect">
-            <a:avLst/>
-          </a:prstGeom>
-          <a:noFill/>
-          <a:ln/>
-        </p:spPr>
-        <p:txBody>
-          <a:bodyPr wrap="square" lIns="0" tIns="0" rIns="0" bIns="0" rtlCol="0" anchor="ctr"/>
-          <a:lstStyle/>
-          <a:p>
-            <a:pPr indent="0" marL="0">
-              <a:buNone/>
-            </a:pPr>
-            <a:r>
-              <a:rPr lang="en-US" sz="950" i="1" dirty="0">
-                <a:solidFill>
-                  <a:srgbClr val="5C6B76"/>
-                </a:solidFill>
-                <a:latin typeface="Garamond" pitchFamily="34" charset="0"/>
-                <a:ea typeface="Garamond" pitchFamily="34" charset="-122"/>
-                <a:cs typeface="Garamond" pitchFamily="34" charset="-120"/>
-              </a:rPr>
-              <a:t>Flight hardware assembly at the Berkeley facility.</a:t>
-            </a:r>
-            <a:endParaRPr lang="en-US" sz="950" dirty="0"/>
-          </a:p>
-        </p:txBody>
-      </p:sp>
-      <p:sp>
-        <p:nvSpPr>
-          <p:cNvPr id="20" name="Shape 16"/>
-          <p:cNvSpPr/>
-          <p:nvPr/>
-        </p:nvSpPr>
-        <p:spPr>
-          <a:xfrm>
-            <a:off x="7360920" y="4617720"/>
-            <a:ext cx="4005072" cy="1554480"/>
-          </a:xfrm>
-          <a:prstGeom prst="roundRect">
-            <a:avLst>
-              <a:gd name="adj" fmla="val 2941"/>
-            </a:avLst>
-          </a:prstGeom>
-          <a:solidFill>
-            <a:srgbClr val="F3F7FA"/>
-          </a:solidFill>
-          <a:ln/>
-        </p:spPr>
-        <p:txBody>
-          <a:bodyPr/>
-          <a:p/>
-        </p:txBody>
-      </p:sp>
-      <p:sp>
-        <p:nvSpPr>
-          <p:cNvPr id="21" name="Text 17"/>
-          <p:cNvSpPr/>
-          <p:nvPr/>
-        </p:nvSpPr>
-        <p:spPr>
-          <a:xfrm>
-            <a:off x="7589520" y="4828032"/>
-            <a:ext cx="1188720" cy="502920"/>
-          </a:xfrm>
-          <a:prstGeom prst="rect">
-            <a:avLst/>
-          </a:prstGeom>
-          <a:noFill/>
-          <a:ln/>
-        </p:spPr>
-        <p:txBody>
-          <a:bodyPr wrap="square" lIns="0" tIns="0" rIns="0" bIns="0" rtlCol="0" anchor="ctr"/>
-          <a:lstStyle/>
-          <a:p>
-            <a:pPr indent="0" marL="0">
-              <a:buNone/>
-            </a:pPr>
-            <a:r>
-              <a:rPr lang="en-US" sz="3000" b="1" dirty="0">
-                <a:solidFill>
-                  <a:srgbClr val="007BCB"/>
-                </a:solidFill>
-                <a:latin typeface="Garamond" pitchFamily="34" charset="0"/>
-                <a:ea typeface="Garamond" pitchFamily="34" charset="-122"/>
-                <a:cs typeface="Garamond" pitchFamily="34" charset="-120"/>
-              </a:rPr>
-              <a:t>10+</a:t>
-            </a:r>
-            <a:endParaRPr lang="en-US" sz="3000" dirty="0"/>
-          </a:p>
-        </p:txBody>
-      </p:sp>
-      <p:sp>
-        <p:nvSpPr>
-          <p:cNvPr id="22" name="Text 18"/>
-          <p:cNvSpPr/>
-          <p:nvPr/>
-        </p:nvSpPr>
-        <p:spPr>
-          <a:xfrm>
-            <a:off x="8732520" y="4864608"/>
-            <a:ext cx="2514600" cy="1097280"/>
-          </a:xfrm>
-          <a:prstGeom prst="rect">
-            <a:avLst/>
-          </a:prstGeom>
-          <a:noFill/>
-          <a:ln/>
-        </p:spPr>
-        <p:txBody>
-          <a:bodyPr wrap="square" lIns="0" tIns="0" rIns="0" bIns="0" rtlCol="0" anchor="t"/>
-          <a:lstStyle/>
-          <a:p>
-            <a:pPr indent="0" marL="0">
-              <a:buNone/>
-            </a:pPr>
-            <a:r>
-              <a:rPr lang="en-US" sz="1150" dirty="0">
-                <a:solidFill>
-                  <a:srgbClr val="1E2A33"/>
-                </a:solidFill>
-                <a:latin typeface="Garamond" pitchFamily="34" charset="0"/>
-                <a:ea typeface="Garamond" pitchFamily="34" charset="-122"/>
-                <a:cs typeface="Garamond" pitchFamily="34" charset="-120"/>
-              </a:rPr>
-              <a:t>missions supported across NASA, ESA, and commercial programs</a:t>
-            </a:r>
-            <a:endParaRPr lang="en-US" sz="1150" dirty="0"/>
-          </a:p>
-        </p:txBody>
-      </p:sp>
+      <p:pic>
+        <p:nvPicPr>
+          <p:cNvPr id="24" name="Picture 23" descr="jpl.png"/>
+          <p:cNvPicPr>
+            <a:picLocks noChangeAspect="1"/>
+          </p:cNvPicPr>
+          <p:nvPr/>
+        </p:nvPicPr>
+        <p:blipFill>
+          <a:blip r:embed="rId6"/>
+          <a:stretch>
+            <a:fillRect/>
+          </a:stretch>
+        </p:blipFill>
+        <p:spPr>
+          <a:xfrm>
+            <a:off x="8796528" y="1646834"/>
+            <a:ext cx="1133856" cy="510235"/>
+          </a:xfrm>
+          <a:prstGeom prst="rect">
+            <a:avLst/>
+          </a:prstGeom>
+        </p:spPr>
+      </p:pic>
+      <p:pic>
+        <p:nvPicPr>
+          <p:cNvPr id="25" name="Picture 24" descr="cnes.png"/>
+          <p:cNvPicPr>
+            <a:picLocks noChangeAspect="1"/>
+          </p:cNvPicPr>
+          <p:nvPr/>
+        </p:nvPicPr>
+        <p:blipFill>
+          <a:blip r:embed="rId7"/>
+          <a:stretch>
+            <a:fillRect/>
+          </a:stretch>
+        </p:blipFill>
+        <p:spPr>
+          <a:xfrm>
+            <a:off x="10362388" y="1618488"/>
+            <a:ext cx="672183" cy="566928"/>
+          </a:xfrm>
+          <a:prstGeom prst="rect">
+            <a:avLst/>
+          </a:prstGeom>
+        </p:spPr>
+      </p:pic>
+      <p:pic>
+        <p:nvPicPr>
+          <p:cNvPr id="26" name="Picture 25" descr="swri.png"/>
+          <p:cNvPicPr>
+            <a:picLocks noChangeAspect="1"/>
+          </p:cNvPicPr>
+          <p:nvPr/>
+        </p:nvPicPr>
+        <p:blipFill>
+          <a:blip r:embed="rId8"/>
+          <a:stretch>
+            <a:fillRect/>
+          </a:stretch>
+        </p:blipFill>
+        <p:spPr>
+          <a:xfrm>
+            <a:off x="7528201" y="2496312"/>
+            <a:ext cx="1000461" cy="566928"/>
+          </a:xfrm>
+          <a:prstGeom prst="rect">
+            <a:avLst/>
+          </a:prstGeom>
+        </p:spPr>
+      </p:pic>
+      <p:pic>
+        <p:nvPicPr>
+          <p:cNvPr id="27" name="Picture 26" descr="blueorigin.png"/>
+          <p:cNvPicPr>
+            <a:picLocks noChangeAspect="1"/>
+          </p:cNvPicPr>
+          <p:nvPr/>
+        </p:nvPicPr>
+        <p:blipFill>
+          <a:blip r:embed="rId9"/>
+          <a:stretch>
+            <a:fillRect/>
+          </a:stretch>
+        </p:blipFill>
+        <p:spPr>
+          <a:xfrm>
+            <a:off x="8796528" y="2673477"/>
+            <a:ext cx="1133856" cy="212597"/>
+          </a:xfrm>
+          <a:prstGeom prst="rect">
+            <a:avLst/>
+          </a:prstGeom>
+        </p:spPr>
+      </p:pic>
+      <p:pic>
+        <p:nvPicPr>
+          <p:cNvPr id="28" name="Picture 27" descr="intuitive.png"/>
+          <p:cNvPicPr>
+            <a:picLocks noChangeAspect="1"/>
+          </p:cNvPicPr>
+          <p:nvPr/>
+        </p:nvPicPr>
+        <p:blipFill>
+          <a:blip r:embed="rId10"/>
+          <a:stretch>
+            <a:fillRect/>
+          </a:stretch>
+        </p:blipFill>
+        <p:spPr>
+          <a:xfrm>
+            <a:off x="10131552" y="2571902"/>
+            <a:ext cx="1133856" cy="415747"/>
+          </a:xfrm>
+          <a:prstGeom prst="rect">
+            <a:avLst/>
+          </a:prstGeom>
+        </p:spPr>
+      </p:pic>
+      <p:pic>
+        <p:nvPicPr>
+          <p:cNvPr id="29" name="Picture 28" descr="berkeley.png"/>
+          <p:cNvPicPr>
+            <a:picLocks noChangeAspect="1"/>
+          </p:cNvPicPr>
+          <p:nvPr/>
+        </p:nvPicPr>
+        <p:blipFill>
+          <a:blip r:embed="rId11"/>
+          <a:stretch>
+            <a:fillRect/>
+          </a:stretch>
+        </p:blipFill>
+        <p:spPr>
+          <a:xfrm>
+            <a:off x="7461504" y="3479254"/>
+            <a:ext cx="1133856" cy="356692"/>
+          </a:xfrm>
+          <a:prstGeom prst="rect">
+            <a:avLst/>
+          </a:prstGeom>
+        </p:spPr>
+      </p:pic>
+      <p:pic>
+        <p:nvPicPr>
+          <p:cNvPr id="30" name="Picture 29" descr="columbia.png"/>
+          <p:cNvPicPr>
+            <a:picLocks noChangeAspect="1"/>
+          </p:cNvPicPr>
+          <p:nvPr/>
+        </p:nvPicPr>
+        <p:blipFill>
+          <a:blip r:embed="rId12"/>
+          <a:stretch>
+            <a:fillRect/>
+          </a:stretch>
+        </p:blipFill>
+        <p:spPr>
+          <a:xfrm>
+            <a:off x="9146103" y="3374136"/>
+            <a:ext cx="434705" cy="566928"/>
+          </a:xfrm>
+          <a:prstGeom prst="rect">
+            <a:avLst/>
+          </a:prstGeom>
+        </p:spPr>
+      </p:pic>
+      <p:pic>
+        <p:nvPicPr>
+          <p:cNvPr id="31" name="Picture 30" descr="breakthrough.png"/>
+          <p:cNvPicPr>
+            <a:picLocks noChangeAspect="1"/>
+          </p:cNvPicPr>
+          <p:nvPr/>
+        </p:nvPicPr>
+        <p:blipFill>
+          <a:blip r:embed="rId13"/>
+          <a:stretch>
+            <a:fillRect/>
+          </a:stretch>
+        </p:blipFill>
+        <p:spPr>
+          <a:xfrm>
+            <a:off x="10131552" y="3518821"/>
+            <a:ext cx="1133856" cy="277558"/>
+          </a:xfrm>
+          <a:prstGeom prst="rect">
+            <a:avLst/>
+          </a:prstGeom>
+        </p:spPr>
+      </p:pic>
     </p:spTree>
   </p:cSld>
   <p:clrMapOvr>
@@ -6944,7 +7110,7 @@
 </p:sld>
 </file>
 
-<file path=ppt/slides/slide17.xml><?xml version="1.0" encoding="utf-8"?>
+<file path=ppt/slides/slide15.xml><?xml version="1.0" encoding="utf-8"?>
 <p:sld xmlns:a="http://schemas.openxmlformats.org/drawingml/2006/main" xmlns:r="http://schemas.openxmlformats.org/officeDocument/2006/relationships" xmlns:p="http://schemas.openxmlformats.org/presentationml/2006/main">
   <p:cSld name="Slide 16">
     <p:spTree>

</xml_diff>

<commit_message>
Restore Berkeley assembly photo on client base slide
Co-authored-by: anthonyleedu <anthonyleedu@users.noreply.github.com>
</commit_message>
<xml_diff>
--- a/Heliospace_Investor_Overview.pptx
+++ b/Heliospace_Investor_Overview.pptx
@@ -5906,8 +5906,8 @@
         </p:nvSpPr>
         <p:spPr>
           <a:xfrm>
-            <a:off x="7360920" y="4617720"/>
-            <a:ext cx="4005072" cy="1554480"/>
+            <a:off x="9646920" y="4617720"/>
+            <a:ext cx="1719072" cy="1554480"/>
           </a:xfrm>
           <a:prstGeom prst="roundRect">
             <a:avLst>
@@ -5932,8 +5932,8 @@
         </p:nvSpPr>
         <p:spPr>
           <a:xfrm>
-            <a:off x="7589520" y="4828032"/>
-            <a:ext cx="1188720" cy="502920"/>
+            <a:off x="9802368" y="4736592"/>
+            <a:ext cx="1417320" cy="457200"/>
           </a:xfrm>
           <a:prstGeom prst="rect">
             <a:avLst/>
@@ -5971,8 +5971,8 @@
         </p:nvSpPr>
         <p:spPr>
           <a:xfrm>
-            <a:off x="8732520" y="4864608"/>
-            <a:ext cx="2514600" cy="1097280"/>
+            <a:off x="9802368" y="5212080"/>
+            <a:ext cx="1444752" cy="914400"/>
           </a:xfrm>
           <a:prstGeom prst="rect">
             <a:avLst/>
@@ -6218,6 +6218,69 @@
           </a:prstGeom>
         </p:spPr>
       </p:pic>
+      <p:pic>
+        <p:nvPicPr>
+          <p:cNvPr id="32" name="Picture 31" descr="image.jpg"/>
+          <p:cNvPicPr>
+            <a:picLocks noChangeAspect="1"/>
+          </p:cNvPicPr>
+          <p:nvPr/>
+        </p:nvPicPr>
+        <p:blipFill>
+          <a:blip r:embed="rId2"/>
+          <a:stretch>
+            <a:fillRect/>
+          </a:stretch>
+        </p:blipFill>
+        <p:spPr>
+          <a:xfrm>
+            <a:off x="7360920" y="4663440"/>
+            <a:ext cx="2148840" cy="1432560"/>
+          </a:xfrm>
+          <a:prstGeom prst="rect">
+            <a:avLst/>
+          </a:prstGeom>
+        </p:spPr>
+      </p:pic>
+      <p:sp>
+        <p:nvSpPr>
+          <p:cNvPr id="33" name="Text 15"/>
+          <p:cNvSpPr/>
+          <p:nvPr/>
+        </p:nvSpPr>
+        <p:spPr>
+          <a:xfrm>
+            <a:off x="7360920" y="6236208"/>
+            <a:ext cx="4005072" cy="201168"/>
+          </a:xfrm>
+          <a:prstGeom prst="rect">
+            <a:avLst/>
+          </a:prstGeom>
+          <a:noFill/>
+          <a:ln/>
+        </p:spPr>
+        <p:txBody>
+          <a:bodyPr wrap="square" lIns="0" tIns="0" rIns="0" bIns="0" rtlCol="0" anchor="ctr"/>
+          <a:lstStyle/>
+          <a:p>
+            <a:pPr indent="0" marL="0">
+              <a:buNone/>
+            </a:pPr>
+            <a:r>
+              <a:rPr lang="en-US" sz="950" i="1" dirty="0">
+                <a:solidFill>
+                  <a:srgbClr val="5C6B76"/>
+                </a:solidFill>
+                <a:latin typeface="Garamond" pitchFamily="34" charset="0"/>
+                <a:ea typeface="Garamond" pitchFamily="34" charset="-122"/>
+                <a:cs typeface="Garamond" pitchFamily="34" charset="-120"/>
+              </a:rPr>
+              <a:t>Flight hardware assembly at the Berkeley facility.</a:t>
+            </a:r>
+            <a:endParaRPr lang="en-US" sz="950" dirty="0"/>
+          </a:p>
+        </p:txBody>
+      </p:sp>
     </p:spTree>
   </p:cSld>
   <p:clrMapOvr>

</xml_diff>

<commit_message>
Enlarge Rocky's contact information on closing slide
Co-authored-by: anthonyleedu <anthonyleedu@users.noreply.github.com>
</commit_message>
<xml_diff>
--- a/Heliospace_Investor_Overview.pptx
+++ b/Heliospace_Investor_Overview.pptx
@@ -7325,7 +7325,7 @@
         <p:spPr>
           <a:xfrm>
             <a:off x="822960" y="3657600"/>
-            <a:ext cx="5577840" cy="1463040"/>
+            <a:ext cx="5577840" cy="1783080"/>
           </a:xfrm>
           <a:prstGeom prst="roundRect">
             <a:avLst>
@@ -7357,8 +7357,8 @@
         </p:nvSpPr>
         <p:spPr>
           <a:xfrm>
-            <a:off x="1097280" y="3886200"/>
-            <a:ext cx="5120640" cy="1005840"/>
+            <a:off x="1097280" y="3931920"/>
+            <a:ext cx="5120640" cy="1371600"/>
           </a:xfrm>
           <a:prstGeom prst="rect">
             <a:avLst/>
@@ -7377,7 +7377,7 @@
               <a:buNone/>
             </a:pPr>
             <a:r>
-              <a:rPr lang="en-US" sz="1700" b="1" dirty="0">
+              <a:rPr lang="en-US" sz="2200" b="1" dirty="0">
                 <a:solidFill>
                   <a:srgbClr val="FFFFFF"/>
                 </a:solidFill>
@@ -7397,7 +7397,7 @@
               <a:buNone/>
             </a:pPr>
             <a:r>
-              <a:rPr lang="en-US" sz="1150" dirty="0">
+              <a:rPr lang="en-US" sz="1500" dirty="0">
                 <a:solidFill>
                   <a:srgbClr val="AFC7D8"/>
                 </a:solidFill>
@@ -7417,7 +7417,7 @@
               <a:buNone/>
             </a:pPr>
             <a:r>
-              <a:rPr lang="en-US" sz="1150" dirty="0">
+              <a:rPr lang="en-US" sz="1500" dirty="0">
                 <a:solidFill>
                   <a:srgbClr val="AFC7D8"/>
                 </a:solidFill>

</xml_diff>